<commit_message>
Result 3: all four methods, inheritance richness, per-database shading, metric references
Direct Mapping and LLM baseline shown before the table as 'no labels, provenance or class
hierarchy, in any run'. Hierarchy reported as inheritance richness (subclass axioms per class,
from Table 8) with OntoQA and OntoMetrics references; shading compares cells within each
database. Strip makes the robust claim; the subclass-count domain point moves to the notes.

Co-Authored-By: Claude Opus 5.5 <noreply@anthropic.com>
Claude-Session: https://claude.ai/code/session_01KcycczqUBG98FnzsgJYAW8
</commit_message>
<xml_diff>
--- a/presentation/RIGOR_results.pptx
+++ b/presentation/RIGOR_results.pptx
@@ -2049,7 +2049,7 @@
                 <a:cs typeface="IBM Plex Sans"/>
                 <a:sym typeface="IBM Plex Sans"/>
               </a:rPr>
-              <a:t>[10:33–11:20]  SPOKEN SCRIPT (81 words)</a:t>
+              <a:t>[10:21–11:07]  SPOKEN SCRIPT (81 words)</a:t>
             </a:r>
           </a:p>
           <a:p>
@@ -2309,7 +2309,7 @@
                 <a:cs typeface="Calibri"/>
                 <a:sym typeface="Calibri"/>
               </a:rPr>
-              <a:t>[11:20–12:11]  SPOKEN SCRIPT (82 words)</a:t>
+              <a:t>[11:07–11:58]  SPOKEN SCRIPT (82 words)</a:t>
             </a:r>
           </a:p>
           <a:p>
@@ -2785,7 +2785,7 @@
                 <a:cs typeface="Calibri"/>
                 <a:sym typeface="Calibri"/>
               </a:rPr>
-              <a:t>[9:57–10:33]  SPOKEN SCRIPT (61 words)</a:t>
+              <a:t>[9:57–10:21]  SPOKEN SCRIPT (39 words)</a:t>
             </a:r>
           </a:p>
           <a:p>
@@ -2799,7 +2799,7 @@
                 <a:cs typeface="Calibri"/>
                 <a:sym typeface="Calibri"/>
               </a:rPr>
-              <a:t>Nothing is lost. Is meaning added? Direct mapping and the LLM baseline add none, in any run. Non-Iterative adds labels, but no provenance and no hierarchy. Only RIGOR adds all three, with every LLM, in every database. [pause] And the hierarchies follow what the LLM knows: over a hundred subclass axioms for the music store, only a few for the clinical schemas.</a:t>
+              <a:t>Nothing is lost. Is meaning added? Direct mapping and the LLM baseline add none, in any run. Non-Iterative RAG adds labels, but no provenance and no class hierarchy. Only RIGOR adds all three, with every LLM, in every database. [pause]</a:t>
             </a:r>
           </a:p>
           <a:p/>
@@ -2814,7 +2814,7 @@
                 <a:cs typeface="Calibri"/>
                 <a:sym typeface="Calibri"/>
               </a:rPr>
-              <a:t>PRESENTER / POINTER: Labels row pair, then provenance, then hierarchy; land on the Chinook hierarchy cells.</a:t>
+              <a:t>PRESENTER / POINTER: Point at the red block first, then the three RIGOR rows.</a:t>
             </a:r>
           </a:p>
           <a:p>
@@ -2828,7 +2828,7 @@
                 <a:cs typeface="Calibri"/>
                 <a:sym typeface="Calibri"/>
               </a:rPr>
-              <a:t>AUDIENCE TAKEAWAY: Only RIGOR adds labels, provenance and hierarchy, with every LLM.</a:t>
+              <a:t>AUDIENCE TAKEAWAY: Only RIGOR adds labels, provenance and a class hierarchy, with every LLM.</a:t>
             </a:r>
           </a:p>
           <a:p>
@@ -2842,7 +2842,7 @@
                 <a:cs typeface="Calibri"/>
                 <a:sym typeface="Calibri"/>
               </a:rPr>
-              <a:t>SOURCE AND SCOPE: Paper Table 8 (annotation assertions, prov:wasDerivedFrom, SubClassOf per run).</a:t>
+              <a:t>SOURCE AND SCOPE: Paper Table 8. Hierarchy as inheritance richness (subclass axioms per class; OntoQA, Tartir et al. 2005; OntoMetrics, Lantow 2016), computed from Table 8 counts. Shading is within each database.</a:t>
             </a:r>
           </a:p>
           <a:p>
@@ -2856,7 +2856,37 @@
                 <a:cs typeface="Calibri"/>
                 <a:sym typeface="Calibri"/>
               </a:rPr>
-              <a:t>IF RUNNING LATE, DROP: "Non-Iterative adds labels, but no provenance and no hierarchy."</a:t>
+              <a:t>IF RUNNING LATE, DROP: "Non-Iterative RAG adds labels, but no provenance and no class hierarchy."</a:t>
+            </a:r>
+          </a:p>
+          <a:p/>
+          <a:p>
+            <a:r>
+              <a:rPr lang="en-US" sz="1200">
+                <a:solidFill>
+                  <a:schemeClr val="dk1"/>
+                </a:solidFill>
+                <a:latin typeface="Calibri"/>
+                <a:ea typeface="Calibri"/>
+                <a:cs typeface="Calibri"/>
+                <a:sym typeface="Calibri"/>
+              </a:rPr>
+              <a:t>IF ASKED 'DOES CHINOOK NEED SO MANY SUBCLASSES?': Count is not quality, so we report whether a hierarchy exists, and only RIGOR builds one. RIGOR's Chinook ontologies have zero OOPS! pitfalls and the judge ranks RIGOR first on all 11 Chinook tables; it does score RIGOR's conciseness lower there (2.59 vs 3.32 for the baseline, Table 10), so tighter hierarchies are future work.</a:t>
+            </a:r>
+          </a:p>
+          <a:p/>
+          <a:p>
+            <a:r>
+              <a:rPr lang="en-US" sz="1200">
+                <a:solidFill>
+                  <a:schemeClr val="dk1"/>
+                </a:solidFill>
+                <a:latin typeface="Calibri"/>
+                <a:ea typeface="Calibri"/>
+                <a:cs typeface="Calibri"/>
+                <a:sym typeface="Calibri"/>
+              </a:rPr>
+              <a:t>DOMAIN PATTERN (notes only): inheritance richness is 0.10-0.70 on the clinical schemas and 2.1-4.1 on the music store; the LLM proposes more specializations in a familiar domain.</a:t>
             </a:r>
           </a:p>
         </p:txBody>
@@ -15278,7 +15308,7 @@
                 <a:latin typeface="Calibri"/>
                 <a:cs typeface="Calibri"/>
               </a:rPr>
-              <a:t xml:space="preserve">Elements per ontology, for every LLM and database. Direct Mapping and LLM baseline add none, in any run.</a:t>
+              <a:t xml:space="preserve">Per ontology, for every LLM and database.</a:t>
             </a:r>
           </a:p>
         </p:txBody>
@@ -15568,14 +15598,14 @@
       </p:sp>
       <p:sp>
         <p:nvSpPr>
-          <p:cNvPr id="1154" name="Metric"/>
+          <p:cNvPr id="1154" name="Database"/>
           <p:cNvSpPr txBox="1"/>
           <p:nvPr/>
         </p:nvSpPr>
         <p:spPr>
           <a:xfrm>
-            <a:off x="1078992" y="3474720"/>
-            <a:ext cx="1417320" cy="658368"/>
+            <a:off x="3794760" y="2990088"/>
+            <a:ext cx="2249424" cy="219456"/>
           </a:xfrm>
           <a:prstGeom prst="rect">
             <a:avLst/>
@@ -15591,30 +15621,30 @@
           </a:bodyPr>
           <a:lstStyle/>
           <a:p>
-            <a:pPr algn="l"/>
-            <a:r>
-              <a:rPr lang="en-US" sz="1150" b="1" i="0" dirty="0">
-                <a:solidFill>
-                  <a:srgbClr val="2F6B78"/>
-                </a:solidFill>
-                <a:latin typeface="Calibri"/>
-                <a:cs typeface="Calibri"/>
-              </a:rPr>
-              <a:t xml:space="preserve">Labels &amp; comments</a:t>
-            </a:r>
-          </a:p>
-        </p:txBody>
-      </p:sp>
-      <p:sp>
-        <p:nvSpPr>
-          <p:cNvPr id="1155" name="Database"/>
+            <a:pPr algn="ctr"/>
+            <a:r>
+              <a:rPr lang="en-US" sz="1100" b="1" i="0" dirty="0">
+                <a:solidFill>
+                  <a:srgbClr val="1F2328"/>
+                </a:solidFill>
+                <a:latin typeface="Calibri"/>
+                <a:cs typeface="Calibri"/>
+              </a:rPr>
+              <a:t xml:space="preserve">Liver Cancer</a:t>
+            </a:r>
+          </a:p>
+        </p:txBody>
+      </p:sp>
+      <p:sp>
+        <p:nvSpPr>
+          <p:cNvPr id="1155" name="LLM"/>
           <p:cNvSpPr txBox="1"/>
           <p:nvPr/>
         </p:nvSpPr>
         <p:spPr>
           <a:xfrm>
-            <a:off x="3794760" y="3017520"/>
-            <a:ext cx="2249424" cy="219456"/>
+            <a:off x="3794760" y="3218688"/>
+            <a:ext cx="749808" cy="182880"/>
           </a:xfrm>
           <a:prstGeom prst="rect">
             <a:avLst/>
@@ -15632,14 +15662,14 @@
           <a:p>
             <a:pPr algn="ctr"/>
             <a:r>
-              <a:rPr lang="en-US" sz="1100" b="1" i="0" dirty="0">
-                <a:solidFill>
-                  <a:srgbClr val="1F2328"/>
-                </a:solidFill>
-                <a:latin typeface="Calibri"/>
-                <a:cs typeface="Calibri"/>
-              </a:rPr>
-              <a:t xml:space="preserve">Liver Cancer</a:t>
+              <a:rPr lang="en-US" sz="850" b="0" i="0" dirty="0">
+                <a:solidFill>
+                  <a:srgbClr val="5B6770"/>
+                </a:solidFill>
+                <a:latin typeface="Calibri"/>
+                <a:cs typeface="Calibri"/>
+              </a:rPr>
+              <a:t xml:space="preserve">Claude</a:t>
             </a:r>
           </a:p>
         </p:txBody>
@@ -15652,7 +15682,7 @@
         </p:nvSpPr>
         <p:spPr>
           <a:xfrm>
-            <a:off x="3794760" y="3246120"/>
+            <a:off x="4544568" y="3218688"/>
             <a:ext cx="749808" cy="182880"/>
           </a:xfrm>
           <a:prstGeom prst="rect">
@@ -15678,7 +15708,7 @@
                 <a:latin typeface="Calibri"/>
                 <a:cs typeface="Calibri"/>
               </a:rPr>
-              <a:t xml:space="preserve">Claude</a:t>
+              <a:t xml:space="preserve">Mistral</a:t>
             </a:r>
           </a:p>
         </p:txBody>
@@ -15691,7 +15721,7 @@
         </p:nvSpPr>
         <p:spPr>
           <a:xfrm>
-            <a:off x="4544568" y="3246120"/>
+            <a:off x="5294376" y="3218688"/>
             <a:ext cx="749808" cy="182880"/>
           </a:xfrm>
           <a:prstGeom prst="rect">
@@ -15717,20 +15747,59 @@
                 <a:latin typeface="Calibri"/>
                 <a:cs typeface="Calibri"/>
               </a:rPr>
-              <a:t xml:space="preserve">Mistral</a:t>
-            </a:r>
-          </a:p>
-        </p:txBody>
-      </p:sp>
-      <p:sp>
-        <p:nvSpPr>
-          <p:cNvPr id="1158" name="LLM"/>
+              <a:t xml:space="preserve">DeepSeek</a:t>
+            </a:r>
+          </a:p>
+        </p:txBody>
+      </p:sp>
+      <p:sp>
+        <p:nvSpPr>
+          <p:cNvPr id="1158" name="Database"/>
           <p:cNvSpPr txBox="1"/>
           <p:nvPr/>
         </p:nvSpPr>
         <p:spPr>
           <a:xfrm>
-            <a:off x="5294376" y="3246120"/>
+            <a:off x="6044184" y="2990088"/>
+            <a:ext cx="2249424" cy="219456"/>
+          </a:xfrm>
+          <a:prstGeom prst="rect">
+            <a:avLst/>
+          </a:prstGeom>
+          <a:noFill/>
+          <a:ln>
+            <a:noFill/>
+          </a:ln>
+        </p:spPr>
+        <p:txBody>
+          <a:bodyPr wrap="square" lIns="0" tIns="0" rIns="0" bIns="0" anchor="ctr">
+            <a:noAutofit/>
+          </a:bodyPr>
+          <a:lstStyle/>
+          <a:p>
+            <a:pPr algn="ctr"/>
+            <a:r>
+              <a:rPr lang="en-US" sz="1100" b="1" i="0" dirty="0">
+                <a:solidFill>
+                  <a:srgbClr val="1F2328"/>
+                </a:solidFill>
+                <a:latin typeface="Calibri"/>
+                <a:cs typeface="Calibri"/>
+              </a:rPr>
+              <a:t xml:space="preserve">eICU-CRD</a:t>
+            </a:r>
+          </a:p>
+        </p:txBody>
+      </p:sp>
+      <p:sp>
+        <p:nvSpPr>
+          <p:cNvPr id="1159" name="LLM"/>
+          <p:cNvSpPr txBox="1"/>
+          <p:nvPr/>
+        </p:nvSpPr>
+        <p:spPr>
+          <a:xfrm>
+            <a:off x="6044184" y="3218688"/>
             <a:ext cx="749808" cy="182880"/>
           </a:xfrm>
           <a:prstGeom prst="rect">
@@ -15756,46 +15825,7 @@
                 <a:latin typeface="Calibri"/>
                 <a:cs typeface="Calibri"/>
               </a:rPr>
-              <a:t xml:space="preserve">DeepSeek</a:t>
-            </a:r>
-          </a:p>
-        </p:txBody>
-      </p:sp>
-      <p:sp>
-        <p:nvSpPr>
-          <p:cNvPr id="1159" name="Database"/>
-          <p:cNvSpPr txBox="1"/>
-          <p:nvPr/>
-        </p:nvSpPr>
-        <p:spPr>
-          <a:xfrm>
-            <a:off x="6044184" y="3017520"/>
-            <a:ext cx="2249424" cy="219456"/>
-          </a:xfrm>
-          <a:prstGeom prst="rect">
-            <a:avLst/>
-          </a:prstGeom>
-          <a:noFill/>
-          <a:ln>
-            <a:noFill/>
-          </a:ln>
-        </p:spPr>
-        <p:txBody>
-          <a:bodyPr wrap="square" lIns="0" tIns="0" rIns="0" bIns="0" anchor="ctr">
-            <a:noAutofit/>
-          </a:bodyPr>
-          <a:lstStyle/>
-          <a:p>
-            <a:pPr algn="ctr"/>
-            <a:r>
-              <a:rPr lang="en-US" sz="1100" b="1" i="0" dirty="0">
-                <a:solidFill>
-                  <a:srgbClr val="1F2328"/>
-                </a:solidFill>
-                <a:latin typeface="Calibri"/>
-                <a:cs typeface="Calibri"/>
-              </a:rPr>
-              <a:t xml:space="preserve">eICU-CRD</a:t>
+              <a:t xml:space="preserve">Claude</a:t>
             </a:r>
           </a:p>
         </p:txBody>
@@ -15808,7 +15838,7 @@
         </p:nvSpPr>
         <p:spPr>
           <a:xfrm>
-            <a:off x="6044184" y="3246120"/>
+            <a:off x="6793992" y="3218688"/>
             <a:ext cx="749808" cy="182880"/>
           </a:xfrm>
           <a:prstGeom prst="rect">
@@ -15834,7 +15864,7 @@
                 <a:latin typeface="Calibri"/>
                 <a:cs typeface="Calibri"/>
               </a:rPr>
-              <a:t xml:space="preserve">Claude</a:t>
+              <a:t xml:space="preserve">Mistral</a:t>
             </a:r>
           </a:p>
         </p:txBody>
@@ -15847,7 +15877,7 @@
         </p:nvSpPr>
         <p:spPr>
           <a:xfrm>
-            <a:off x="6793992" y="3246120"/>
+            <a:off x="7543800" y="3218688"/>
             <a:ext cx="749808" cy="182880"/>
           </a:xfrm>
           <a:prstGeom prst="rect">
@@ -15873,20 +15903,59 @@
                 <a:latin typeface="Calibri"/>
                 <a:cs typeface="Calibri"/>
               </a:rPr>
-              <a:t xml:space="preserve">Mistral</a:t>
-            </a:r>
-          </a:p>
-        </p:txBody>
-      </p:sp>
-      <p:sp>
-        <p:nvSpPr>
-          <p:cNvPr id="1162" name="LLM"/>
+              <a:t xml:space="preserve">DeepSeek</a:t>
+            </a:r>
+          </a:p>
+        </p:txBody>
+      </p:sp>
+      <p:sp>
+        <p:nvSpPr>
+          <p:cNvPr id="1162" name="Database"/>
           <p:cNvSpPr txBox="1"/>
           <p:nvPr/>
         </p:nvSpPr>
         <p:spPr>
           <a:xfrm>
-            <a:off x="7543800" y="3246120"/>
+            <a:off x="8293608" y="2990088"/>
+            <a:ext cx="2249424" cy="219456"/>
+          </a:xfrm>
+          <a:prstGeom prst="rect">
+            <a:avLst/>
+          </a:prstGeom>
+          <a:noFill/>
+          <a:ln>
+            <a:noFill/>
+          </a:ln>
+        </p:spPr>
+        <p:txBody>
+          <a:bodyPr wrap="square" lIns="0" tIns="0" rIns="0" bIns="0" anchor="ctr">
+            <a:noAutofit/>
+          </a:bodyPr>
+          <a:lstStyle/>
+          <a:p>
+            <a:pPr algn="ctr"/>
+            <a:r>
+              <a:rPr lang="en-US" sz="1100" b="1" i="0" dirty="0">
+                <a:solidFill>
+                  <a:srgbClr val="1F2328"/>
+                </a:solidFill>
+                <a:latin typeface="Calibri"/>
+                <a:cs typeface="Calibri"/>
+              </a:rPr>
+              <a:t xml:space="preserve">Chinook</a:t>
+            </a:r>
+          </a:p>
+        </p:txBody>
+      </p:sp>
+      <p:sp>
+        <p:nvSpPr>
+          <p:cNvPr id="1163" name="LLM"/>
+          <p:cNvSpPr txBox="1"/>
+          <p:nvPr/>
+        </p:nvSpPr>
+        <p:spPr>
+          <a:xfrm>
+            <a:off x="8293608" y="3218688"/>
             <a:ext cx="749808" cy="182880"/>
           </a:xfrm>
           <a:prstGeom prst="rect">
@@ -15912,46 +15981,7 @@
                 <a:latin typeface="Calibri"/>
                 <a:cs typeface="Calibri"/>
               </a:rPr>
-              <a:t xml:space="preserve">DeepSeek</a:t>
-            </a:r>
-          </a:p>
-        </p:txBody>
-      </p:sp>
-      <p:sp>
-        <p:nvSpPr>
-          <p:cNvPr id="1163" name="Database"/>
-          <p:cNvSpPr txBox="1"/>
-          <p:nvPr/>
-        </p:nvSpPr>
-        <p:spPr>
-          <a:xfrm>
-            <a:off x="8293608" y="3017520"/>
-            <a:ext cx="2249424" cy="219456"/>
-          </a:xfrm>
-          <a:prstGeom prst="rect">
-            <a:avLst/>
-          </a:prstGeom>
-          <a:noFill/>
-          <a:ln>
-            <a:noFill/>
-          </a:ln>
-        </p:spPr>
-        <p:txBody>
-          <a:bodyPr wrap="square" lIns="0" tIns="0" rIns="0" bIns="0" anchor="ctr">
-            <a:noAutofit/>
-          </a:bodyPr>
-          <a:lstStyle/>
-          <a:p>
-            <a:pPr algn="ctr"/>
-            <a:r>
-              <a:rPr lang="en-US" sz="1100" b="1" i="0" dirty="0">
-                <a:solidFill>
-                  <a:srgbClr val="1F2328"/>
-                </a:solidFill>
-                <a:latin typeface="Calibri"/>
-                <a:cs typeface="Calibri"/>
-              </a:rPr>
-              <a:t xml:space="preserve">Chinook</a:t>
+              <a:t xml:space="preserve">Claude</a:t>
             </a:r>
           </a:p>
         </p:txBody>
@@ -15964,7 +15994,7 @@
         </p:nvSpPr>
         <p:spPr>
           <a:xfrm>
-            <a:off x="8293608" y="3246120"/>
+            <a:off x="9043416" y="3218688"/>
             <a:ext cx="749808" cy="182880"/>
           </a:xfrm>
           <a:prstGeom prst="rect">
@@ -15990,7 +16020,7 @@
                 <a:latin typeface="Calibri"/>
                 <a:cs typeface="Calibri"/>
               </a:rPr>
-              <a:t xml:space="preserve">Claude</a:t>
+              <a:t xml:space="preserve">Mistral</a:t>
             </a:r>
           </a:p>
         </p:txBody>
@@ -16003,7 +16033,7 @@
         </p:nvSpPr>
         <p:spPr>
           <a:xfrm>
-            <a:off x="9043416" y="3246120"/>
+            <a:off x="9793224" y="3218688"/>
             <a:ext cx="749808" cy="182880"/>
           </a:xfrm>
           <a:prstGeom prst="rect">
@@ -16029,21 +16059,21 @@
                 <a:latin typeface="Calibri"/>
                 <a:cs typeface="Calibri"/>
               </a:rPr>
-              <a:t xml:space="preserve">Mistral</a:t>
-            </a:r>
-          </a:p>
-        </p:txBody>
-      </p:sp>
-      <p:sp>
-        <p:nvSpPr>
-          <p:cNvPr id="1166" name="LLM"/>
+              <a:t xml:space="preserve">DeepSeek</a:t>
+            </a:r>
+          </a:p>
+        </p:txBody>
+      </p:sp>
+      <p:sp>
+        <p:nvSpPr>
+          <p:cNvPr id="1166" name="Avg head"/>
           <p:cNvSpPr txBox="1"/>
           <p:nvPr/>
         </p:nvSpPr>
         <p:spPr>
           <a:xfrm>
-            <a:off x="9793224" y="3246120"/>
-            <a:ext cx="749808" cy="182880"/>
+            <a:off x="10588752" y="3099816"/>
+            <a:ext cx="685800" cy="237744"/>
           </a:xfrm>
           <a:prstGeom prst="rect">
             <a:avLst/>
@@ -16061,28 +16091,28 @@
           <a:p>
             <a:pPr algn="ctr"/>
             <a:r>
-              <a:rPr lang="en-US" sz="850" b="0" i="0" dirty="0">
+              <a:rPr lang="en-US" sz="1000" b="1" i="0" dirty="0">
                 <a:solidFill>
                   <a:srgbClr val="5B6770"/>
                 </a:solidFill>
                 <a:latin typeface="Calibri"/>
                 <a:cs typeface="Calibri"/>
               </a:rPr>
-              <a:t xml:space="preserve">DeepSeek</a:t>
-            </a:r>
-          </a:p>
-        </p:txBody>
-      </p:sp>
-      <p:sp>
-        <p:nvSpPr>
-          <p:cNvPr id="1167" name="Avg head"/>
+              <a:t xml:space="preserve">Avg</a:t>
+            </a:r>
+          </a:p>
+        </p:txBody>
+      </p:sp>
+      <p:sp>
+        <p:nvSpPr>
+          <p:cNvPr id="1167" name="Method"/>
           <p:cNvSpPr txBox="1"/>
           <p:nvPr/>
         </p:nvSpPr>
         <p:spPr>
           <a:xfrm>
-            <a:off x="10588752" y="3127248"/>
-            <a:ext cx="685800" cy="237744"/>
+            <a:off x="2514600" y="3447288"/>
+            <a:ext cx="1280160" cy="182880"/>
           </a:xfrm>
           <a:prstGeom prst="rect">
             <a:avLst/>
@@ -16098,16 +16128,16 @@
           </a:bodyPr>
           <a:lstStyle/>
           <a:p>
-            <a:pPr algn="ctr"/>
-            <a:r>
-              <a:rPr lang="en-US" sz="1000" b="1" i="0" dirty="0">
-                <a:solidFill>
-                  <a:srgbClr val="5B6770"/>
-                </a:solidFill>
-                <a:latin typeface="Calibri"/>
-                <a:cs typeface="Calibri"/>
-              </a:rPr>
-              <a:t xml:space="preserve">Avg</a:t>
+            <a:pPr algn="l"/>
+            <a:r>
+              <a:rPr lang="en-US" sz="1100" b="0" i="0" dirty="0">
+                <a:solidFill>
+                  <a:srgbClr val="1F2328"/>
+                </a:solidFill>
+                <a:latin typeface="Calibri"/>
+                <a:cs typeface="Calibri"/>
+              </a:rPr>
+              <a:t xml:space="preserve">Direct Mapping</a:t>
             </a:r>
           </a:p>
         </p:txBody>
@@ -16120,8 +16150,8 @@
         </p:nvSpPr>
         <p:spPr>
           <a:xfrm>
-            <a:off x="2514600" y="3474720"/>
-            <a:ext cx="1280160" cy="329184"/>
+            <a:off x="2514600" y="3630168"/>
+            <a:ext cx="1280160" cy="182880"/>
           </a:xfrm>
           <a:prstGeom prst="rect">
             <a:avLst/>
@@ -16139,6 +16169,125 @@
           <a:p>
             <a:pPr algn="l"/>
             <a:r>
+              <a:rPr lang="en-US" sz="1100" b="0" i="0" dirty="0">
+                <a:solidFill>
+                  <a:srgbClr val="1F2328"/>
+                </a:solidFill>
+                <a:latin typeface="Calibri"/>
+                <a:cs typeface="Calibri"/>
+              </a:rPr>
+              <a:t xml:space="preserve">LLM baseline</a:t>
+            </a:r>
+          </a:p>
+        </p:txBody>
+      </p:sp>
+      <p:sp>
+        <p:nvSpPr>
+          <p:cNvPr id="1169" name="None"/>
+          <p:cNvSpPr/>
+          <p:nvPr/>
+        </p:nvSpPr>
+        <p:spPr>
+          <a:xfrm>
+            <a:off x="3813048" y="3456432"/>
+            <a:ext cx="6711696" cy="347472"/>
+          </a:xfrm>
+          <a:prstGeom prst="rect">
+            <a:avLst/>
+          </a:prstGeom>
+          <a:solidFill>
+            <a:srgbClr val="F6DAD3"/>
+          </a:solidFill>
+          <a:ln>
+            <a:noFill/>
+          </a:ln>
+        </p:spPr>
+        <p:txBody>
+          <a:bodyPr wrap="square" lIns="0" tIns="0" rIns="0" bIns="0" anchor="ctr">
+            <a:noAutofit/>
+          </a:bodyPr>
+          <a:lstStyle/>
+          <a:p>
+            <a:pPr algn="ctr"/>
+            <a:r>
+              <a:rPr lang="en-US" sz="1150" b="0" i="1" dirty="0">
+                <a:solidFill>
+                  <a:srgbClr val="1F2328"/>
+                </a:solidFill>
+                <a:latin typeface="Calibri"/>
+                <a:cs typeface="Calibri"/>
+              </a:rPr>
+              <a:t xml:space="preserve">No labels, provenance or class hierarchy, in any run.</a:t>
+            </a:r>
+          </a:p>
+        </p:txBody>
+      </p:sp>
+      <p:sp>
+        <p:nvSpPr>
+          <p:cNvPr id="1170" name="Metric"/>
+          <p:cNvSpPr txBox="1"/>
+          <p:nvPr/>
+        </p:nvSpPr>
+        <p:spPr>
+          <a:xfrm>
+            <a:off x="1078992" y="3867912"/>
+            <a:ext cx="1417320" cy="512064"/>
+          </a:xfrm>
+          <a:prstGeom prst="rect">
+            <a:avLst/>
+          </a:prstGeom>
+          <a:noFill/>
+          <a:ln>
+            <a:noFill/>
+          </a:ln>
+        </p:spPr>
+        <p:txBody>
+          <a:bodyPr wrap="square" lIns="0" tIns="0" rIns="0" bIns="0" anchor="ctr">
+            <a:noAutofit/>
+          </a:bodyPr>
+          <a:lstStyle/>
+          <a:p>
+            <a:pPr algn="l"/>
+            <a:r>
+              <a:rPr lang="en-US" sz="1150" b="1" i="0" dirty="0">
+                <a:solidFill>
+                  <a:srgbClr val="2F6B78"/>
+                </a:solidFill>
+                <a:latin typeface="Calibri"/>
+                <a:cs typeface="Calibri"/>
+              </a:rPr>
+              <a:t xml:space="preserve">Labels &amp; comments</a:t>
+            </a:r>
+          </a:p>
+        </p:txBody>
+      </p:sp>
+      <p:sp>
+        <p:nvSpPr>
+          <p:cNvPr id="1171" name="Method"/>
+          <p:cNvSpPr txBox="1"/>
+          <p:nvPr/>
+        </p:nvSpPr>
+        <p:spPr>
+          <a:xfrm>
+            <a:off x="2514600" y="3867912"/>
+            <a:ext cx="1280160" cy="256032"/>
+          </a:xfrm>
+          <a:prstGeom prst="rect">
+            <a:avLst/>
+          </a:prstGeom>
+          <a:noFill/>
+          <a:ln>
+            <a:noFill/>
+          </a:ln>
+        </p:spPr>
+        <p:txBody>
+          <a:bodyPr wrap="square" lIns="0" tIns="0" rIns="0" bIns="0" anchor="ctr">
+            <a:noAutofit/>
+          </a:bodyPr>
+          <a:lstStyle/>
+          <a:p>
+            <a:pPr algn="l"/>
+            <a:r>
               <a:rPr lang="en-US" sz="1200" b="0" i="0" dirty="0">
                 <a:solidFill>
                   <a:srgbClr val="1F2328"/>
@@ -16146,130 +16295,7 @@
                 <a:latin typeface="Calibri"/>
                 <a:cs typeface="Calibri"/>
               </a:rPr>
-              <a:t xml:space="preserve">Non-Iterative</a:t>
-            </a:r>
-          </a:p>
-        </p:txBody>
-      </p:sp>
-      <p:sp>
-        <p:nvSpPr>
-          <p:cNvPr id="1169" name="Cell"/>
-          <p:cNvSpPr/>
-          <p:nvPr/>
-        </p:nvSpPr>
-        <p:spPr>
-          <a:xfrm>
-            <a:off x="3813048" y="3493008"/>
-            <a:ext cx="713231" cy="292608"/>
-          </a:xfrm>
-          <a:prstGeom prst="rect">
-            <a:avLst/>
-          </a:prstGeom>
-          <a:solidFill>
-            <a:srgbClr val="DDF0E5"/>
-          </a:solidFill>
-          <a:ln>
-            <a:noFill/>
-          </a:ln>
-        </p:spPr>
-        <p:txBody>
-          <a:bodyPr wrap="square" lIns="0" tIns="0" rIns="0" bIns="0" anchor="ctr">
-            <a:noAutofit/>
-          </a:bodyPr>
-          <a:lstStyle/>
-          <a:p>
-            <a:pPr algn="ctr"/>
-            <a:r>
-              <a:rPr lang="en-US" sz="1100" b="0" i="0" dirty="0">
-                <a:solidFill>
-                  <a:srgbClr val="1F2328"/>
-                </a:solidFill>
-                <a:latin typeface="Calibri"/>
-                <a:cs typeface="Calibri"/>
-              </a:rPr>
-              <a:t xml:space="preserve">680</a:t>
-            </a:r>
-          </a:p>
-        </p:txBody>
-      </p:sp>
-      <p:sp>
-        <p:nvSpPr>
-          <p:cNvPr id="1170" name="Cell"/>
-          <p:cNvSpPr/>
-          <p:nvPr/>
-        </p:nvSpPr>
-        <p:spPr>
-          <a:xfrm>
-            <a:off x="4562856" y="3493008"/>
-            <a:ext cx="713231" cy="292608"/>
-          </a:xfrm>
-          <a:prstGeom prst="rect">
-            <a:avLst/>
-          </a:prstGeom>
-          <a:solidFill>
-            <a:srgbClr val="F1F3F2"/>
-          </a:solidFill>
-          <a:ln>
-            <a:noFill/>
-          </a:ln>
-        </p:spPr>
-        <p:txBody>
-          <a:bodyPr wrap="square" lIns="0" tIns="0" rIns="0" bIns="0" anchor="ctr">
-            <a:noAutofit/>
-          </a:bodyPr>
-          <a:lstStyle/>
-          <a:p>
-            <a:pPr algn="ctr"/>
-            <a:r>
-              <a:rPr lang="en-US" sz="1100" b="0" i="0" dirty="0">
-                <a:solidFill>
-                  <a:srgbClr val="1F2328"/>
-                </a:solidFill>
-                <a:latin typeface="Calibri"/>
-                <a:cs typeface="Calibri"/>
-              </a:rPr>
-              <a:t xml:space="preserve">134</a:t>
-            </a:r>
-          </a:p>
-        </p:txBody>
-      </p:sp>
-      <p:sp>
-        <p:nvSpPr>
-          <p:cNvPr id="1171" name="Cell"/>
-          <p:cNvSpPr/>
-          <p:nvPr/>
-        </p:nvSpPr>
-        <p:spPr>
-          <a:xfrm>
-            <a:off x="5312664" y="3493008"/>
-            <a:ext cx="713231" cy="292608"/>
-          </a:xfrm>
-          <a:prstGeom prst="rect">
-            <a:avLst/>
-          </a:prstGeom>
-          <a:solidFill>
-            <a:srgbClr val="DDF0E5"/>
-          </a:solidFill>
-          <a:ln>
-            <a:noFill/>
-          </a:ln>
-        </p:spPr>
-        <p:txBody>
-          <a:bodyPr wrap="square" lIns="0" tIns="0" rIns="0" bIns="0" anchor="ctr">
-            <a:noAutofit/>
-          </a:bodyPr>
-          <a:lstStyle/>
-          <a:p>
-            <a:pPr algn="ctr"/>
-            <a:r>
-              <a:rPr lang="en-US" sz="1100" b="0" i="0" dirty="0">
-                <a:solidFill>
-                  <a:srgbClr val="1F2328"/>
-                </a:solidFill>
-                <a:latin typeface="Calibri"/>
-                <a:cs typeface="Calibri"/>
-              </a:rPr>
-              <a:t xml:space="preserve">736</a:t>
+              <a:t xml:space="preserve">Non-Iterative RAG</a:t>
             </a:r>
           </a:p>
         </p:txBody>
@@ -16282,14 +16308,14 @@
         </p:nvSpPr>
         <p:spPr>
           <a:xfrm>
-            <a:off x="6062472" y="3493008"/>
-            <a:ext cx="713231" cy="292608"/>
-          </a:xfrm>
-          <a:prstGeom prst="rect">
-            <a:avLst/>
-          </a:prstGeom>
-          <a:solidFill>
-            <a:srgbClr val="BFE3CF"/>
+            <a:off x="3813048" y="3886200"/>
+            <a:ext cx="713231" cy="219456"/>
+          </a:xfrm>
+          <a:prstGeom prst="rect">
+            <a:avLst/>
+          </a:prstGeom>
+          <a:solidFill>
+            <a:srgbClr val="DDF0E5"/>
           </a:solidFill>
           <a:ln>
             <a:noFill/>
@@ -16310,7 +16336,7 @@
                 <a:latin typeface="Calibri"/>
                 <a:cs typeface="Calibri"/>
               </a:rPr>
-              <a:t xml:space="preserve">877</a:t>
+              <a:t xml:space="preserve">680</a:t>
             </a:r>
           </a:p>
         </p:txBody>
@@ -16323,14 +16349,14 @@
         </p:nvSpPr>
         <p:spPr>
           <a:xfrm>
-            <a:off x="6812279" y="3493008"/>
-            <a:ext cx="713231" cy="292608"/>
-          </a:xfrm>
-          <a:prstGeom prst="rect">
-            <a:avLst/>
-          </a:prstGeom>
-          <a:solidFill>
-            <a:srgbClr val="F1F3F2"/>
+            <a:off x="4562856" y="3886200"/>
+            <a:ext cx="713231" cy="219456"/>
+          </a:xfrm>
+          <a:prstGeom prst="rect">
+            <a:avLst/>
+          </a:prstGeom>
+          <a:solidFill>
+            <a:srgbClr val="F6DAD3"/>
           </a:solidFill>
           <a:ln>
             <a:noFill/>
@@ -16351,7 +16377,7 @@
                 <a:latin typeface="Calibri"/>
                 <a:cs typeface="Calibri"/>
               </a:rPr>
-              <a:t xml:space="preserve">157</a:t>
+              <a:t xml:space="preserve">134</a:t>
             </a:r>
           </a:p>
         </p:txBody>
@@ -16364,8 +16390,8 @@
         </p:nvSpPr>
         <p:spPr>
           <a:xfrm>
-            <a:off x="7562088" y="3493008"/>
-            <a:ext cx="713231" cy="292608"/>
+            <a:off x="5312664" y="3886200"/>
+            <a:ext cx="713231" cy="219456"/>
           </a:xfrm>
           <a:prstGeom prst="rect">
             <a:avLst/>
@@ -16392,7 +16418,7 @@
                 <a:latin typeface="Calibri"/>
                 <a:cs typeface="Calibri"/>
               </a:rPr>
-              <a:t xml:space="preserve">743</a:t>
+              <a:t xml:space="preserve">736</a:t>
             </a:r>
           </a:p>
         </p:txBody>
@@ -16405,14 +16431,14 @@
         </p:nvSpPr>
         <p:spPr>
           <a:xfrm>
-            <a:off x="8311896" y="3493008"/>
-            <a:ext cx="713231" cy="292608"/>
-          </a:xfrm>
-          <a:prstGeom prst="rect">
-            <a:avLst/>
-          </a:prstGeom>
-          <a:solidFill>
-            <a:srgbClr val="F6DAD3"/>
+            <a:off x="6062472" y="3886200"/>
+            <a:ext cx="713231" cy="219456"/>
+          </a:xfrm>
+          <a:prstGeom prst="rect">
+            <a:avLst/>
+          </a:prstGeom>
+          <a:solidFill>
+            <a:srgbClr val="DDF0E5"/>
           </a:solidFill>
           <a:ln>
             <a:noFill/>
@@ -16433,7 +16459,7 @@
                 <a:latin typeface="Calibri"/>
                 <a:cs typeface="Calibri"/>
               </a:rPr>
-              <a:t xml:space="preserve">98</a:t>
+              <a:t xml:space="preserve">877</a:t>
             </a:r>
           </a:p>
         </p:txBody>
@@ -16446,8 +16472,8 @@
         </p:nvSpPr>
         <p:spPr>
           <a:xfrm>
-            <a:off x="9061704" y="3493008"/>
-            <a:ext cx="713231" cy="292608"/>
+            <a:off x="6812279" y="3886200"/>
+            <a:ext cx="713231" cy="219456"/>
           </a:xfrm>
           <a:prstGeom prst="rect">
             <a:avLst/>
@@ -16474,7 +16500,7 @@
                 <a:latin typeface="Calibri"/>
                 <a:cs typeface="Calibri"/>
               </a:rPr>
-              <a:t xml:space="preserve">14</a:t>
+              <a:t xml:space="preserve">157</a:t>
             </a:r>
           </a:p>
         </p:txBody>
@@ -16487,8 +16513,90 @@
         </p:nvSpPr>
         <p:spPr>
           <a:xfrm>
-            <a:off x="9811512" y="3493008"/>
-            <a:ext cx="713231" cy="292608"/>
+            <a:off x="7562088" y="3886200"/>
+            <a:ext cx="713231" cy="219456"/>
+          </a:xfrm>
+          <a:prstGeom prst="rect">
+            <a:avLst/>
+          </a:prstGeom>
+          <a:solidFill>
+            <a:srgbClr val="F1F3F2"/>
+          </a:solidFill>
+          <a:ln>
+            <a:noFill/>
+          </a:ln>
+        </p:spPr>
+        <p:txBody>
+          <a:bodyPr wrap="square" lIns="0" tIns="0" rIns="0" bIns="0" anchor="ctr">
+            <a:noAutofit/>
+          </a:bodyPr>
+          <a:lstStyle/>
+          <a:p>
+            <a:pPr algn="ctr"/>
+            <a:r>
+              <a:rPr lang="en-US" sz="1100" b="0" i="0" dirty="0">
+                <a:solidFill>
+                  <a:srgbClr val="1F2328"/>
+                </a:solidFill>
+                <a:latin typeface="Calibri"/>
+                <a:cs typeface="Calibri"/>
+              </a:rPr>
+              <a:t xml:space="preserve">743</a:t>
+            </a:r>
+          </a:p>
+        </p:txBody>
+      </p:sp>
+      <p:sp>
+        <p:nvSpPr>
+          <p:cNvPr id="1178" name="Cell"/>
+          <p:cNvSpPr/>
+          <p:nvPr/>
+        </p:nvSpPr>
+        <p:spPr>
+          <a:xfrm>
+            <a:off x="8311896" y="3886200"/>
+            <a:ext cx="713231" cy="219456"/>
+          </a:xfrm>
+          <a:prstGeom prst="rect">
+            <a:avLst/>
+          </a:prstGeom>
+          <a:solidFill>
+            <a:srgbClr val="F1F3F2"/>
+          </a:solidFill>
+          <a:ln>
+            <a:noFill/>
+          </a:ln>
+        </p:spPr>
+        <p:txBody>
+          <a:bodyPr wrap="square" lIns="0" tIns="0" rIns="0" bIns="0" anchor="ctr">
+            <a:noAutofit/>
+          </a:bodyPr>
+          <a:lstStyle/>
+          <a:p>
+            <a:pPr algn="ctr"/>
+            <a:r>
+              <a:rPr lang="en-US" sz="1100" b="0" i="0" dirty="0">
+                <a:solidFill>
+                  <a:srgbClr val="1F2328"/>
+                </a:solidFill>
+                <a:latin typeface="Calibri"/>
+                <a:cs typeface="Calibri"/>
+              </a:rPr>
+              <a:t xml:space="preserve">98</a:t>
+            </a:r>
+          </a:p>
+        </p:txBody>
+      </p:sp>
+      <p:sp>
+        <p:nvSpPr>
+          <p:cNvPr id="1179" name="Cell"/>
+          <p:cNvSpPr/>
+          <p:nvPr/>
+        </p:nvSpPr>
+        <p:spPr>
+          <a:xfrm>
+            <a:off x="9061704" y="3886200"/>
+            <a:ext cx="713231" cy="219456"/>
           </a:xfrm>
           <a:prstGeom prst="rect">
             <a:avLst/>
@@ -16515,85 +16623,7 @@
                 <a:latin typeface="Calibri"/>
                 <a:cs typeface="Calibri"/>
               </a:rPr>
-              <a:t xml:space="preserve">64</a:t>
-            </a:r>
-          </a:p>
-        </p:txBody>
-      </p:sp>
-      <p:sp>
-        <p:nvSpPr>
-          <p:cNvPr id="1178" name="Avg"/>
-          <p:cNvSpPr txBox="1"/>
-          <p:nvPr/>
-        </p:nvSpPr>
-        <p:spPr>
-          <a:xfrm>
-            <a:off x="10588752" y="3474720"/>
-            <a:ext cx="685800" cy="329184"/>
-          </a:xfrm>
-          <a:prstGeom prst="rect">
-            <a:avLst/>
-          </a:prstGeom>
-          <a:noFill/>
-          <a:ln>
-            <a:noFill/>
-          </a:ln>
-        </p:spPr>
-        <p:txBody>
-          <a:bodyPr wrap="square" lIns="0" tIns="0" rIns="0" bIns="0" anchor="ctr">
-            <a:noAutofit/>
-          </a:bodyPr>
-          <a:lstStyle/>
-          <a:p>
-            <a:pPr algn="ctr"/>
-            <a:r>
-              <a:rPr lang="en-US" sz="1250" b="0" i="0" dirty="0">
-                <a:solidFill>
-                  <a:srgbClr val="1F2328"/>
-                </a:solidFill>
-                <a:latin typeface="Calibri"/>
-                <a:cs typeface="Calibri"/>
-              </a:rPr>
-              <a:t xml:space="preserve">389</a:t>
-            </a:r>
-          </a:p>
-        </p:txBody>
-      </p:sp>
-      <p:sp>
-        <p:nvSpPr>
-          <p:cNvPr id="1179" name="Method"/>
-          <p:cNvSpPr txBox="1"/>
-          <p:nvPr/>
-        </p:nvSpPr>
-        <p:spPr>
-          <a:xfrm>
-            <a:off x="2514600" y="3803904"/>
-            <a:ext cx="1280160" cy="329184"/>
-          </a:xfrm>
-          <a:prstGeom prst="rect">
-            <a:avLst/>
-          </a:prstGeom>
-          <a:noFill/>
-          <a:ln>
-            <a:noFill/>
-          </a:ln>
-        </p:spPr>
-        <p:txBody>
-          <a:bodyPr wrap="square" lIns="0" tIns="0" rIns="0" bIns="0" anchor="ctr">
-            <a:noAutofit/>
-          </a:bodyPr>
-          <a:lstStyle/>
-          <a:p>
-            <a:pPr algn="l"/>
-            <a:r>
-              <a:rPr lang="en-US" sz="1200" b="1" i="0" dirty="0">
-                <a:solidFill>
-                  <a:srgbClr val="0B6E4F"/>
-                </a:solidFill>
-                <a:latin typeface="Calibri"/>
-                <a:cs typeface="Calibri"/>
-              </a:rPr>
-              <a:t xml:space="preserve">RIGOR</a:t>
+              <a:t xml:space="preserve">14</a:t>
             </a:r>
           </a:p>
         </p:txBody>
@@ -16606,117 +16636,113 @@
         </p:nvSpPr>
         <p:spPr>
           <a:xfrm>
-            <a:off x="3813048" y="3822191"/>
-            <a:ext cx="713231" cy="292608"/>
-          </a:xfrm>
-          <a:prstGeom prst="rect">
-            <a:avLst/>
-          </a:prstGeom>
-          <a:solidFill>
-            <a:srgbClr val="BFE3CF"/>
-          </a:solidFill>
-          <a:ln>
-            <a:noFill/>
-          </a:ln>
-        </p:spPr>
-        <p:txBody>
-          <a:bodyPr wrap="square" lIns="0" tIns="0" rIns="0" bIns="0" anchor="ctr">
-            <a:noAutofit/>
-          </a:bodyPr>
-          <a:lstStyle/>
-          <a:p>
-            <a:pPr algn="ctr"/>
-            <a:r>
-              <a:rPr lang="en-US" sz="1100" b="1" i="0" dirty="0">
-                <a:solidFill>
-                  <a:srgbClr val="1F2328"/>
-                </a:solidFill>
-                <a:latin typeface="Calibri"/>
-                <a:cs typeface="Calibri"/>
-              </a:rPr>
-              <a:t xml:space="preserve">1,029</a:t>
-            </a:r>
-          </a:p>
-        </p:txBody>
-      </p:sp>
-      <p:sp>
-        <p:nvSpPr>
-          <p:cNvPr id="1181" name="Cell"/>
-          <p:cNvSpPr/>
-          <p:nvPr/>
-        </p:nvSpPr>
-        <p:spPr>
-          <a:xfrm>
-            <a:off x="4562856" y="3822191"/>
-            <a:ext cx="713231" cy="292608"/>
-          </a:xfrm>
-          <a:prstGeom prst="rect">
-            <a:avLst/>
-          </a:prstGeom>
-          <a:solidFill>
-            <a:srgbClr val="BFE3CF"/>
-          </a:solidFill>
-          <a:ln>
-            <a:noFill/>
-          </a:ln>
-        </p:spPr>
-        <p:txBody>
-          <a:bodyPr wrap="square" lIns="0" tIns="0" rIns="0" bIns="0" anchor="ctr">
-            <a:noAutofit/>
-          </a:bodyPr>
-          <a:lstStyle/>
-          <a:p>
-            <a:pPr algn="ctr"/>
-            <a:r>
-              <a:rPr lang="en-US" sz="1100" b="1" i="0" dirty="0">
-                <a:solidFill>
-                  <a:srgbClr val="1F2328"/>
-                </a:solidFill>
-                <a:latin typeface="Calibri"/>
-                <a:cs typeface="Calibri"/>
-              </a:rPr>
-              <a:t xml:space="preserve">1,137</a:t>
-            </a:r>
-          </a:p>
-        </p:txBody>
-      </p:sp>
-      <p:sp>
-        <p:nvSpPr>
-          <p:cNvPr id="1182" name="Cell"/>
-          <p:cNvSpPr/>
-          <p:nvPr/>
-        </p:nvSpPr>
-        <p:spPr>
-          <a:xfrm>
-            <a:off x="5312664" y="3822191"/>
-            <a:ext cx="713231" cy="292608"/>
-          </a:xfrm>
-          <a:prstGeom prst="rect">
-            <a:avLst/>
-          </a:prstGeom>
-          <a:solidFill>
-            <a:srgbClr val="DDF0E5"/>
-          </a:solidFill>
-          <a:ln>
-            <a:noFill/>
-          </a:ln>
-        </p:spPr>
-        <p:txBody>
-          <a:bodyPr wrap="square" lIns="0" tIns="0" rIns="0" bIns="0" anchor="ctr">
-            <a:noAutofit/>
-          </a:bodyPr>
-          <a:lstStyle/>
-          <a:p>
-            <a:pPr algn="ctr"/>
-            <a:r>
-              <a:rPr lang="en-US" sz="1100" b="1" i="0" dirty="0">
-                <a:solidFill>
-                  <a:srgbClr val="1F2328"/>
-                </a:solidFill>
-                <a:latin typeface="Calibri"/>
-                <a:cs typeface="Calibri"/>
-              </a:rPr>
-              <a:t xml:space="preserve">341</a:t>
+            <a:off x="9811512" y="3886200"/>
+            <a:ext cx="713231" cy="219456"/>
+          </a:xfrm>
+          <a:prstGeom prst="rect">
+            <a:avLst/>
+          </a:prstGeom>
+          <a:solidFill>
+            <a:srgbClr val="F6DAD3"/>
+          </a:solidFill>
+          <a:ln>
+            <a:noFill/>
+          </a:ln>
+        </p:spPr>
+        <p:txBody>
+          <a:bodyPr wrap="square" lIns="0" tIns="0" rIns="0" bIns="0" anchor="ctr">
+            <a:noAutofit/>
+          </a:bodyPr>
+          <a:lstStyle/>
+          <a:p>
+            <a:pPr algn="ctr"/>
+            <a:r>
+              <a:rPr lang="en-US" sz="1100" b="0" i="0" dirty="0">
+                <a:solidFill>
+                  <a:srgbClr val="1F2328"/>
+                </a:solidFill>
+                <a:latin typeface="Calibri"/>
+                <a:cs typeface="Calibri"/>
+              </a:rPr>
+              <a:t xml:space="preserve">64</a:t>
+            </a:r>
+          </a:p>
+        </p:txBody>
+      </p:sp>
+      <p:sp>
+        <p:nvSpPr>
+          <p:cNvPr id="1181" name="Avg"/>
+          <p:cNvSpPr txBox="1"/>
+          <p:nvPr/>
+        </p:nvSpPr>
+        <p:spPr>
+          <a:xfrm>
+            <a:off x="10588752" y="3867912"/>
+            <a:ext cx="685800" cy="256032"/>
+          </a:xfrm>
+          <a:prstGeom prst="rect">
+            <a:avLst/>
+          </a:prstGeom>
+          <a:noFill/>
+          <a:ln>
+            <a:noFill/>
+          </a:ln>
+        </p:spPr>
+        <p:txBody>
+          <a:bodyPr wrap="square" lIns="0" tIns="0" rIns="0" bIns="0" anchor="ctr">
+            <a:noAutofit/>
+          </a:bodyPr>
+          <a:lstStyle/>
+          <a:p>
+            <a:pPr algn="ctr"/>
+            <a:r>
+              <a:rPr lang="en-US" sz="1250" b="0" i="0" dirty="0">
+                <a:solidFill>
+                  <a:srgbClr val="1F2328"/>
+                </a:solidFill>
+                <a:latin typeface="Calibri"/>
+                <a:cs typeface="Calibri"/>
+              </a:rPr>
+              <a:t xml:space="preserve">389</a:t>
+            </a:r>
+          </a:p>
+        </p:txBody>
+      </p:sp>
+      <p:sp>
+        <p:nvSpPr>
+          <p:cNvPr id="1182" name="Method"/>
+          <p:cNvSpPr txBox="1"/>
+          <p:nvPr/>
+        </p:nvSpPr>
+        <p:spPr>
+          <a:xfrm>
+            <a:off x="2514600" y="4123944"/>
+            <a:ext cx="1280160" cy="256032"/>
+          </a:xfrm>
+          <a:prstGeom prst="rect">
+            <a:avLst/>
+          </a:prstGeom>
+          <a:noFill/>
+          <a:ln>
+            <a:noFill/>
+          </a:ln>
+        </p:spPr>
+        <p:txBody>
+          <a:bodyPr wrap="square" lIns="0" tIns="0" rIns="0" bIns="0" anchor="ctr">
+            <a:noAutofit/>
+          </a:bodyPr>
+          <a:lstStyle/>
+          <a:p>
+            <a:pPr algn="l"/>
+            <a:r>
+              <a:rPr lang="en-US" sz="1200" b="1" i="0" dirty="0">
+                <a:solidFill>
+                  <a:srgbClr val="0B6E4F"/>
+                </a:solidFill>
+                <a:latin typeface="Calibri"/>
+                <a:cs typeface="Calibri"/>
+              </a:rPr>
+              <a:t xml:space="preserve">RIGOR</a:t>
             </a:r>
           </a:p>
         </p:txBody>
@@ -16729,8 +16755,8 @@
         </p:nvSpPr>
         <p:spPr>
           <a:xfrm>
-            <a:off x="6062472" y="3822191"/>
-            <a:ext cx="713231" cy="292608"/>
+            <a:off x="3813048" y="4142232"/>
+            <a:ext cx="713231" cy="219456"/>
           </a:xfrm>
           <a:prstGeom prst="rect">
             <a:avLst/>
@@ -16757,7 +16783,7 @@
                 <a:latin typeface="Calibri"/>
                 <a:cs typeface="Calibri"/>
               </a:rPr>
-              <a:t xml:space="preserve">1,291</a:t>
+              <a:t xml:space="preserve">1,029</a:t>
             </a:r>
           </a:p>
         </p:txBody>
@@ -16770,8 +16796,8 @@
         </p:nvSpPr>
         <p:spPr>
           <a:xfrm>
-            <a:off x="6812279" y="3822191"/>
-            <a:ext cx="713231" cy="292608"/>
+            <a:off x="4562856" y="4142232"/>
+            <a:ext cx="713231" cy="219456"/>
           </a:xfrm>
           <a:prstGeom prst="rect">
             <a:avLst/>
@@ -16798,7 +16824,7 @@
                 <a:latin typeface="Calibri"/>
                 <a:cs typeface="Calibri"/>
               </a:rPr>
-              <a:t xml:space="preserve">1,684</a:t>
+              <a:t xml:space="preserve">1,137</a:t>
             </a:r>
           </a:p>
         </p:txBody>
@@ -16811,14 +16837,14 @@
         </p:nvSpPr>
         <p:spPr>
           <a:xfrm>
-            <a:off x="7562088" y="3822191"/>
-            <a:ext cx="713231" cy="292608"/>
-          </a:xfrm>
-          <a:prstGeom prst="rect">
-            <a:avLst/>
-          </a:prstGeom>
-          <a:solidFill>
-            <a:srgbClr val="DDF0E5"/>
+            <a:off x="5312664" y="4142232"/>
+            <a:ext cx="713231" cy="219456"/>
+          </a:xfrm>
+          <a:prstGeom prst="rect">
+            <a:avLst/>
+          </a:prstGeom>
+          <a:solidFill>
+            <a:srgbClr val="F1F3F2"/>
           </a:solidFill>
           <a:ln>
             <a:noFill/>
@@ -16839,7 +16865,7 @@
                 <a:latin typeface="Calibri"/>
                 <a:cs typeface="Calibri"/>
               </a:rPr>
-              <a:t xml:space="preserve">435</a:t>
+              <a:t xml:space="preserve">341</a:t>
             </a:r>
           </a:p>
         </p:txBody>
@@ -16852,14 +16878,14 @@
         </p:nvSpPr>
         <p:spPr>
           <a:xfrm>
-            <a:off x="8311896" y="3822191"/>
-            <a:ext cx="713231" cy="292608"/>
-          </a:xfrm>
-          <a:prstGeom prst="rect">
-            <a:avLst/>
-          </a:prstGeom>
-          <a:solidFill>
-            <a:srgbClr val="DDF0E5"/>
+            <a:off x="6062472" y="4142232"/>
+            <a:ext cx="713231" cy="219456"/>
+          </a:xfrm>
+          <a:prstGeom prst="rect">
+            <a:avLst/>
+          </a:prstGeom>
+          <a:solidFill>
+            <a:srgbClr val="BFE3CF"/>
           </a:solidFill>
           <a:ln>
             <a:noFill/>
@@ -16880,7 +16906,7 @@
                 <a:latin typeface="Calibri"/>
                 <a:cs typeface="Calibri"/>
               </a:rPr>
-              <a:t xml:space="preserve">357</a:t>
+              <a:t xml:space="preserve">1,291</a:t>
             </a:r>
           </a:p>
         </p:txBody>
@@ -16893,14 +16919,14 @@
         </p:nvSpPr>
         <p:spPr>
           <a:xfrm>
-            <a:off x="9061704" y="3822191"/>
-            <a:ext cx="713231" cy="292608"/>
-          </a:xfrm>
-          <a:prstGeom prst="rect">
-            <a:avLst/>
-          </a:prstGeom>
-          <a:solidFill>
-            <a:srgbClr val="DDF0E5"/>
+            <a:off x="6812279" y="4142232"/>
+            <a:ext cx="713231" cy="219456"/>
+          </a:xfrm>
+          <a:prstGeom prst="rect">
+            <a:avLst/>
+          </a:prstGeom>
+          <a:solidFill>
+            <a:srgbClr val="BFE3CF"/>
           </a:solidFill>
           <a:ln>
             <a:noFill/>
@@ -16921,7 +16947,7 @@
                 <a:latin typeface="Calibri"/>
                 <a:cs typeface="Calibri"/>
               </a:rPr>
-              <a:t xml:space="preserve">362</a:t>
+              <a:t xml:space="preserve">1,684</a:t>
             </a:r>
           </a:p>
         </p:txBody>
@@ -16934,14 +16960,14 @@
         </p:nvSpPr>
         <p:spPr>
           <a:xfrm>
-            <a:off x="9811512" y="3822191"/>
-            <a:ext cx="713231" cy="292608"/>
-          </a:xfrm>
-          <a:prstGeom prst="rect">
-            <a:avLst/>
-          </a:prstGeom>
-          <a:solidFill>
-            <a:srgbClr val="DDF0E5"/>
+            <a:off x="7562088" y="4142232"/>
+            <a:ext cx="713231" cy="219456"/>
+          </a:xfrm>
+          <a:prstGeom prst="rect">
+            <a:avLst/>
+          </a:prstGeom>
+          <a:solidFill>
+            <a:srgbClr val="F1F3F2"/>
           </a:solidFill>
           <a:ln>
             <a:noFill/>
@@ -16962,6 +16988,129 @@
                 <a:latin typeface="Calibri"/>
                 <a:cs typeface="Calibri"/>
               </a:rPr>
+              <a:t xml:space="preserve">435</a:t>
+            </a:r>
+          </a:p>
+        </p:txBody>
+      </p:sp>
+      <p:sp>
+        <p:nvSpPr>
+          <p:cNvPr id="1189" name="Cell"/>
+          <p:cNvSpPr/>
+          <p:nvPr/>
+        </p:nvSpPr>
+        <p:spPr>
+          <a:xfrm>
+            <a:off x="8311896" y="4142232"/>
+            <a:ext cx="713231" cy="219456"/>
+          </a:xfrm>
+          <a:prstGeom prst="rect">
+            <a:avLst/>
+          </a:prstGeom>
+          <a:solidFill>
+            <a:srgbClr val="BFE3CF"/>
+          </a:solidFill>
+          <a:ln>
+            <a:noFill/>
+          </a:ln>
+        </p:spPr>
+        <p:txBody>
+          <a:bodyPr wrap="square" lIns="0" tIns="0" rIns="0" bIns="0" anchor="ctr">
+            <a:noAutofit/>
+          </a:bodyPr>
+          <a:lstStyle/>
+          <a:p>
+            <a:pPr algn="ctr"/>
+            <a:r>
+              <a:rPr lang="en-US" sz="1100" b="1" i="0" dirty="0">
+                <a:solidFill>
+                  <a:srgbClr val="1F2328"/>
+                </a:solidFill>
+                <a:latin typeface="Calibri"/>
+                <a:cs typeface="Calibri"/>
+              </a:rPr>
+              <a:t xml:space="preserve">357</a:t>
+            </a:r>
+          </a:p>
+        </p:txBody>
+      </p:sp>
+      <p:sp>
+        <p:nvSpPr>
+          <p:cNvPr id="1190" name="Cell"/>
+          <p:cNvSpPr/>
+          <p:nvPr/>
+        </p:nvSpPr>
+        <p:spPr>
+          <a:xfrm>
+            <a:off x="9061704" y="4142232"/>
+            <a:ext cx="713231" cy="219456"/>
+          </a:xfrm>
+          <a:prstGeom prst="rect">
+            <a:avLst/>
+          </a:prstGeom>
+          <a:solidFill>
+            <a:srgbClr val="BFE3CF"/>
+          </a:solidFill>
+          <a:ln>
+            <a:noFill/>
+          </a:ln>
+        </p:spPr>
+        <p:txBody>
+          <a:bodyPr wrap="square" lIns="0" tIns="0" rIns="0" bIns="0" anchor="ctr">
+            <a:noAutofit/>
+          </a:bodyPr>
+          <a:lstStyle/>
+          <a:p>
+            <a:pPr algn="ctr"/>
+            <a:r>
+              <a:rPr lang="en-US" sz="1100" b="1" i="0" dirty="0">
+                <a:solidFill>
+                  <a:srgbClr val="1F2328"/>
+                </a:solidFill>
+                <a:latin typeface="Calibri"/>
+                <a:cs typeface="Calibri"/>
+              </a:rPr>
+              <a:t xml:space="preserve">362</a:t>
+            </a:r>
+          </a:p>
+        </p:txBody>
+      </p:sp>
+      <p:sp>
+        <p:nvSpPr>
+          <p:cNvPr id="1191" name="Cell"/>
+          <p:cNvSpPr/>
+          <p:nvPr/>
+        </p:nvSpPr>
+        <p:spPr>
+          <a:xfrm>
+            <a:off x="9811512" y="4142232"/>
+            <a:ext cx="713231" cy="219456"/>
+          </a:xfrm>
+          <a:prstGeom prst="rect">
+            <a:avLst/>
+          </a:prstGeom>
+          <a:solidFill>
+            <a:srgbClr val="BFE3CF"/>
+          </a:solidFill>
+          <a:ln>
+            <a:noFill/>
+          </a:ln>
+        </p:spPr>
+        <p:txBody>
+          <a:bodyPr wrap="square" lIns="0" tIns="0" rIns="0" bIns="0" anchor="ctr">
+            <a:noAutofit/>
+          </a:bodyPr>
+          <a:lstStyle/>
+          <a:p>
+            <a:pPr algn="ctr"/>
+            <a:r>
+              <a:rPr lang="en-US" sz="1100" b="1" i="0" dirty="0">
+                <a:solidFill>
+                  <a:srgbClr val="1F2328"/>
+                </a:solidFill>
+                <a:latin typeface="Calibri"/>
+                <a:cs typeface="Calibri"/>
+              </a:rPr>
               <a:t xml:space="preserve">359</a:t>
             </a:r>
           </a:p>
@@ -16969,14 +17118,14 @@
       </p:sp>
       <p:sp>
         <p:nvSpPr>
-          <p:cNvPr id="1189" name="Avg"/>
+          <p:cNvPr id="1192" name="Avg"/>
           <p:cNvSpPr txBox="1"/>
           <p:nvPr/>
         </p:nvSpPr>
         <p:spPr>
           <a:xfrm>
-            <a:off x="10588752" y="3803904"/>
-            <a:ext cx="685800" cy="329184"/>
+            <a:off x="10588752" y="4123944"/>
+            <a:ext cx="685800" cy="256032"/>
           </a:xfrm>
           <a:prstGeom prst="rect">
             <a:avLst/>
@@ -17008,14 +17157,14 @@
       </p:sp>
       <p:sp>
         <p:nvSpPr>
-          <p:cNvPr id="1190" name="Metric"/>
+          <p:cNvPr id="1193" name="Metric"/>
           <p:cNvSpPr txBox="1"/>
           <p:nvPr/>
         </p:nvSpPr>
         <p:spPr>
           <a:xfrm>
-            <a:off x="1078992" y="4169664"/>
-            <a:ext cx="1417320" cy="658368"/>
+            <a:off x="1078992" y="4425696"/>
+            <a:ext cx="1417320" cy="512064"/>
           </a:xfrm>
           <a:prstGeom prst="rect">
             <a:avLst/>
@@ -17047,14 +17196,14 @@
       </p:sp>
       <p:sp>
         <p:nvSpPr>
-          <p:cNvPr id="1191" name="Method"/>
+          <p:cNvPr id="1194" name="Method"/>
           <p:cNvSpPr txBox="1"/>
           <p:nvPr/>
         </p:nvSpPr>
         <p:spPr>
           <a:xfrm>
-            <a:off x="2514600" y="4169664"/>
-            <a:ext cx="1280160" cy="329184"/>
+            <a:off x="2514600" y="4425696"/>
+            <a:ext cx="1280160" cy="256032"/>
           </a:xfrm>
           <a:prstGeom prst="rect">
             <a:avLst/>
@@ -17079,130 +17228,7 @@
                 <a:latin typeface="Calibri"/>
                 <a:cs typeface="Calibri"/>
               </a:rPr>
-              <a:t xml:space="preserve">Non-Iterative</a:t>
-            </a:r>
-          </a:p>
-        </p:txBody>
-      </p:sp>
-      <p:sp>
-        <p:nvSpPr>
-          <p:cNvPr id="1192" name="Cell"/>
-          <p:cNvSpPr/>
-          <p:nvPr/>
-        </p:nvSpPr>
-        <p:spPr>
-          <a:xfrm>
-            <a:off x="3813048" y="4187952"/>
-            <a:ext cx="713231" cy="292608"/>
-          </a:xfrm>
-          <a:prstGeom prst="rect">
-            <a:avLst/>
-          </a:prstGeom>
-          <a:solidFill>
-            <a:srgbClr val="EDB8AC"/>
-          </a:solidFill>
-          <a:ln>
-            <a:noFill/>
-          </a:ln>
-        </p:spPr>
-        <p:txBody>
-          <a:bodyPr wrap="square" lIns="0" tIns="0" rIns="0" bIns="0" anchor="ctr">
-            <a:noAutofit/>
-          </a:bodyPr>
-          <a:lstStyle/>
-          <a:p>
-            <a:pPr algn="ctr"/>
-            <a:r>
-              <a:rPr lang="en-US" sz="1100" b="0" i="0" dirty="0">
-                <a:solidFill>
-                  <a:srgbClr val="1F2328"/>
-                </a:solidFill>
-                <a:latin typeface="Calibri"/>
-                <a:cs typeface="Calibri"/>
-              </a:rPr>
-              <a:t xml:space="preserve">0</a:t>
-            </a:r>
-          </a:p>
-        </p:txBody>
-      </p:sp>
-      <p:sp>
-        <p:nvSpPr>
-          <p:cNvPr id="1193" name="Cell"/>
-          <p:cNvSpPr/>
-          <p:nvPr/>
-        </p:nvSpPr>
-        <p:spPr>
-          <a:xfrm>
-            <a:off x="4562856" y="4187952"/>
-            <a:ext cx="713231" cy="292608"/>
-          </a:xfrm>
-          <a:prstGeom prst="rect">
-            <a:avLst/>
-          </a:prstGeom>
-          <a:solidFill>
-            <a:srgbClr val="EDB8AC"/>
-          </a:solidFill>
-          <a:ln>
-            <a:noFill/>
-          </a:ln>
-        </p:spPr>
-        <p:txBody>
-          <a:bodyPr wrap="square" lIns="0" tIns="0" rIns="0" bIns="0" anchor="ctr">
-            <a:noAutofit/>
-          </a:bodyPr>
-          <a:lstStyle/>
-          <a:p>
-            <a:pPr algn="ctr"/>
-            <a:r>
-              <a:rPr lang="en-US" sz="1100" b="0" i="0" dirty="0">
-                <a:solidFill>
-                  <a:srgbClr val="1F2328"/>
-                </a:solidFill>
-                <a:latin typeface="Calibri"/>
-                <a:cs typeface="Calibri"/>
-              </a:rPr>
-              <a:t xml:space="preserve">0</a:t>
-            </a:r>
-          </a:p>
-        </p:txBody>
-      </p:sp>
-      <p:sp>
-        <p:nvSpPr>
-          <p:cNvPr id="1194" name="Cell"/>
-          <p:cNvSpPr/>
-          <p:nvPr/>
-        </p:nvSpPr>
-        <p:spPr>
-          <a:xfrm>
-            <a:off x="5312664" y="4187952"/>
-            <a:ext cx="713231" cy="292608"/>
-          </a:xfrm>
-          <a:prstGeom prst="rect">
-            <a:avLst/>
-          </a:prstGeom>
-          <a:solidFill>
-            <a:srgbClr val="EDB8AC"/>
-          </a:solidFill>
-          <a:ln>
-            <a:noFill/>
-          </a:ln>
-        </p:spPr>
-        <p:txBody>
-          <a:bodyPr wrap="square" lIns="0" tIns="0" rIns="0" bIns="0" anchor="ctr">
-            <a:noAutofit/>
-          </a:bodyPr>
-          <a:lstStyle/>
-          <a:p>
-            <a:pPr algn="ctr"/>
-            <a:r>
-              <a:rPr lang="en-US" sz="1100" b="0" i="0" dirty="0">
-                <a:solidFill>
-                  <a:srgbClr val="1F2328"/>
-                </a:solidFill>
-                <a:latin typeface="Calibri"/>
-                <a:cs typeface="Calibri"/>
-              </a:rPr>
-              <a:t xml:space="preserve">0</a:t>
+              <a:t xml:space="preserve">Non-Iterative RAG</a:t>
             </a:r>
           </a:p>
         </p:txBody>
@@ -17215,8 +17241,8 @@
         </p:nvSpPr>
         <p:spPr>
           <a:xfrm>
-            <a:off x="6062472" y="4187952"/>
-            <a:ext cx="713231" cy="292608"/>
+            <a:off x="3813048" y="4443984"/>
+            <a:ext cx="713231" cy="219456"/>
           </a:xfrm>
           <a:prstGeom prst="rect">
             <a:avLst/>
@@ -17256,8 +17282,8 @@
         </p:nvSpPr>
         <p:spPr>
           <a:xfrm>
-            <a:off x="6812279" y="4187952"/>
-            <a:ext cx="713231" cy="292608"/>
+            <a:off x="4562856" y="4443984"/>
+            <a:ext cx="713231" cy="219456"/>
           </a:xfrm>
           <a:prstGeom prst="rect">
             <a:avLst/>
@@ -17297,8 +17323,8 @@
         </p:nvSpPr>
         <p:spPr>
           <a:xfrm>
-            <a:off x="7562088" y="4187952"/>
-            <a:ext cx="713231" cy="292608"/>
+            <a:off x="5312664" y="4443984"/>
+            <a:ext cx="713231" cy="219456"/>
           </a:xfrm>
           <a:prstGeom prst="rect">
             <a:avLst/>
@@ -17338,8 +17364,8 @@
         </p:nvSpPr>
         <p:spPr>
           <a:xfrm>
-            <a:off x="8311896" y="4187952"/>
-            <a:ext cx="713231" cy="292608"/>
+            <a:off x="6062472" y="4443984"/>
+            <a:ext cx="713231" cy="219456"/>
           </a:xfrm>
           <a:prstGeom prst="rect">
             <a:avLst/>
@@ -17379,8 +17405,8 @@
         </p:nvSpPr>
         <p:spPr>
           <a:xfrm>
-            <a:off x="9061704" y="4187952"/>
-            <a:ext cx="713231" cy="292608"/>
+            <a:off x="6812279" y="4443984"/>
+            <a:ext cx="713231" cy="219456"/>
           </a:xfrm>
           <a:prstGeom prst="rect">
             <a:avLst/>
@@ -17420,8 +17446,8 @@
         </p:nvSpPr>
         <p:spPr>
           <a:xfrm>
-            <a:off x="9811512" y="4187952"/>
-            <a:ext cx="713231" cy="292608"/>
+            <a:off x="7562088" y="4443984"/>
+            <a:ext cx="713231" cy="219456"/>
           </a:xfrm>
           <a:prstGeom prst="rect">
             <a:avLst/>
@@ -17455,32 +17481,34 @@
       </p:sp>
       <p:sp>
         <p:nvSpPr>
-          <p:cNvPr id="1201" name="Avg"/>
-          <p:cNvSpPr txBox="1"/>
-          <p:nvPr/>
-        </p:nvSpPr>
-        <p:spPr>
-          <a:xfrm>
-            <a:off x="10588752" y="4169664"/>
-            <a:ext cx="685800" cy="329184"/>
-          </a:xfrm>
-          <a:prstGeom prst="rect">
-            <a:avLst/>
-          </a:prstGeom>
-          <a:noFill/>
-          <a:ln>
-            <a:noFill/>
-          </a:ln>
-        </p:spPr>
-        <p:txBody>
-          <a:bodyPr wrap="square" lIns="0" tIns="0" rIns="0" bIns="0" anchor="ctr">
-            <a:noAutofit/>
-          </a:bodyPr>
-          <a:lstStyle/>
-          <a:p>
-            <a:pPr algn="ctr"/>
-            <a:r>
-              <a:rPr lang="en-US" sz="1250" b="0" i="0" dirty="0">
+          <p:cNvPr id="1201" name="Cell"/>
+          <p:cNvSpPr/>
+          <p:nvPr/>
+        </p:nvSpPr>
+        <p:spPr>
+          <a:xfrm>
+            <a:off x="8311896" y="4443984"/>
+            <a:ext cx="713231" cy="219456"/>
+          </a:xfrm>
+          <a:prstGeom prst="rect">
+            <a:avLst/>
+          </a:prstGeom>
+          <a:solidFill>
+            <a:srgbClr val="EDB8AC"/>
+          </a:solidFill>
+          <a:ln>
+            <a:noFill/>
+          </a:ln>
+        </p:spPr>
+        <p:txBody>
+          <a:bodyPr wrap="square" lIns="0" tIns="0" rIns="0" bIns="0" anchor="ctr">
+            <a:noAutofit/>
+          </a:bodyPr>
+          <a:lstStyle/>
+          <a:p>
+            <a:pPr algn="ctr"/>
+            <a:r>
+              <a:rPr lang="en-US" sz="1100" b="0" i="0" dirty="0">
                 <a:solidFill>
                   <a:srgbClr val="1F2328"/>
                 </a:solidFill>
@@ -17494,39 +17522,41 @@
       </p:sp>
       <p:sp>
         <p:nvSpPr>
-          <p:cNvPr id="1202" name="Method"/>
-          <p:cNvSpPr txBox="1"/>
-          <p:nvPr/>
-        </p:nvSpPr>
-        <p:spPr>
-          <a:xfrm>
-            <a:off x="2514600" y="4498848"/>
-            <a:ext cx="1280160" cy="329184"/>
-          </a:xfrm>
-          <a:prstGeom prst="rect">
-            <a:avLst/>
-          </a:prstGeom>
-          <a:noFill/>
-          <a:ln>
-            <a:noFill/>
-          </a:ln>
-        </p:spPr>
-        <p:txBody>
-          <a:bodyPr wrap="square" lIns="0" tIns="0" rIns="0" bIns="0" anchor="ctr">
-            <a:noAutofit/>
-          </a:bodyPr>
-          <a:lstStyle/>
-          <a:p>
-            <a:pPr algn="l"/>
-            <a:r>
-              <a:rPr lang="en-US" sz="1200" b="1" i="0" dirty="0">
-                <a:solidFill>
-                  <a:srgbClr val="0B6E4F"/>
-                </a:solidFill>
-                <a:latin typeface="Calibri"/>
-                <a:cs typeface="Calibri"/>
-              </a:rPr>
-              <a:t xml:space="preserve">RIGOR</a:t>
+          <p:cNvPr id="1202" name="Cell"/>
+          <p:cNvSpPr/>
+          <p:nvPr/>
+        </p:nvSpPr>
+        <p:spPr>
+          <a:xfrm>
+            <a:off x="9061704" y="4443984"/>
+            <a:ext cx="713231" cy="219456"/>
+          </a:xfrm>
+          <a:prstGeom prst="rect">
+            <a:avLst/>
+          </a:prstGeom>
+          <a:solidFill>
+            <a:srgbClr val="EDB8AC"/>
+          </a:solidFill>
+          <a:ln>
+            <a:noFill/>
+          </a:ln>
+        </p:spPr>
+        <p:txBody>
+          <a:bodyPr wrap="square" lIns="0" tIns="0" rIns="0" bIns="0" anchor="ctr">
+            <a:noAutofit/>
+          </a:bodyPr>
+          <a:lstStyle/>
+          <a:p>
+            <a:pPr algn="ctr"/>
+            <a:r>
+              <a:rPr lang="en-US" sz="1100" b="0" i="0" dirty="0">
+                <a:solidFill>
+                  <a:srgbClr val="1F2328"/>
+                </a:solidFill>
+                <a:latin typeface="Calibri"/>
+                <a:cs typeface="Calibri"/>
+              </a:rPr>
+              <a:t xml:space="preserve">0</a:t>
             </a:r>
           </a:p>
         </p:txBody>
@@ -17539,117 +17569,113 @@
         </p:nvSpPr>
         <p:spPr>
           <a:xfrm>
-            <a:off x="3813048" y="4517136"/>
-            <a:ext cx="713231" cy="292608"/>
-          </a:xfrm>
-          <a:prstGeom prst="rect">
-            <a:avLst/>
-          </a:prstGeom>
-          <a:solidFill>
-            <a:srgbClr val="BFE3CF"/>
-          </a:solidFill>
-          <a:ln>
-            <a:noFill/>
-          </a:ln>
-        </p:spPr>
-        <p:txBody>
-          <a:bodyPr wrap="square" lIns="0" tIns="0" rIns="0" bIns="0" anchor="ctr">
-            <a:noAutofit/>
-          </a:bodyPr>
-          <a:lstStyle/>
-          <a:p>
-            <a:pPr algn="ctr"/>
-            <a:r>
-              <a:rPr lang="en-US" sz="1100" b="1" i="0" dirty="0">
-                <a:solidFill>
-                  <a:srgbClr val="1F2328"/>
-                </a:solidFill>
-                <a:latin typeface="Calibri"/>
-                <a:cs typeface="Calibri"/>
-              </a:rPr>
-              <a:t xml:space="preserve">336</a:t>
-            </a:r>
-          </a:p>
-        </p:txBody>
-      </p:sp>
-      <p:sp>
-        <p:nvSpPr>
-          <p:cNvPr id="1204" name="Cell"/>
-          <p:cNvSpPr/>
-          <p:nvPr/>
-        </p:nvSpPr>
-        <p:spPr>
-          <a:xfrm>
-            <a:off x="4562856" y="4517136"/>
-            <a:ext cx="713231" cy="292608"/>
-          </a:xfrm>
-          <a:prstGeom prst="rect">
-            <a:avLst/>
-          </a:prstGeom>
-          <a:solidFill>
-            <a:srgbClr val="BFE3CF"/>
-          </a:solidFill>
-          <a:ln>
-            <a:noFill/>
-          </a:ln>
-        </p:spPr>
-        <p:txBody>
-          <a:bodyPr wrap="square" lIns="0" tIns="0" rIns="0" bIns="0" anchor="ctr">
-            <a:noAutofit/>
-          </a:bodyPr>
-          <a:lstStyle/>
-          <a:p>
-            <a:pPr algn="ctr"/>
-            <a:r>
-              <a:rPr lang="en-US" sz="1100" b="1" i="0" dirty="0">
-                <a:solidFill>
-                  <a:srgbClr val="1F2328"/>
-                </a:solidFill>
-                <a:latin typeface="Calibri"/>
-                <a:cs typeface="Calibri"/>
-              </a:rPr>
-              <a:t xml:space="preserve">308</a:t>
-            </a:r>
-          </a:p>
-        </p:txBody>
-      </p:sp>
-      <p:sp>
-        <p:nvSpPr>
-          <p:cNvPr id="1205" name="Cell"/>
-          <p:cNvSpPr/>
-          <p:nvPr/>
-        </p:nvSpPr>
-        <p:spPr>
-          <a:xfrm>
-            <a:off x="5312664" y="4517136"/>
-            <a:ext cx="713231" cy="292608"/>
-          </a:xfrm>
-          <a:prstGeom prst="rect">
-            <a:avLst/>
-          </a:prstGeom>
-          <a:solidFill>
-            <a:srgbClr val="F6DAD3"/>
-          </a:solidFill>
-          <a:ln>
-            <a:noFill/>
-          </a:ln>
-        </p:spPr>
-        <p:txBody>
-          <a:bodyPr wrap="square" lIns="0" tIns="0" rIns="0" bIns="0" anchor="ctr">
-            <a:noAutofit/>
-          </a:bodyPr>
-          <a:lstStyle/>
-          <a:p>
-            <a:pPr algn="ctr"/>
-            <a:r>
-              <a:rPr lang="en-US" sz="1100" b="1" i="0" dirty="0">
-                <a:solidFill>
-                  <a:srgbClr val="1F2328"/>
-                </a:solidFill>
-                <a:latin typeface="Calibri"/>
-                <a:cs typeface="Calibri"/>
-              </a:rPr>
-              <a:t xml:space="preserve">22</a:t>
+            <a:off x="9811512" y="4443984"/>
+            <a:ext cx="713231" cy="219456"/>
+          </a:xfrm>
+          <a:prstGeom prst="rect">
+            <a:avLst/>
+          </a:prstGeom>
+          <a:solidFill>
+            <a:srgbClr val="EDB8AC"/>
+          </a:solidFill>
+          <a:ln>
+            <a:noFill/>
+          </a:ln>
+        </p:spPr>
+        <p:txBody>
+          <a:bodyPr wrap="square" lIns="0" tIns="0" rIns="0" bIns="0" anchor="ctr">
+            <a:noAutofit/>
+          </a:bodyPr>
+          <a:lstStyle/>
+          <a:p>
+            <a:pPr algn="ctr"/>
+            <a:r>
+              <a:rPr lang="en-US" sz="1100" b="0" i="0" dirty="0">
+                <a:solidFill>
+                  <a:srgbClr val="1F2328"/>
+                </a:solidFill>
+                <a:latin typeface="Calibri"/>
+                <a:cs typeface="Calibri"/>
+              </a:rPr>
+              <a:t xml:space="preserve">0</a:t>
+            </a:r>
+          </a:p>
+        </p:txBody>
+      </p:sp>
+      <p:sp>
+        <p:nvSpPr>
+          <p:cNvPr id="1204" name="Avg"/>
+          <p:cNvSpPr txBox="1"/>
+          <p:nvPr/>
+        </p:nvSpPr>
+        <p:spPr>
+          <a:xfrm>
+            <a:off x="10588752" y="4425696"/>
+            <a:ext cx="685800" cy="256032"/>
+          </a:xfrm>
+          <a:prstGeom prst="rect">
+            <a:avLst/>
+          </a:prstGeom>
+          <a:noFill/>
+          <a:ln>
+            <a:noFill/>
+          </a:ln>
+        </p:spPr>
+        <p:txBody>
+          <a:bodyPr wrap="square" lIns="0" tIns="0" rIns="0" bIns="0" anchor="ctr">
+            <a:noAutofit/>
+          </a:bodyPr>
+          <a:lstStyle/>
+          <a:p>
+            <a:pPr algn="ctr"/>
+            <a:r>
+              <a:rPr lang="en-US" sz="1250" b="0" i="0" dirty="0">
+                <a:solidFill>
+                  <a:srgbClr val="1F2328"/>
+                </a:solidFill>
+                <a:latin typeface="Calibri"/>
+                <a:cs typeface="Calibri"/>
+              </a:rPr>
+              <a:t xml:space="preserve">0</a:t>
+            </a:r>
+          </a:p>
+        </p:txBody>
+      </p:sp>
+      <p:sp>
+        <p:nvSpPr>
+          <p:cNvPr id="1205" name="Method"/>
+          <p:cNvSpPr txBox="1"/>
+          <p:nvPr/>
+        </p:nvSpPr>
+        <p:spPr>
+          <a:xfrm>
+            <a:off x="2514600" y="4681728"/>
+            <a:ext cx="1280160" cy="256032"/>
+          </a:xfrm>
+          <a:prstGeom prst="rect">
+            <a:avLst/>
+          </a:prstGeom>
+          <a:noFill/>
+          <a:ln>
+            <a:noFill/>
+          </a:ln>
+        </p:spPr>
+        <p:txBody>
+          <a:bodyPr wrap="square" lIns="0" tIns="0" rIns="0" bIns="0" anchor="ctr">
+            <a:noAutofit/>
+          </a:bodyPr>
+          <a:lstStyle/>
+          <a:p>
+            <a:pPr algn="l"/>
+            <a:r>
+              <a:rPr lang="en-US" sz="1200" b="1" i="0" dirty="0">
+                <a:solidFill>
+                  <a:srgbClr val="0B6E4F"/>
+                </a:solidFill>
+                <a:latin typeface="Calibri"/>
+                <a:cs typeface="Calibri"/>
+              </a:rPr>
+              <a:t xml:space="preserve">RIGOR</a:t>
             </a:r>
           </a:p>
         </p:txBody>
@@ -17662,8 +17688,8 @@
         </p:nvSpPr>
         <p:spPr>
           <a:xfrm>
-            <a:off x="6062472" y="4517136"/>
-            <a:ext cx="713231" cy="292608"/>
+            <a:off x="3813048" y="4700016"/>
+            <a:ext cx="713231" cy="219456"/>
           </a:xfrm>
           <a:prstGeom prst="rect">
             <a:avLst/>
@@ -17690,7 +17716,7 @@
                 <a:latin typeface="Calibri"/>
                 <a:cs typeface="Calibri"/>
               </a:rPr>
-              <a:t xml:space="preserve">423</a:t>
+              <a:t xml:space="preserve">336</a:t>
             </a:r>
           </a:p>
         </p:txBody>
@@ -17703,8 +17729,8 @@
         </p:nvSpPr>
         <p:spPr>
           <a:xfrm>
-            <a:off x="6812279" y="4517136"/>
-            <a:ext cx="713231" cy="292608"/>
+            <a:off x="4562856" y="4700016"/>
+            <a:ext cx="713231" cy="219456"/>
           </a:xfrm>
           <a:prstGeom prst="rect">
             <a:avLst/>
@@ -17731,7 +17757,7 @@
                 <a:latin typeface="Calibri"/>
                 <a:cs typeface="Calibri"/>
               </a:rPr>
-              <a:t xml:space="preserve">335</a:t>
+              <a:t xml:space="preserve">308</a:t>
             </a:r>
           </a:p>
         </p:txBody>
@@ -17744,14 +17770,14 @@
         </p:nvSpPr>
         <p:spPr>
           <a:xfrm>
-            <a:off x="7562088" y="4517136"/>
-            <a:ext cx="713231" cy="292608"/>
-          </a:xfrm>
-          <a:prstGeom prst="rect">
-            <a:avLst/>
-          </a:prstGeom>
-          <a:solidFill>
-            <a:srgbClr val="DDF0E5"/>
+            <a:off x="5312664" y="4700016"/>
+            <a:ext cx="713231" cy="219456"/>
+          </a:xfrm>
+          <a:prstGeom prst="rect">
+            <a:avLst/>
+          </a:prstGeom>
+          <a:solidFill>
+            <a:srgbClr val="F6DAD3"/>
           </a:solidFill>
           <a:ln>
             <a:noFill/>
@@ -17772,7 +17798,7 @@
                 <a:latin typeface="Calibri"/>
                 <a:cs typeface="Calibri"/>
               </a:rPr>
-              <a:t xml:space="preserve">99</a:t>
+              <a:t xml:space="preserve">22</a:t>
             </a:r>
           </a:p>
         </p:txBody>
@@ -17785,14 +17811,14 @@
         </p:nvSpPr>
         <p:spPr>
           <a:xfrm>
-            <a:off x="8311896" y="4517136"/>
-            <a:ext cx="713231" cy="292608"/>
-          </a:xfrm>
-          <a:prstGeom prst="rect">
-            <a:avLst/>
-          </a:prstGeom>
-          <a:solidFill>
-            <a:srgbClr val="DDF0E5"/>
+            <a:off x="6062472" y="4700016"/>
+            <a:ext cx="713231" cy="219456"/>
+          </a:xfrm>
+          <a:prstGeom prst="rect">
+            <a:avLst/>
+          </a:prstGeom>
+          <a:solidFill>
+            <a:srgbClr val="BFE3CF"/>
           </a:solidFill>
           <a:ln>
             <a:noFill/>
@@ -17813,7 +17839,7 @@
                 <a:latin typeface="Calibri"/>
                 <a:cs typeface="Calibri"/>
               </a:rPr>
-              <a:t xml:space="preserve">81</a:t>
+              <a:t xml:space="preserve">423</a:t>
             </a:r>
           </a:p>
         </p:txBody>
@@ -17826,14 +17852,14 @@
         </p:nvSpPr>
         <p:spPr>
           <a:xfrm>
-            <a:off x="9061704" y="4517136"/>
-            <a:ext cx="713231" cy="292608"/>
-          </a:xfrm>
-          <a:prstGeom prst="rect">
-            <a:avLst/>
-          </a:prstGeom>
-          <a:solidFill>
-            <a:srgbClr val="DDF0E5"/>
+            <a:off x="6812279" y="4700016"/>
+            <a:ext cx="713231" cy="219456"/>
+          </a:xfrm>
+          <a:prstGeom prst="rect">
+            <a:avLst/>
+          </a:prstGeom>
+          <a:solidFill>
+            <a:srgbClr val="BFE3CF"/>
           </a:solidFill>
           <a:ln>
             <a:noFill/>
@@ -17854,7 +17880,7 @@
                 <a:latin typeface="Calibri"/>
                 <a:cs typeface="Calibri"/>
               </a:rPr>
-              <a:t xml:space="preserve">83</a:t>
+              <a:t xml:space="preserve">335</a:t>
             </a:r>
           </a:p>
         </p:txBody>
@@ -17867,14 +17893,14 @@
         </p:nvSpPr>
         <p:spPr>
           <a:xfrm>
-            <a:off x="9811512" y="4517136"/>
-            <a:ext cx="713231" cy="292608"/>
-          </a:xfrm>
-          <a:prstGeom prst="rect">
-            <a:avLst/>
-          </a:prstGeom>
-          <a:solidFill>
-            <a:srgbClr val="F1F3F2"/>
+            <a:off x="7562088" y="4700016"/>
+            <a:ext cx="713231" cy="219456"/>
+          </a:xfrm>
+          <a:prstGeom prst="rect">
+            <a:avLst/>
+          </a:prstGeom>
+          <a:solidFill>
+            <a:srgbClr val="F6DAD3"/>
           </a:solidFill>
           <a:ln>
             <a:noFill/>
@@ -17895,6 +17921,129 @@
                 <a:latin typeface="Calibri"/>
                 <a:cs typeface="Calibri"/>
               </a:rPr>
+              <a:t xml:space="preserve">99</a:t>
+            </a:r>
+          </a:p>
+        </p:txBody>
+      </p:sp>
+      <p:sp>
+        <p:nvSpPr>
+          <p:cNvPr id="1212" name="Cell"/>
+          <p:cNvSpPr/>
+          <p:nvPr/>
+        </p:nvSpPr>
+        <p:spPr>
+          <a:xfrm>
+            <a:off x="8311896" y="4700016"/>
+            <a:ext cx="713231" cy="219456"/>
+          </a:xfrm>
+          <a:prstGeom prst="rect">
+            <a:avLst/>
+          </a:prstGeom>
+          <a:solidFill>
+            <a:srgbClr val="BFE3CF"/>
+          </a:solidFill>
+          <a:ln>
+            <a:noFill/>
+          </a:ln>
+        </p:spPr>
+        <p:txBody>
+          <a:bodyPr wrap="square" lIns="0" tIns="0" rIns="0" bIns="0" anchor="ctr">
+            <a:noAutofit/>
+          </a:bodyPr>
+          <a:lstStyle/>
+          <a:p>
+            <a:pPr algn="ctr"/>
+            <a:r>
+              <a:rPr lang="en-US" sz="1100" b="1" i="0" dirty="0">
+                <a:solidFill>
+                  <a:srgbClr val="1F2328"/>
+                </a:solidFill>
+                <a:latin typeface="Calibri"/>
+                <a:cs typeface="Calibri"/>
+              </a:rPr>
+              <a:t xml:space="preserve">81</a:t>
+            </a:r>
+          </a:p>
+        </p:txBody>
+      </p:sp>
+      <p:sp>
+        <p:nvSpPr>
+          <p:cNvPr id="1213" name="Cell"/>
+          <p:cNvSpPr/>
+          <p:nvPr/>
+        </p:nvSpPr>
+        <p:spPr>
+          <a:xfrm>
+            <a:off x="9061704" y="4700016"/>
+            <a:ext cx="713231" cy="219456"/>
+          </a:xfrm>
+          <a:prstGeom prst="rect">
+            <a:avLst/>
+          </a:prstGeom>
+          <a:solidFill>
+            <a:srgbClr val="BFE3CF"/>
+          </a:solidFill>
+          <a:ln>
+            <a:noFill/>
+          </a:ln>
+        </p:spPr>
+        <p:txBody>
+          <a:bodyPr wrap="square" lIns="0" tIns="0" rIns="0" bIns="0" anchor="ctr">
+            <a:noAutofit/>
+          </a:bodyPr>
+          <a:lstStyle/>
+          <a:p>
+            <a:pPr algn="ctr"/>
+            <a:r>
+              <a:rPr lang="en-US" sz="1100" b="1" i="0" dirty="0">
+                <a:solidFill>
+                  <a:srgbClr val="1F2328"/>
+                </a:solidFill>
+                <a:latin typeface="Calibri"/>
+                <a:cs typeface="Calibri"/>
+              </a:rPr>
+              <a:t xml:space="preserve">83</a:t>
+            </a:r>
+          </a:p>
+        </p:txBody>
+      </p:sp>
+      <p:sp>
+        <p:nvSpPr>
+          <p:cNvPr id="1214" name="Cell"/>
+          <p:cNvSpPr/>
+          <p:nvPr/>
+        </p:nvSpPr>
+        <p:spPr>
+          <a:xfrm>
+            <a:off x="9811512" y="4700016"/>
+            <a:ext cx="713231" cy="219456"/>
+          </a:xfrm>
+          <a:prstGeom prst="rect">
+            <a:avLst/>
+          </a:prstGeom>
+          <a:solidFill>
+            <a:srgbClr val="BFE3CF"/>
+          </a:solidFill>
+          <a:ln>
+            <a:noFill/>
+          </a:ln>
+        </p:spPr>
+        <p:txBody>
+          <a:bodyPr wrap="square" lIns="0" tIns="0" rIns="0" bIns="0" anchor="ctr">
+            <a:noAutofit/>
+          </a:bodyPr>
+          <a:lstStyle/>
+          <a:p>
+            <a:pPr algn="ctr"/>
+            <a:r>
+              <a:rPr lang="en-US" sz="1100" b="1" i="0" dirty="0">
+                <a:solidFill>
+                  <a:srgbClr val="1F2328"/>
+                </a:solidFill>
+                <a:latin typeface="Calibri"/>
+                <a:cs typeface="Calibri"/>
+              </a:rPr>
               <a:t xml:space="preserve">75</a:t>
             </a:r>
           </a:p>
@@ -17902,14 +18051,14 @@
       </p:sp>
       <p:sp>
         <p:nvSpPr>
-          <p:cNvPr id="1212" name="Avg"/>
+          <p:cNvPr id="1215" name="Avg"/>
           <p:cNvSpPr txBox="1"/>
           <p:nvPr/>
         </p:nvSpPr>
         <p:spPr>
           <a:xfrm>
-            <a:off x="10588752" y="4498848"/>
-            <a:ext cx="685800" cy="329184"/>
+            <a:off x="10588752" y="4681728"/>
+            <a:ext cx="685800" cy="256032"/>
           </a:xfrm>
           <a:prstGeom prst="rect">
             <a:avLst/>
@@ -17941,14 +18090,14 @@
       </p:sp>
       <p:sp>
         <p:nvSpPr>
-          <p:cNvPr id="1213" name="Metric"/>
+          <p:cNvPr id="1216" name="Metric"/>
           <p:cNvSpPr txBox="1"/>
           <p:nvPr/>
         </p:nvSpPr>
         <p:spPr>
           <a:xfrm>
-            <a:off x="1078992" y="4864608"/>
-            <a:ext cx="1417320" cy="658368"/>
+            <a:off x="1078992" y="5001768"/>
+            <a:ext cx="1417320" cy="237744"/>
           </a:xfrm>
           <a:prstGeom prst="rect">
             <a:avLst/>
@@ -17973,21 +18122,21 @@
                 <a:latin typeface="Calibri"/>
                 <a:cs typeface="Calibri"/>
               </a:rPr>
-              <a:t xml:space="preserve">Subclass axioms</a:t>
-            </a:r>
-          </a:p>
-        </p:txBody>
-      </p:sp>
-      <p:sp>
-        <p:nvSpPr>
-          <p:cNvPr id="1214" name="Method"/>
+              <a:t xml:space="preserve">Class hierarchy</a:t>
+            </a:r>
+          </a:p>
+        </p:txBody>
+      </p:sp>
+      <p:sp>
+        <p:nvSpPr>
+          <p:cNvPr id="1217" name="Metric note"/>
           <p:cNvSpPr txBox="1"/>
           <p:nvPr/>
         </p:nvSpPr>
         <p:spPr>
           <a:xfrm>
-            <a:off x="2514600" y="4864608"/>
-            <a:ext cx="1280160" cy="329184"/>
+            <a:off x="1078992" y="5239512"/>
+            <a:ext cx="1417320" cy="219456"/>
           </a:xfrm>
           <a:prstGeom prst="rect">
             <a:avLst/>
@@ -18005,6 +18154,45 @@
           <a:p>
             <a:pPr algn="l"/>
             <a:r>
+              <a:rPr lang="en-US" sz="950" b="0" i="1" dirty="0">
+                <a:solidFill>
+                  <a:srgbClr val="5B6770"/>
+                </a:solidFill>
+                <a:latin typeface="Calibri"/>
+                <a:cs typeface="Calibri"/>
+              </a:rPr>
+              <a:t xml:space="preserve">inheritance richness</a:t>
+            </a:r>
+          </a:p>
+        </p:txBody>
+      </p:sp>
+      <p:sp>
+        <p:nvSpPr>
+          <p:cNvPr id="1218" name="Method"/>
+          <p:cNvSpPr txBox="1"/>
+          <p:nvPr/>
+        </p:nvSpPr>
+        <p:spPr>
+          <a:xfrm>
+            <a:off x="2514600" y="4983480"/>
+            <a:ext cx="1280160" cy="256032"/>
+          </a:xfrm>
+          <a:prstGeom prst="rect">
+            <a:avLst/>
+          </a:prstGeom>
+          <a:noFill/>
+          <a:ln>
+            <a:noFill/>
+          </a:ln>
+        </p:spPr>
+        <p:txBody>
+          <a:bodyPr wrap="square" lIns="0" tIns="0" rIns="0" bIns="0" anchor="ctr">
+            <a:noAutofit/>
+          </a:bodyPr>
+          <a:lstStyle/>
+          <a:p>
+            <a:pPr algn="l"/>
+            <a:r>
               <a:rPr lang="en-US" sz="1200" b="0" i="0" dirty="0">
                 <a:solidFill>
                   <a:srgbClr val="1F2328"/>
@@ -18012,171 +18200,7 @@
                 <a:latin typeface="Calibri"/>
                 <a:cs typeface="Calibri"/>
               </a:rPr>
-              <a:t xml:space="preserve">Non-Iterative</a:t>
-            </a:r>
-          </a:p>
-        </p:txBody>
-      </p:sp>
-      <p:sp>
-        <p:nvSpPr>
-          <p:cNvPr id="1215" name="Cell"/>
-          <p:cNvSpPr/>
-          <p:nvPr/>
-        </p:nvSpPr>
-        <p:spPr>
-          <a:xfrm>
-            <a:off x="3813048" y="4882896"/>
-            <a:ext cx="713231" cy="292608"/>
-          </a:xfrm>
-          <a:prstGeom prst="rect">
-            <a:avLst/>
-          </a:prstGeom>
-          <a:solidFill>
-            <a:srgbClr val="EDB8AC"/>
-          </a:solidFill>
-          <a:ln>
-            <a:noFill/>
-          </a:ln>
-        </p:spPr>
-        <p:txBody>
-          <a:bodyPr wrap="square" lIns="0" tIns="0" rIns="0" bIns="0" anchor="ctr">
-            <a:noAutofit/>
-          </a:bodyPr>
-          <a:lstStyle/>
-          <a:p>
-            <a:pPr algn="ctr"/>
-            <a:r>
-              <a:rPr lang="en-US" sz="1100" b="0" i="0" dirty="0">
-                <a:solidFill>
-                  <a:srgbClr val="1F2328"/>
-                </a:solidFill>
-                <a:latin typeface="Calibri"/>
-                <a:cs typeface="Calibri"/>
-              </a:rPr>
-              <a:t xml:space="preserve">0</a:t>
-            </a:r>
-          </a:p>
-        </p:txBody>
-      </p:sp>
-      <p:sp>
-        <p:nvSpPr>
-          <p:cNvPr id="1216" name="Cell"/>
-          <p:cNvSpPr/>
-          <p:nvPr/>
-        </p:nvSpPr>
-        <p:spPr>
-          <a:xfrm>
-            <a:off x="4562856" y="4882896"/>
-            <a:ext cx="713231" cy="292608"/>
-          </a:xfrm>
-          <a:prstGeom prst="rect">
-            <a:avLst/>
-          </a:prstGeom>
-          <a:solidFill>
-            <a:srgbClr val="EDB8AC"/>
-          </a:solidFill>
-          <a:ln>
-            <a:noFill/>
-          </a:ln>
-        </p:spPr>
-        <p:txBody>
-          <a:bodyPr wrap="square" lIns="0" tIns="0" rIns="0" bIns="0" anchor="ctr">
-            <a:noAutofit/>
-          </a:bodyPr>
-          <a:lstStyle/>
-          <a:p>
-            <a:pPr algn="ctr"/>
-            <a:r>
-              <a:rPr lang="en-US" sz="1100" b="0" i="0" dirty="0">
-                <a:solidFill>
-                  <a:srgbClr val="1F2328"/>
-                </a:solidFill>
-                <a:latin typeface="Calibri"/>
-                <a:cs typeface="Calibri"/>
-              </a:rPr>
-              <a:t xml:space="preserve">0</a:t>
-            </a:r>
-          </a:p>
-        </p:txBody>
-      </p:sp>
-      <p:sp>
-        <p:nvSpPr>
-          <p:cNvPr id="1217" name="Cell"/>
-          <p:cNvSpPr/>
-          <p:nvPr/>
-        </p:nvSpPr>
-        <p:spPr>
-          <a:xfrm>
-            <a:off x="5312664" y="4882896"/>
-            <a:ext cx="713231" cy="292608"/>
-          </a:xfrm>
-          <a:prstGeom prst="rect">
-            <a:avLst/>
-          </a:prstGeom>
-          <a:solidFill>
-            <a:srgbClr val="EDB8AC"/>
-          </a:solidFill>
-          <a:ln>
-            <a:noFill/>
-          </a:ln>
-        </p:spPr>
-        <p:txBody>
-          <a:bodyPr wrap="square" lIns="0" tIns="0" rIns="0" bIns="0" anchor="ctr">
-            <a:noAutofit/>
-          </a:bodyPr>
-          <a:lstStyle/>
-          <a:p>
-            <a:pPr algn="ctr"/>
-            <a:r>
-              <a:rPr lang="en-US" sz="1100" b="0" i="0" dirty="0">
-                <a:solidFill>
-                  <a:srgbClr val="1F2328"/>
-                </a:solidFill>
-                <a:latin typeface="Calibri"/>
-                <a:cs typeface="Calibri"/>
-              </a:rPr>
-              <a:t xml:space="preserve">0</a:t>
-            </a:r>
-          </a:p>
-        </p:txBody>
-      </p:sp>
-      <p:sp>
-        <p:nvSpPr>
-          <p:cNvPr id="1218" name="Cell"/>
-          <p:cNvSpPr/>
-          <p:nvPr/>
-        </p:nvSpPr>
-        <p:spPr>
-          <a:xfrm>
-            <a:off x="6062472" y="4882896"/>
-            <a:ext cx="713231" cy="292608"/>
-          </a:xfrm>
-          <a:prstGeom prst="rect">
-            <a:avLst/>
-          </a:prstGeom>
-          <a:solidFill>
-            <a:srgbClr val="EDB8AC"/>
-          </a:solidFill>
-          <a:ln>
-            <a:noFill/>
-          </a:ln>
-        </p:spPr>
-        <p:txBody>
-          <a:bodyPr wrap="square" lIns="0" tIns="0" rIns="0" bIns="0" anchor="ctr">
-            <a:noAutofit/>
-          </a:bodyPr>
-          <a:lstStyle/>
-          <a:p>
-            <a:pPr algn="ctr"/>
-            <a:r>
-              <a:rPr lang="en-US" sz="1100" b="0" i="0" dirty="0">
-                <a:solidFill>
-                  <a:srgbClr val="1F2328"/>
-                </a:solidFill>
-                <a:latin typeface="Calibri"/>
-                <a:cs typeface="Calibri"/>
-              </a:rPr>
-              <a:t xml:space="preserve">0</a:t>
+              <a:t xml:space="preserve">Non-Iterative RAG</a:t>
             </a:r>
           </a:p>
         </p:txBody>
@@ -18189,8 +18213,8 @@
         </p:nvSpPr>
         <p:spPr>
           <a:xfrm>
-            <a:off x="6812279" y="4882896"/>
-            <a:ext cx="713231" cy="292608"/>
+            <a:off x="3813048" y="5001768"/>
+            <a:ext cx="713231" cy="219456"/>
           </a:xfrm>
           <a:prstGeom prst="rect">
             <a:avLst/>
@@ -18217,7 +18241,7 @@
                 <a:latin typeface="Calibri"/>
                 <a:cs typeface="Calibri"/>
               </a:rPr>
-              <a:t xml:space="preserve">0</a:t>
+              <a:t xml:space="preserve">0.00</a:t>
             </a:r>
           </a:p>
         </p:txBody>
@@ -18230,8 +18254,8 @@
         </p:nvSpPr>
         <p:spPr>
           <a:xfrm>
-            <a:off x="7562088" y="4882896"/>
-            <a:ext cx="713231" cy="292608"/>
+            <a:off x="4562856" y="5001768"/>
+            <a:ext cx="713231" cy="219456"/>
           </a:xfrm>
           <a:prstGeom prst="rect">
             <a:avLst/>
@@ -18258,7 +18282,7 @@
                 <a:latin typeface="Calibri"/>
                 <a:cs typeface="Calibri"/>
               </a:rPr>
-              <a:t xml:space="preserve">0</a:t>
+              <a:t xml:space="preserve">0.00</a:t>
             </a:r>
           </a:p>
         </p:txBody>
@@ -18271,8 +18295,8 @@
         </p:nvSpPr>
         <p:spPr>
           <a:xfrm>
-            <a:off x="8311896" y="4882896"/>
-            <a:ext cx="713231" cy="292608"/>
+            <a:off x="5312664" y="5001768"/>
+            <a:ext cx="713231" cy="219456"/>
           </a:xfrm>
           <a:prstGeom prst="rect">
             <a:avLst/>
@@ -18299,7 +18323,7 @@
                 <a:latin typeface="Calibri"/>
                 <a:cs typeface="Calibri"/>
               </a:rPr>
-              <a:t xml:space="preserve">0</a:t>
+              <a:t xml:space="preserve">0.00</a:t>
             </a:r>
           </a:p>
         </p:txBody>
@@ -18312,8 +18336,8 @@
         </p:nvSpPr>
         <p:spPr>
           <a:xfrm>
-            <a:off x="9061704" y="4882896"/>
-            <a:ext cx="713231" cy="292608"/>
+            <a:off x="6062472" y="5001768"/>
+            <a:ext cx="713231" cy="219456"/>
           </a:xfrm>
           <a:prstGeom prst="rect">
             <a:avLst/>
@@ -18340,7 +18364,7 @@
                 <a:latin typeface="Calibri"/>
                 <a:cs typeface="Calibri"/>
               </a:rPr>
-              <a:t xml:space="preserve">0</a:t>
+              <a:t xml:space="preserve">0.00</a:t>
             </a:r>
           </a:p>
         </p:txBody>
@@ -18353,8 +18377,8 @@
         </p:nvSpPr>
         <p:spPr>
           <a:xfrm>
-            <a:off x="9811512" y="4882896"/>
-            <a:ext cx="713231" cy="292608"/>
+            <a:off x="6812279" y="5001768"/>
+            <a:ext cx="713231" cy="219456"/>
           </a:xfrm>
           <a:prstGeom prst="rect">
             <a:avLst/>
@@ -18381,85 +18405,89 @@
                 <a:latin typeface="Calibri"/>
                 <a:cs typeface="Calibri"/>
               </a:rPr>
-              <a:t xml:space="preserve">0</a:t>
-            </a:r>
-          </a:p>
-        </p:txBody>
-      </p:sp>
-      <p:sp>
-        <p:nvSpPr>
-          <p:cNvPr id="1224" name="Avg"/>
-          <p:cNvSpPr txBox="1"/>
-          <p:nvPr/>
-        </p:nvSpPr>
-        <p:spPr>
-          <a:xfrm>
-            <a:off x="10588752" y="4864608"/>
-            <a:ext cx="685800" cy="329184"/>
-          </a:xfrm>
-          <a:prstGeom prst="rect">
-            <a:avLst/>
-          </a:prstGeom>
-          <a:noFill/>
-          <a:ln>
-            <a:noFill/>
-          </a:ln>
-        </p:spPr>
-        <p:txBody>
-          <a:bodyPr wrap="square" lIns="0" tIns="0" rIns="0" bIns="0" anchor="ctr">
-            <a:noAutofit/>
-          </a:bodyPr>
-          <a:lstStyle/>
-          <a:p>
-            <a:pPr algn="ctr"/>
-            <a:r>
-              <a:rPr lang="en-US" sz="1250" b="0" i="0" dirty="0">
-                <a:solidFill>
-                  <a:srgbClr val="1F2328"/>
-                </a:solidFill>
-                <a:latin typeface="Calibri"/>
-                <a:cs typeface="Calibri"/>
-              </a:rPr>
-              <a:t xml:space="preserve">0</a:t>
-            </a:r>
-          </a:p>
-        </p:txBody>
-      </p:sp>
-      <p:sp>
-        <p:nvSpPr>
-          <p:cNvPr id="1225" name="Method"/>
-          <p:cNvSpPr txBox="1"/>
-          <p:nvPr/>
-        </p:nvSpPr>
-        <p:spPr>
-          <a:xfrm>
-            <a:off x="2514600" y="5193792"/>
-            <a:ext cx="1280160" cy="329184"/>
-          </a:xfrm>
-          <a:prstGeom prst="rect">
-            <a:avLst/>
-          </a:prstGeom>
-          <a:noFill/>
-          <a:ln>
-            <a:noFill/>
-          </a:ln>
-        </p:spPr>
-        <p:txBody>
-          <a:bodyPr wrap="square" lIns="0" tIns="0" rIns="0" bIns="0" anchor="ctr">
-            <a:noAutofit/>
-          </a:bodyPr>
-          <a:lstStyle/>
-          <a:p>
-            <a:pPr algn="l"/>
-            <a:r>
-              <a:rPr lang="en-US" sz="1200" b="1" i="0" dirty="0">
-                <a:solidFill>
-                  <a:srgbClr val="0B6E4F"/>
-                </a:solidFill>
-                <a:latin typeface="Calibri"/>
-                <a:cs typeface="Calibri"/>
-              </a:rPr>
-              <a:t xml:space="preserve">RIGOR</a:t>
+              <a:t xml:space="preserve">0.00</a:t>
+            </a:r>
+          </a:p>
+        </p:txBody>
+      </p:sp>
+      <p:sp>
+        <p:nvSpPr>
+          <p:cNvPr id="1224" name="Cell"/>
+          <p:cNvSpPr/>
+          <p:nvPr/>
+        </p:nvSpPr>
+        <p:spPr>
+          <a:xfrm>
+            <a:off x="7562088" y="5001768"/>
+            <a:ext cx="713231" cy="219456"/>
+          </a:xfrm>
+          <a:prstGeom prst="rect">
+            <a:avLst/>
+          </a:prstGeom>
+          <a:solidFill>
+            <a:srgbClr val="EDB8AC"/>
+          </a:solidFill>
+          <a:ln>
+            <a:noFill/>
+          </a:ln>
+        </p:spPr>
+        <p:txBody>
+          <a:bodyPr wrap="square" lIns="0" tIns="0" rIns="0" bIns="0" anchor="ctr">
+            <a:noAutofit/>
+          </a:bodyPr>
+          <a:lstStyle/>
+          <a:p>
+            <a:pPr algn="ctr"/>
+            <a:r>
+              <a:rPr lang="en-US" sz="1100" b="0" i="0" dirty="0">
+                <a:solidFill>
+                  <a:srgbClr val="1F2328"/>
+                </a:solidFill>
+                <a:latin typeface="Calibri"/>
+                <a:cs typeface="Calibri"/>
+              </a:rPr>
+              <a:t xml:space="preserve">0.00</a:t>
+            </a:r>
+          </a:p>
+        </p:txBody>
+      </p:sp>
+      <p:sp>
+        <p:nvSpPr>
+          <p:cNvPr id="1225" name="Cell"/>
+          <p:cNvSpPr/>
+          <p:nvPr/>
+        </p:nvSpPr>
+        <p:spPr>
+          <a:xfrm>
+            <a:off x="8311896" y="5001768"/>
+            <a:ext cx="713231" cy="219456"/>
+          </a:xfrm>
+          <a:prstGeom prst="rect">
+            <a:avLst/>
+          </a:prstGeom>
+          <a:solidFill>
+            <a:srgbClr val="EDB8AC"/>
+          </a:solidFill>
+          <a:ln>
+            <a:noFill/>
+          </a:ln>
+        </p:spPr>
+        <p:txBody>
+          <a:bodyPr wrap="square" lIns="0" tIns="0" rIns="0" bIns="0" anchor="ctr">
+            <a:noAutofit/>
+          </a:bodyPr>
+          <a:lstStyle/>
+          <a:p>
+            <a:pPr algn="ctr"/>
+            <a:r>
+              <a:rPr lang="en-US" sz="1100" b="0" i="0" dirty="0">
+                <a:solidFill>
+                  <a:srgbClr val="1F2328"/>
+                </a:solidFill>
+                <a:latin typeface="Calibri"/>
+                <a:cs typeface="Calibri"/>
+              </a:rPr>
+              <a:t xml:space="preserve">0.00</a:t>
             </a:r>
           </a:p>
         </p:txBody>
@@ -18472,35 +18500,35 @@
         </p:nvSpPr>
         <p:spPr>
           <a:xfrm>
-            <a:off x="3813048" y="5212080"/>
-            <a:ext cx="713231" cy="292608"/>
-          </a:xfrm>
-          <a:prstGeom prst="rect">
-            <a:avLst/>
-          </a:prstGeom>
-          <a:solidFill>
-            <a:srgbClr val="F1F3F2"/>
-          </a:solidFill>
-          <a:ln>
-            <a:noFill/>
-          </a:ln>
-        </p:spPr>
-        <p:txBody>
-          <a:bodyPr wrap="square" lIns="0" tIns="0" rIns="0" bIns="0" anchor="ctr">
-            <a:noAutofit/>
-          </a:bodyPr>
-          <a:lstStyle/>
-          <a:p>
-            <a:pPr algn="ctr"/>
-            <a:r>
-              <a:rPr lang="en-US" sz="1100" b="1" i="0" dirty="0">
-                <a:solidFill>
-                  <a:srgbClr val="1F2328"/>
-                </a:solidFill>
-                <a:latin typeface="Calibri"/>
-                <a:cs typeface="Calibri"/>
-              </a:rPr>
-              <a:t xml:space="preserve">14</a:t>
+            <a:off x="9061704" y="5001768"/>
+            <a:ext cx="713231" cy="219456"/>
+          </a:xfrm>
+          <a:prstGeom prst="rect">
+            <a:avLst/>
+          </a:prstGeom>
+          <a:solidFill>
+            <a:srgbClr val="EDB8AC"/>
+          </a:solidFill>
+          <a:ln>
+            <a:noFill/>
+          </a:ln>
+        </p:spPr>
+        <p:txBody>
+          <a:bodyPr wrap="square" lIns="0" tIns="0" rIns="0" bIns="0" anchor="ctr">
+            <a:noAutofit/>
+          </a:bodyPr>
+          <a:lstStyle/>
+          <a:p>
+            <a:pPr algn="ctr"/>
+            <a:r>
+              <a:rPr lang="en-US" sz="1100" b="0" i="0" dirty="0">
+                <a:solidFill>
+                  <a:srgbClr val="1F2328"/>
+                </a:solidFill>
+                <a:latin typeface="Calibri"/>
+                <a:cs typeface="Calibri"/>
+              </a:rPr>
+              <a:t xml:space="preserve">0.00</a:t>
             </a:r>
           </a:p>
         </p:txBody>
@@ -18513,117 +18541,113 @@
         </p:nvSpPr>
         <p:spPr>
           <a:xfrm>
-            <a:off x="4562856" y="5212080"/>
-            <a:ext cx="713231" cy="292608"/>
-          </a:xfrm>
-          <a:prstGeom prst="rect">
-            <a:avLst/>
-          </a:prstGeom>
-          <a:solidFill>
-            <a:srgbClr val="F1F3F2"/>
-          </a:solidFill>
-          <a:ln>
-            <a:noFill/>
-          </a:ln>
-        </p:spPr>
-        <p:txBody>
-          <a:bodyPr wrap="square" lIns="0" tIns="0" rIns="0" bIns="0" anchor="ctr">
-            <a:noAutofit/>
-          </a:bodyPr>
-          <a:lstStyle/>
-          <a:p>
-            <a:pPr algn="ctr"/>
-            <a:r>
-              <a:rPr lang="en-US" sz="1100" b="1" i="0" dirty="0">
-                <a:solidFill>
-                  <a:srgbClr val="1F2328"/>
-                </a:solidFill>
-                <a:latin typeface="Calibri"/>
-                <a:cs typeface="Calibri"/>
-              </a:rPr>
-              <a:t xml:space="preserve">12</a:t>
-            </a:r>
-          </a:p>
-        </p:txBody>
-      </p:sp>
-      <p:sp>
-        <p:nvSpPr>
-          <p:cNvPr id="1228" name="Cell"/>
-          <p:cNvSpPr/>
-          <p:nvPr/>
-        </p:nvSpPr>
-        <p:spPr>
-          <a:xfrm>
-            <a:off x="5312664" y="5212080"/>
-            <a:ext cx="713231" cy="292608"/>
-          </a:xfrm>
-          <a:prstGeom prst="rect">
-            <a:avLst/>
-          </a:prstGeom>
-          <a:solidFill>
-            <a:srgbClr val="F6DAD3"/>
-          </a:solidFill>
-          <a:ln>
-            <a:noFill/>
-          </a:ln>
-        </p:spPr>
-        <p:txBody>
-          <a:bodyPr wrap="square" lIns="0" tIns="0" rIns="0" bIns="0" anchor="ctr">
-            <a:noAutofit/>
-          </a:bodyPr>
-          <a:lstStyle/>
-          <a:p>
-            <a:pPr algn="ctr"/>
-            <a:r>
-              <a:rPr lang="en-US" sz="1100" b="1" i="0" dirty="0">
-                <a:solidFill>
-                  <a:srgbClr val="1F2328"/>
-                </a:solidFill>
-                <a:latin typeface="Calibri"/>
-                <a:cs typeface="Calibri"/>
-              </a:rPr>
-              <a:t xml:space="preserve">2</a:t>
-            </a:r>
-          </a:p>
-        </p:txBody>
-      </p:sp>
-      <p:sp>
-        <p:nvSpPr>
-          <p:cNvPr id="1229" name="Cell"/>
-          <p:cNvSpPr/>
-          <p:nvPr/>
-        </p:nvSpPr>
-        <p:spPr>
-          <a:xfrm>
-            <a:off x="6062472" y="5212080"/>
-            <a:ext cx="713231" cy="292608"/>
-          </a:xfrm>
-          <a:prstGeom prst="rect">
-            <a:avLst/>
-          </a:prstGeom>
-          <a:solidFill>
-            <a:srgbClr val="DDF0E5"/>
-          </a:solidFill>
-          <a:ln>
-            <a:noFill/>
-          </a:ln>
-        </p:spPr>
-        <p:txBody>
-          <a:bodyPr wrap="square" lIns="0" tIns="0" rIns="0" bIns="0" anchor="ctr">
-            <a:noAutofit/>
-          </a:bodyPr>
-          <a:lstStyle/>
-          <a:p>
-            <a:pPr algn="ctr"/>
-            <a:r>
-              <a:rPr lang="en-US" sz="1100" b="1" i="0" dirty="0">
-                <a:solidFill>
-                  <a:srgbClr val="1F2328"/>
-                </a:solidFill>
-                <a:latin typeface="Calibri"/>
-                <a:cs typeface="Calibri"/>
-              </a:rPr>
-              <a:t xml:space="preserve">21</a:t>
+            <a:off x="9811512" y="5001768"/>
+            <a:ext cx="713231" cy="219456"/>
+          </a:xfrm>
+          <a:prstGeom prst="rect">
+            <a:avLst/>
+          </a:prstGeom>
+          <a:solidFill>
+            <a:srgbClr val="EDB8AC"/>
+          </a:solidFill>
+          <a:ln>
+            <a:noFill/>
+          </a:ln>
+        </p:spPr>
+        <p:txBody>
+          <a:bodyPr wrap="square" lIns="0" tIns="0" rIns="0" bIns="0" anchor="ctr">
+            <a:noAutofit/>
+          </a:bodyPr>
+          <a:lstStyle/>
+          <a:p>
+            <a:pPr algn="ctr"/>
+            <a:r>
+              <a:rPr lang="en-US" sz="1100" b="0" i="0" dirty="0">
+                <a:solidFill>
+                  <a:srgbClr val="1F2328"/>
+                </a:solidFill>
+                <a:latin typeface="Calibri"/>
+                <a:cs typeface="Calibri"/>
+              </a:rPr>
+              <a:t xml:space="preserve">0.00</a:t>
+            </a:r>
+          </a:p>
+        </p:txBody>
+      </p:sp>
+      <p:sp>
+        <p:nvSpPr>
+          <p:cNvPr id="1228" name="Avg"/>
+          <p:cNvSpPr txBox="1"/>
+          <p:nvPr/>
+        </p:nvSpPr>
+        <p:spPr>
+          <a:xfrm>
+            <a:off x="10588752" y="4983480"/>
+            <a:ext cx="685800" cy="256032"/>
+          </a:xfrm>
+          <a:prstGeom prst="rect">
+            <a:avLst/>
+          </a:prstGeom>
+          <a:noFill/>
+          <a:ln>
+            <a:noFill/>
+          </a:ln>
+        </p:spPr>
+        <p:txBody>
+          <a:bodyPr wrap="square" lIns="0" tIns="0" rIns="0" bIns="0" anchor="ctr">
+            <a:noAutofit/>
+          </a:bodyPr>
+          <a:lstStyle/>
+          <a:p>
+            <a:pPr algn="ctr"/>
+            <a:r>
+              <a:rPr lang="en-US" sz="1250" b="0" i="0" dirty="0">
+                <a:solidFill>
+                  <a:srgbClr val="1F2328"/>
+                </a:solidFill>
+                <a:latin typeface="Calibri"/>
+                <a:cs typeface="Calibri"/>
+              </a:rPr>
+              <a:t xml:space="preserve">0.00</a:t>
+            </a:r>
+          </a:p>
+        </p:txBody>
+      </p:sp>
+      <p:sp>
+        <p:nvSpPr>
+          <p:cNvPr id="1229" name="Method"/>
+          <p:cNvSpPr txBox="1"/>
+          <p:nvPr/>
+        </p:nvSpPr>
+        <p:spPr>
+          <a:xfrm>
+            <a:off x="2514600" y="5239512"/>
+            <a:ext cx="1280160" cy="256032"/>
+          </a:xfrm>
+          <a:prstGeom prst="rect">
+            <a:avLst/>
+          </a:prstGeom>
+          <a:noFill/>
+          <a:ln>
+            <a:noFill/>
+          </a:ln>
+        </p:spPr>
+        <p:txBody>
+          <a:bodyPr wrap="square" lIns="0" tIns="0" rIns="0" bIns="0" anchor="ctr">
+            <a:noAutofit/>
+          </a:bodyPr>
+          <a:lstStyle/>
+          <a:p>
+            <a:pPr algn="l"/>
+            <a:r>
+              <a:rPr lang="en-US" sz="1200" b="1" i="0" dirty="0">
+                <a:solidFill>
+                  <a:srgbClr val="0B6E4F"/>
+                </a:solidFill>
+                <a:latin typeface="Calibri"/>
+                <a:cs typeface="Calibri"/>
+              </a:rPr>
+              <a:t xml:space="preserve">RIGOR</a:t>
             </a:r>
           </a:p>
         </p:txBody>
@@ -18636,14 +18660,14 @@
         </p:nvSpPr>
         <p:spPr>
           <a:xfrm>
-            <a:off x="6812279" y="5212080"/>
-            <a:ext cx="713231" cy="292608"/>
-          </a:xfrm>
-          <a:prstGeom prst="rect">
-            <a:avLst/>
-          </a:prstGeom>
-          <a:solidFill>
-            <a:srgbClr val="DDF0E5"/>
+            <a:off x="3813048" y="5257800"/>
+            <a:ext cx="713231" cy="219456"/>
+          </a:xfrm>
+          <a:prstGeom prst="rect">
+            <a:avLst/>
+          </a:prstGeom>
+          <a:solidFill>
+            <a:srgbClr val="BFE3CF"/>
           </a:solidFill>
           <a:ln>
             <a:noFill/>
@@ -18664,7 +18688,7 @@
                 <a:latin typeface="Calibri"/>
                 <a:cs typeface="Calibri"/>
               </a:rPr>
-              <a:t xml:space="preserve">59</a:t>
+              <a:t xml:space="preserve">0.70</a:t>
             </a:r>
           </a:p>
         </p:txBody>
@@ -18677,14 +18701,14 @@
         </p:nvSpPr>
         <p:spPr>
           <a:xfrm>
-            <a:off x="7562088" y="5212080"/>
-            <a:ext cx="713231" cy="292608"/>
-          </a:xfrm>
-          <a:prstGeom prst="rect">
-            <a:avLst/>
-          </a:prstGeom>
-          <a:solidFill>
-            <a:srgbClr val="F6DAD3"/>
+            <a:off x="4562856" y="5257800"/>
+            <a:ext cx="713231" cy="219456"/>
+          </a:xfrm>
+          <a:prstGeom prst="rect">
+            <a:avLst/>
+          </a:prstGeom>
+          <a:solidFill>
+            <a:srgbClr val="DDF0E5"/>
           </a:solidFill>
           <a:ln>
             <a:noFill/>
@@ -18705,7 +18729,7 @@
                 <a:latin typeface="Calibri"/>
                 <a:cs typeface="Calibri"/>
               </a:rPr>
-              <a:t xml:space="preserve">3</a:t>
+              <a:t xml:space="preserve">0.39</a:t>
             </a:r>
           </a:p>
         </p:txBody>
@@ -18718,14 +18742,14 @@
         </p:nvSpPr>
         <p:spPr>
           <a:xfrm>
-            <a:off x="8311896" y="5212080"/>
-            <a:ext cx="713231" cy="292608"/>
-          </a:xfrm>
-          <a:prstGeom prst="rect">
-            <a:avLst/>
-          </a:prstGeom>
-          <a:solidFill>
-            <a:srgbClr val="BFE3CF"/>
+            <a:off x="5312664" y="5257800"/>
+            <a:ext cx="713231" cy="219456"/>
+          </a:xfrm>
+          <a:prstGeom prst="rect">
+            <a:avLst/>
+          </a:prstGeom>
+          <a:solidFill>
+            <a:srgbClr val="F6DAD3"/>
           </a:solidFill>
           <a:ln>
             <a:noFill/>
@@ -18746,7 +18770,7 @@
                 <a:latin typeface="Calibri"/>
                 <a:cs typeface="Calibri"/>
               </a:rPr>
-              <a:t xml:space="preserve">157</a:t>
+              <a:t xml:space="preserve">0.13</a:t>
             </a:r>
           </a:p>
         </p:txBody>
@@ -18759,8 +18783,8 @@
         </p:nvSpPr>
         <p:spPr>
           <a:xfrm>
-            <a:off x="9061704" y="5212080"/>
-            <a:ext cx="713231" cy="292608"/>
+            <a:off x="6062472" y="5257800"/>
+            <a:ext cx="713231" cy="219456"/>
           </a:xfrm>
           <a:prstGeom prst="rect">
             <a:avLst/>
@@ -18787,7 +18811,7 @@
                 <a:latin typeface="Calibri"/>
                 <a:cs typeface="Calibri"/>
               </a:rPr>
-              <a:t xml:space="preserve">147</a:t>
+              <a:t xml:space="preserve">0.62</a:t>
             </a:r>
           </a:p>
         </p:txBody>
@@ -18800,8 +18824,8 @@
         </p:nvSpPr>
         <p:spPr>
           <a:xfrm>
-            <a:off x="9811512" y="5212080"/>
-            <a:ext cx="713231" cy="292608"/>
+            <a:off x="6812279" y="5257800"/>
+            <a:ext cx="713231" cy="219456"/>
           </a:xfrm>
           <a:prstGeom prst="rect">
             <a:avLst/>
@@ -18828,21 +18852,185 @@
                 <a:latin typeface="Calibri"/>
                 <a:cs typeface="Calibri"/>
               </a:rPr>
-              <a:t xml:space="preserve">114</a:t>
-            </a:r>
-          </a:p>
-        </p:txBody>
-      </p:sp>
-      <p:sp>
-        <p:nvSpPr>
-          <p:cNvPr id="1235" name="Avg"/>
+              <a:t xml:space="preserve">0.49</a:t>
+            </a:r>
+          </a:p>
+        </p:txBody>
+      </p:sp>
+      <p:sp>
+        <p:nvSpPr>
+          <p:cNvPr id="1235" name="Cell"/>
+          <p:cNvSpPr/>
+          <p:nvPr/>
+        </p:nvSpPr>
+        <p:spPr>
+          <a:xfrm>
+            <a:off x="7562088" y="5257800"/>
+            <a:ext cx="713231" cy="219456"/>
+          </a:xfrm>
+          <a:prstGeom prst="rect">
+            <a:avLst/>
+          </a:prstGeom>
+          <a:solidFill>
+            <a:srgbClr val="F6DAD3"/>
+          </a:solidFill>
+          <a:ln>
+            <a:noFill/>
+          </a:ln>
+        </p:spPr>
+        <p:txBody>
+          <a:bodyPr wrap="square" lIns="0" tIns="0" rIns="0" bIns="0" anchor="ctr">
+            <a:noAutofit/>
+          </a:bodyPr>
+          <a:lstStyle/>
+          <a:p>
+            <a:pPr algn="ctr"/>
+            <a:r>
+              <a:rPr lang="en-US" sz="1100" b="1" i="0" dirty="0">
+                <a:solidFill>
+                  <a:srgbClr val="1F2328"/>
+                </a:solidFill>
+                <a:latin typeface="Calibri"/>
+                <a:cs typeface="Calibri"/>
+              </a:rPr>
+              <a:t xml:space="preserve">0.10</a:t>
+            </a:r>
+          </a:p>
+        </p:txBody>
+      </p:sp>
+      <p:sp>
+        <p:nvSpPr>
+          <p:cNvPr id="1236" name="Cell"/>
+          <p:cNvSpPr/>
+          <p:nvPr/>
+        </p:nvSpPr>
+        <p:spPr>
+          <a:xfrm>
+            <a:off x="8311896" y="5257800"/>
+            <a:ext cx="713231" cy="219456"/>
+          </a:xfrm>
+          <a:prstGeom prst="rect">
+            <a:avLst/>
+          </a:prstGeom>
+          <a:solidFill>
+            <a:srgbClr val="DDF0E5"/>
+          </a:solidFill>
+          <a:ln>
+            <a:noFill/>
+          </a:ln>
+        </p:spPr>
+        <p:txBody>
+          <a:bodyPr wrap="square" lIns="0" tIns="0" rIns="0" bIns="0" anchor="ctr">
+            <a:noAutofit/>
+          </a:bodyPr>
+          <a:lstStyle/>
+          <a:p>
+            <a:pPr algn="ctr"/>
+            <a:r>
+              <a:rPr lang="en-US" sz="1100" b="1" i="0" dirty="0">
+                <a:solidFill>
+                  <a:srgbClr val="1F2328"/>
+                </a:solidFill>
+                <a:latin typeface="Calibri"/>
+                <a:cs typeface="Calibri"/>
+              </a:rPr>
+              <a:t xml:space="preserve">2.12</a:t>
+            </a:r>
+          </a:p>
+        </p:txBody>
+      </p:sp>
+      <p:sp>
+        <p:nvSpPr>
+          <p:cNvPr id="1237" name="Cell"/>
+          <p:cNvSpPr/>
+          <p:nvPr/>
+        </p:nvSpPr>
+        <p:spPr>
+          <a:xfrm>
+            <a:off x="9061704" y="5257800"/>
+            <a:ext cx="713231" cy="219456"/>
+          </a:xfrm>
+          <a:prstGeom prst="rect">
+            <a:avLst/>
+          </a:prstGeom>
+          <a:solidFill>
+            <a:srgbClr val="DDF0E5"/>
+          </a:solidFill>
+          <a:ln>
+            <a:noFill/>
+          </a:ln>
+        </p:spPr>
+        <p:txBody>
+          <a:bodyPr wrap="square" lIns="0" tIns="0" rIns="0" bIns="0" anchor="ctr">
+            <a:noAutofit/>
+          </a:bodyPr>
+          <a:lstStyle/>
+          <a:p>
+            <a:pPr algn="ctr"/>
+            <a:r>
+              <a:rPr lang="en-US" sz="1100" b="1" i="0" dirty="0">
+                <a:solidFill>
+                  <a:srgbClr val="1F2328"/>
+                </a:solidFill>
+                <a:latin typeface="Calibri"/>
+                <a:cs typeface="Calibri"/>
+              </a:rPr>
+              <a:t xml:space="preserve">2.72</a:t>
+            </a:r>
+          </a:p>
+        </p:txBody>
+      </p:sp>
+      <p:sp>
+        <p:nvSpPr>
+          <p:cNvPr id="1238" name="Cell"/>
+          <p:cNvSpPr/>
+          <p:nvPr/>
+        </p:nvSpPr>
+        <p:spPr>
+          <a:xfrm>
+            <a:off x="9811512" y="5257800"/>
+            <a:ext cx="713231" cy="219456"/>
+          </a:xfrm>
+          <a:prstGeom prst="rect">
+            <a:avLst/>
+          </a:prstGeom>
+          <a:solidFill>
+            <a:srgbClr val="BFE3CF"/>
+          </a:solidFill>
+          <a:ln>
+            <a:noFill/>
+          </a:ln>
+        </p:spPr>
+        <p:txBody>
+          <a:bodyPr wrap="square" lIns="0" tIns="0" rIns="0" bIns="0" anchor="ctr">
+            <a:noAutofit/>
+          </a:bodyPr>
+          <a:lstStyle/>
+          <a:p>
+            <a:pPr algn="ctr"/>
+            <a:r>
+              <a:rPr lang="en-US" sz="1100" b="1" i="0" dirty="0">
+                <a:solidFill>
+                  <a:srgbClr val="1F2328"/>
+                </a:solidFill>
+                <a:latin typeface="Calibri"/>
+                <a:cs typeface="Calibri"/>
+              </a:rPr>
+              <a:t xml:space="preserve">4.07</a:t>
+            </a:r>
+          </a:p>
+        </p:txBody>
+      </p:sp>
+      <p:sp>
+        <p:nvSpPr>
+          <p:cNvPr id="1239" name="Avg"/>
           <p:cNvSpPr txBox="1"/>
           <p:nvPr/>
         </p:nvSpPr>
         <p:spPr>
           <a:xfrm>
-            <a:off x="10588752" y="5193792"/>
-            <a:ext cx="685800" cy="329184"/>
+            <a:off x="10588752" y="5239512"/>
+            <a:ext cx="685800" cy="256032"/>
           </a:xfrm>
           <a:prstGeom prst="rect">
             <a:avLst/>
@@ -18867,14 +19055,14 @@
                 <a:latin typeface="Calibri"/>
                 <a:cs typeface="Calibri"/>
               </a:rPr>
-              <a:t xml:space="preserve">59</a:t>
-            </a:r>
-          </a:p>
-        </p:txBody>
-      </p:sp>
-      <p:sp>
-        <p:nvSpPr>
-          <p:cNvPr id="1236" name="Strip"/>
+              <a:t xml:space="preserve">1.26</a:t>
+            </a:r>
+          </a:p>
+        </p:txBody>
+      </p:sp>
+      <p:sp>
+        <p:nvSpPr>
+          <p:cNvPr id="1240" name="Strip"/>
           <p:cNvSpPr/>
           <p:nvPr/>
         </p:nvSpPr>
@@ -18910,40 +19098,50 @@
                 <a:latin typeface="Calibri"/>
                 <a:cs typeface="Calibri"/>
               </a:rPr>
-              <a:t xml:space="preserve">Hierarchies follow what the LLM knows: </a:t>
+              <a:t xml:space="preserve">Only RIGOR adds labels, provenance </a:t>
             </a:r>
             <a:r>
               <a:rPr lang="en-US" sz="1400" b="1" i="0" dirty="0">
                 <a:solidFill>
+                  <a:srgbClr val="1F2328"/>
+                </a:solidFill>
+                <a:latin typeface="Calibri"/>
+                <a:cs typeface="Calibri"/>
+              </a:rPr>
+              <a:t xml:space="preserve">and</a:t>
+            </a:r>
+            <a:r>
+              <a:rPr lang="en-US" sz="1400" b="0" i="0" dirty="0">
+                <a:solidFill>
+                  <a:srgbClr val="3A434C"/>
+                </a:solidFill>
+                <a:latin typeface="Calibri"/>
+                <a:cs typeface="Calibri"/>
+              </a:rPr>
+              <a:t xml:space="preserve"> a class hierarchy: </a:t>
+            </a:r>
+            <a:r>
+              <a:rPr lang="en-US" sz="1400" b="1" i="0" dirty="0">
+                <a:solidFill>
                   <a:srgbClr val="0B6E4F"/>
                 </a:solidFill>
                 <a:latin typeface="Calibri"/>
                 <a:cs typeface="Calibri"/>
               </a:rPr>
-              <a:t xml:space="preserve">114–157 subclass axioms for the music store</a:t>
-            </a:r>
-            <a:r>
-              <a:rPr lang="en-US" sz="1400" b="0" i="0" dirty="0">
-                <a:solidFill>
-                  <a:srgbClr val="3A434C"/>
-                </a:solidFill>
-                <a:latin typeface="Calibri"/>
-                <a:cs typeface="Calibri"/>
-              </a:rPr>
-              <a:t xml:space="preserve">, 2–59 for the clinical schemas.</a:t>
-            </a:r>
-          </a:p>
-        </p:txBody>
-      </p:sp>
-      <p:sp>
-        <p:nvSpPr>
-          <p:cNvPr id="1237" name="Source"/>
+              <a:t xml:space="preserve">with every LLM, in every database.</a:t>
+            </a:r>
+          </a:p>
+        </p:txBody>
+      </p:sp>
+      <p:sp>
+        <p:nvSpPr>
+          <p:cNvPr id="1241" name="Source"/>
           <p:cNvSpPr txBox="1"/>
           <p:nvPr/>
         </p:nvSpPr>
         <p:spPr>
           <a:xfrm>
-            <a:off x="822960" y="6382512"/>
+            <a:off x="822960" y="6345936"/>
             <a:ext cx="10607040" cy="237744"/>
           </a:xfrm>
           <a:prstGeom prst="rect">
@@ -18969,7 +19167,7 @@
                 <a:latin typeface="Calibri"/>
                 <a:cs typeface="Calibri"/>
               </a:rPr>
-              <a:t xml:space="preserve">Paper Table 8: annotation assertions (labels and comments), prov:wasDerivedFrom assertions, rdfs:subClassOf axioms.</a:t>
+              <a:t xml:space="preserve">Labels &amp; comments: annotation assertions; provenance: prov:wasDerivedFrom (paper Table 8). Hierarchy: inheritance richness, subclass axioms per class [OntoQA: Tartir et al., KADASH 2005; OntoMetrics: Lantow, KEOD 2016], from Table 8. Shading compares cells within each database.</a:t>
             </a:r>
           </a:p>
         </p:txBody>

</xml_diff>

<commit_message>
Result 5: plain claims, average scores, and how the judges scored
Replaces the 58/58 and 28/40 counts with 'First on every table' and 'First in 7 of 10
rankings'; the expert table shows average scores (Table 11) like the judge table; a 'How
they judged' box explains the setup (schema, 5 competency questions, four anonymized
ontologies, seven 0-5 dimensions, ranking). Counts move to the Q&A notes.

Co-Authored-By: Claude Opus 5.5 <noreply@anthropic.com>
Claude-Session: https://claude.ai/code/session_01KcycczqUBG98FnzsgJYAW8
</commit_message>
<xml_diff>
--- a/presentation/RIGOR_results.pptx
+++ b/presentation/RIGOR_results.pptx
@@ -2309,7 +2309,7 @@
                 <a:cs typeface="Calibri"/>
                 <a:sym typeface="Calibri"/>
               </a:rPr>
-              <a:t>[11:07–11:58]  SPOKEN SCRIPT (82 words)</a:t>
+              <a:t>[11:07–12:03]  SPOKEN SCRIPT (91 words)</a:t>
             </a:r>
           </a:p>
           <a:p>
@@ -2323,7 +2323,7 @@
                 <a:cs typeface="Calibri"/>
                 <a:sym typeface="Calibri"/>
               </a:rPr>
-              <a:t>Automatic checks agree. Do evaluators agree? Both judged each table against its competency questions: what the ontology must be able to answer, five per table, verified by a domain expert. An LLM judge ranked RIGOR first on all fifty-eight tables, with its largest lead on the liver registry that no LLM has seen. [pause] Ten ontology experts ranked RIGOR first in twenty-eight of forty rankings. [pause] Direct mapping gives structure without meaning. LLMs alone give meaning without structure. RIGOR gives both, and checks them.</a:t>
+              <a:t>Automatic checks agree. Do evaluators agree? For each table, an LLM judge and ten ontology experts saw the schema, five competency questions, the questions the ontology must answer, and four anonymized ontologies. They scored each on seven quality dimensions and ranked them. The LLM judge put RIGOR first on every table, in all three databases. [pause] The experts put RIGOR first in seven of ten rankings, with the highest average score on both databases. [pause] Direct mapping gives structure without meaning. LLMs alone give meaning without structure. RIGOR gives both, and checks them.</a:t>
             </a:r>
           </a:p>
           <a:p/>
@@ -2338,7 +2338,7 @@
                 <a:cs typeface="Calibri"/>
                 <a:sym typeface="Calibri"/>
               </a:rPr>
-              <a:t>PRESENTER / POINTER: Read the competency question aloud; then 58 of 58; then 28 of 40; then the closing strip.</a:t>
+              <a:t>PRESENTER / POINTER: The 'How they judged' box in one breath; then the two claims; then the closing strip.</a:t>
             </a:r>
           </a:p>
           <a:p>
@@ -2352,7 +2352,7 @@
                 <a:cs typeface="Calibri"/>
                 <a:sym typeface="Calibri"/>
               </a:rPr>
-              <a:t>AUDIENCE TAKEAWAY: Judged against competency questions, an LLM judge and human experts both rank RIGOR first.</a:t>
+              <a:t>AUDIENCE TAKEAWAY: Judged blind against competency questions, an LLM judge and human experts both rank RIGOR first.</a:t>
             </a:r>
           </a:p>
           <a:p>
@@ -2366,7 +2366,7 @@
                 <a:cs typeface="Calibri"/>
                 <a:sym typeface="Calibri"/>
               </a:rPr>
-              <a:t>SOURCE AND SCOPE: Paper Sec. 4.2 (5 CQs per table, LLM-generated, expert-verified; 290 in total), Table 6 (example), Table 1 (scores, rankings), Table 12 (Kendall's W 0.39-0.72). Judge: Claude ontologies.</a:t>
+              <a:t>SOURCE AND SCOPE: Paper Sec. 4.2 and 4.6 (5 expert-verified CQs per table, 7 dimensions, ranking), Table 1 (judge scores and first places: 58 of 58 tables), Table 11 (expert scores), Table 12 (Kendall's W 0.39-0.72). Judge evaluated the Claude ontologies; experts 4 medical tables, 28 of 40 first places.</a:t>
             </a:r>
           </a:p>
           <a:p>
@@ -2380,7 +2380,22 @@
                 <a:cs typeface="Calibri"/>
                 <a:sym typeface="Calibri"/>
               </a:rPr>
-              <a:t>IF RUNNING LATE, DROP: "with its largest lead on the liver registry that no LLM has seen"</a:t>
+              <a:t>IF RUNNING LATE, DROP: "with the highest average score on both databases"</a:t>
+            </a:r>
+          </a:p>
+          <a:p/>
+          <a:p>
+            <a:r>
+              <a:rPr lang="en-US" sz="1200">
+                <a:solidFill>
+                  <a:schemeClr val="dk1"/>
+                </a:solidFill>
+                <a:latin typeface="Calibri"/>
+                <a:ea typeface="Calibri"/>
+                <a:cs typeface="Calibri"/>
+                <a:sym typeface="Calibri"/>
+              </a:rPr>
+              <a:t>IF ASKED HOW MANY: the judge ranked RIGOR first on 58 of 58 tables (16 Liver Cancer, 31 eICU-CRD, 11 Chinook); the experts in 28 of 40 rankings (10 experts x 4 tables).</a:t>
             </a:r>
           </a:p>
         </p:txBody>
@@ -10464,7 +10479,7 @@
                 <a:latin typeface="Calibri"/>
                 <a:cs typeface="Calibri"/>
               </a:rPr>
-              <a:t xml:space="preserve">Both ranked four anonymized ontologies per table, judged against that table's competency questions.</a:t>
+              <a:t xml:space="preserve">Blind evaluation: nobody knew which ontology came from which method.</a:t>
             </a:r>
           </a:p>
         </p:txBody>
@@ -10676,14 +10691,14 @@
       </p:sp>
       <p:sp>
         <p:nvSpPr>
-          <p:cNvPr id="1264" name="CQ strip"/>
+          <p:cNvPr id="1264" name="How"/>
           <p:cNvSpPr/>
           <p:nvPr/>
         </p:nvSpPr>
         <p:spPr>
           <a:xfrm>
             <a:off x="804672" y="2606040"/>
-            <a:ext cx="10579608" cy="475488"/>
+            <a:ext cx="10579608" cy="658368"/>
           </a:xfrm>
           <a:prstGeom prst="roundRect">
             <a:avLst>
@@ -10714,27 +10729,17 @@
                 <a:latin typeface="Consolas"/>
                 <a:cs typeface="Consolas"/>
               </a:rPr>
-              <a:t xml:space="preserve">COMPETENCY QUESTIONS  </a:t>
-            </a:r>
-            <a:r>
-              <a:rPr lang="en-US" sz="1150" b="0" i="0" dirty="0">
+              <a:t xml:space="preserve">HOW THEY JUDGED   </a:t>
+            </a:r>
+            <a:r>
+              <a:rPr lang="en-US" sz="1200" b="0" i="0" dirty="0">
                 <a:solidFill>
                   <a:srgbClr val="3A434C"/>
                 </a:solidFill>
                 <a:latin typeface="Calibri"/>
                 <a:cs typeface="Calibri"/>
               </a:rPr>
-              <a:t xml:space="preserve">what the ontology must answer. 5 per table, 290 in total, expert-verified.  </a:t>
-            </a:r>
-            <a:r>
-              <a:rPr lang="en-US" sz="1150" b="0" i="1" dirty="0">
-                <a:solidFill>
-                  <a:srgbClr val="1F2328"/>
-                </a:solidFill>
-                <a:latin typeface="Calibri"/>
-                <a:cs typeface="Calibri"/>
-              </a:rPr>
-              <a:t xml:space="preserve">e.g. “Which patients had abnormal physical exam findings?”</a:t>
+              <a:t xml:space="preserve">For each table: its schema, its 5 competency questions (what the ontology must answer) and four anonymized ontologies. Each scored 0–5 on accuracy, completeness, conciseness, adaptability, clarity, consistency and domain enrichment, then ranked 1st–4th.</a:t>
             </a:r>
           </a:p>
         </p:txBody>
@@ -10747,8 +10752,8 @@
         </p:nvSpPr>
         <p:spPr>
           <a:xfrm>
-            <a:off x="804672" y="3172968"/>
-            <a:ext cx="5760720" cy="2587752"/>
+            <a:off x="804672" y="3355848"/>
+            <a:ext cx="5760720" cy="2404872"/>
           </a:xfrm>
           <a:prstGeom prst="roundRect">
             <a:avLst>
@@ -10782,7 +10787,7 @@
         </p:nvSpPr>
         <p:spPr>
           <a:xfrm>
-            <a:off x="1078992" y="3355848"/>
+            <a:off x="1078992" y="3538728"/>
             <a:ext cx="5212080" cy="274320"/>
           </a:xfrm>
           <a:prstGeom prst="rect">
@@ -10815,14 +10820,14 @@
       </p:sp>
       <p:sp>
         <p:nvSpPr>
-          <p:cNvPr id="1267" name="Big"/>
+          <p:cNvPr id="1267" name="Claim"/>
           <p:cNvSpPr txBox="1"/>
           <p:nvPr/>
         </p:nvSpPr>
         <p:spPr>
           <a:xfrm>
-            <a:off x="1078992" y="3557016"/>
-            <a:ext cx="2194560" cy="566928"/>
+            <a:off x="1078992" y="3794760"/>
+            <a:ext cx="5212080" cy="365760"/>
           </a:xfrm>
           <a:prstGeom prst="rect">
             <a:avLst/>
@@ -10833,60 +10838,70 @@
           </a:ln>
         </p:spPr>
         <p:txBody>
-          <a:bodyPr wrap="square" lIns="0" tIns="0" rIns="0" bIns="0" anchor="t">
+          <a:bodyPr wrap="square" lIns="0" tIns="0" rIns="0" bIns="0" anchor="ctr">
             <a:noAutofit/>
           </a:bodyPr>
           <a:lstStyle/>
           <a:p>
             <a:pPr algn="l"/>
             <a:r>
-              <a:rPr lang="en-US" sz="3400" b="1" i="0" dirty="0">
+              <a:rPr lang="en-US" sz="1800" b="1" i="0" dirty="0">
+                <a:solidFill>
+                  <a:srgbClr val="0B6E4F"/>
+                </a:solidFill>
+                <a:latin typeface="Calibri"/>
+                <a:cs typeface="Calibri"/>
+              </a:rPr>
+              <a:t xml:space="preserve">First on every table</a:t>
+            </a:r>
+            <a:r>
+              <a:rPr lang="en-US" sz="1500" b="0" i="0" dirty="0">
+                <a:solidFill>
+                  <a:srgbClr val="3A434C"/>
+                </a:solidFill>
+                <a:latin typeface="Calibri"/>
+                <a:cs typeface="Calibri"/>
+              </a:rPr>
+              <a:t xml:space="preserve">, in all three databases</a:t>
+            </a:r>
+          </a:p>
+        </p:txBody>
+      </p:sp>
+      <p:sp>
+        <p:nvSpPr>
+          <p:cNvPr id="1268" name="Database"/>
+          <p:cNvSpPr txBox="1"/>
+          <p:nvPr/>
+        </p:nvSpPr>
+        <p:spPr>
+          <a:xfrm>
+            <a:off x="2542032" y="4251960"/>
+            <a:ext cx="1243584" cy="219456"/>
+          </a:xfrm>
+          <a:prstGeom prst="rect">
+            <a:avLst/>
+          </a:prstGeom>
+          <a:noFill/>
+          <a:ln>
+            <a:noFill/>
+          </a:ln>
+        </p:spPr>
+        <p:txBody>
+          <a:bodyPr wrap="square" lIns="0" tIns="0" rIns="0" bIns="0" anchor="ctr">
+            <a:noAutofit/>
+          </a:bodyPr>
+          <a:lstStyle/>
+          <a:p>
+            <a:pPr algn="ctr"/>
+            <a:r>
+              <a:rPr lang="en-US" sz="1100" b="1" i="0" dirty="0">
                 <a:solidFill>
                   <a:srgbClr val="1F2328"/>
                 </a:solidFill>
-                <a:latin typeface="Cambria"/>
-                <a:cs typeface="Cambria"/>
-              </a:rPr>
-              <a:t xml:space="preserve">58 / 58</a:t>
-            </a:r>
-          </a:p>
-        </p:txBody>
-      </p:sp>
-      <p:sp>
-        <p:nvSpPr>
-          <p:cNvPr id="1268" name="Claim"/>
-          <p:cNvSpPr txBox="1"/>
-          <p:nvPr/>
-        </p:nvSpPr>
-        <p:spPr>
-          <a:xfrm>
-            <a:off x="3136391" y="3584448"/>
-            <a:ext cx="3200400" cy="502920"/>
-          </a:xfrm>
-          <a:prstGeom prst="rect">
-            <a:avLst/>
-          </a:prstGeom>
-          <a:noFill/>
-          <a:ln>
-            <a:noFill/>
-          </a:ln>
-        </p:spPr>
-        <p:txBody>
-          <a:bodyPr wrap="square" lIns="0" tIns="0" rIns="0" bIns="0" anchor="ctr">
-            <a:noAutofit/>
-          </a:bodyPr>
-          <a:lstStyle/>
-          <a:p>
-            <a:pPr algn="l"/>
-            <a:r>
-              <a:rPr lang="en-US" sz="1500" b="1" i="0" dirty="0">
-                <a:solidFill>
-                  <a:srgbClr val="0B6E4F"/>
-                </a:solidFill>
-                <a:latin typeface="Calibri"/>
-                <a:cs typeface="Calibri"/>
-              </a:rPr>
-              <a:t xml:space="preserve">tables with RIGOR ranked first</a:t>
+                <a:latin typeface="Calibri"/>
+                <a:cs typeface="Calibri"/>
+              </a:rPr>
+              <a:t xml:space="preserve">Liver Cancer</a:t>
             </a:r>
           </a:p>
         </p:txBody>
@@ -10899,8 +10914,8 @@
         </p:nvSpPr>
         <p:spPr>
           <a:xfrm>
-            <a:off x="2359152" y="4160520"/>
-            <a:ext cx="1298448" cy="219456"/>
+            <a:off x="3785615" y="4251960"/>
+            <a:ext cx="1243584" cy="219456"/>
           </a:xfrm>
           <a:prstGeom prst="rect">
             <a:avLst/>
@@ -10925,7 +10940,7 @@
                 <a:latin typeface="Calibri"/>
                 <a:cs typeface="Calibri"/>
               </a:rPr>
-              <a:t xml:space="preserve">Liver Cancer</a:t>
+              <a:t xml:space="preserve">eICU-CRD</a:t>
             </a:r>
           </a:p>
         </p:txBody>
@@ -10938,8 +10953,8 @@
         </p:nvSpPr>
         <p:spPr>
           <a:xfrm>
-            <a:off x="3657600" y="4160520"/>
-            <a:ext cx="1298448" cy="219456"/>
+            <a:off x="5029200" y="4251960"/>
+            <a:ext cx="1243584" cy="219456"/>
           </a:xfrm>
           <a:prstGeom prst="rect">
             <a:avLst/>
@@ -10964,21 +10979,21 @@
                 <a:latin typeface="Calibri"/>
                 <a:cs typeface="Calibri"/>
               </a:rPr>
-              <a:t xml:space="preserve">eICU-CRD</a:t>
-            </a:r>
-          </a:p>
-        </p:txBody>
-      </p:sp>
-      <p:sp>
-        <p:nvSpPr>
-          <p:cNvPr id="1271" name="Database"/>
+              <a:t xml:space="preserve">Chinook</a:t>
+            </a:r>
+          </a:p>
+        </p:txBody>
+      </p:sp>
+      <p:sp>
+        <p:nvSpPr>
+          <p:cNvPr id="1271" name="Method"/>
           <p:cNvSpPr txBox="1"/>
           <p:nvPr/>
         </p:nvSpPr>
         <p:spPr>
           <a:xfrm>
-            <a:off x="4956048" y="4160520"/>
-            <a:ext cx="1298448" cy="219456"/>
+            <a:off x="1033271" y="4507992"/>
+            <a:ext cx="1508760" cy="292608"/>
           </a:xfrm>
           <a:prstGeom prst="rect">
             <a:avLst/>
@@ -10994,55 +11009,57 @@
           </a:bodyPr>
           <a:lstStyle/>
           <a:p>
-            <a:pPr algn="ctr"/>
-            <a:r>
-              <a:rPr lang="en-US" sz="1100" b="1" i="0" dirty="0">
+            <a:pPr algn="l"/>
+            <a:r>
+              <a:rPr lang="en-US" sz="1200" b="0" i="0" dirty="0">
                 <a:solidFill>
                   <a:srgbClr val="1F2328"/>
                 </a:solidFill>
                 <a:latin typeface="Calibri"/>
                 <a:cs typeface="Calibri"/>
               </a:rPr>
-              <a:t xml:space="preserve">Chinook</a:t>
-            </a:r>
-          </a:p>
-        </p:txBody>
-      </p:sp>
-      <p:sp>
-        <p:nvSpPr>
-          <p:cNvPr id="1272" name="Method"/>
-          <p:cNvSpPr txBox="1"/>
-          <p:nvPr/>
-        </p:nvSpPr>
-        <p:spPr>
-          <a:xfrm>
-            <a:off x="1033271" y="4416552"/>
-            <a:ext cx="1325880" cy="310896"/>
-          </a:xfrm>
-          <a:prstGeom prst="rect">
-            <a:avLst/>
-          </a:prstGeom>
-          <a:noFill/>
-          <a:ln>
-            <a:noFill/>
-          </a:ln>
-        </p:spPr>
-        <p:txBody>
-          <a:bodyPr wrap="square" lIns="0" tIns="0" rIns="0" bIns="0" anchor="ctr">
-            <a:noAutofit/>
-          </a:bodyPr>
-          <a:lstStyle/>
-          <a:p>
-            <a:pPr algn="l"/>
-            <a:r>
-              <a:rPr lang="en-US" sz="1200" b="0" i="0" dirty="0">
+              <a:t xml:space="preserve">Direct Mapping</a:t>
+            </a:r>
+          </a:p>
+        </p:txBody>
+      </p:sp>
+      <p:sp>
+        <p:nvSpPr>
+          <p:cNvPr id="1272" name="Cell"/>
+          <p:cNvSpPr/>
+          <p:nvPr/>
+        </p:nvSpPr>
+        <p:spPr>
+          <a:xfrm>
+            <a:off x="2560320" y="4526280"/>
+            <a:ext cx="1207008" cy="256032"/>
+          </a:xfrm>
+          <a:prstGeom prst="rect">
+            <a:avLst/>
+          </a:prstGeom>
+          <a:solidFill>
+            <a:srgbClr val="F1F3F2"/>
+          </a:solidFill>
+          <a:ln>
+            <a:noFill/>
+          </a:ln>
+        </p:spPr>
+        <p:txBody>
+          <a:bodyPr wrap="square" lIns="0" tIns="0" rIns="0" bIns="0" anchor="ctr">
+            <a:noAutofit/>
+          </a:bodyPr>
+          <a:lstStyle/>
+          <a:p>
+            <a:pPr algn="ctr"/>
+            <a:r>
+              <a:rPr lang="en-US" sz="1100" b="0" i="0" dirty="0">
                 <a:solidFill>
                   <a:srgbClr val="1F2328"/>
                 </a:solidFill>
                 <a:latin typeface="Calibri"/>
                 <a:cs typeface="Calibri"/>
               </a:rPr>
-              <a:t xml:space="preserve">Direct Mapping</a:t>
+              <a:t xml:space="preserve">2.05</a:t>
             </a:r>
           </a:p>
         </p:txBody>
@@ -11055,8 +11072,8 @@
         </p:nvSpPr>
         <p:spPr>
           <a:xfrm>
-            <a:off x="2377440" y="4434840"/>
-            <a:ext cx="1261872" cy="274320"/>
+            <a:off x="3803903" y="4526280"/>
+            <a:ext cx="1207008" cy="256032"/>
           </a:xfrm>
           <a:prstGeom prst="rect">
             <a:avLst/>
@@ -11083,7 +11100,7 @@
                 <a:latin typeface="Calibri"/>
                 <a:cs typeface="Calibri"/>
               </a:rPr>
-              <a:t xml:space="preserve">2.05</a:t>
+              <a:t xml:space="preserve">2.13</a:t>
             </a:r>
           </a:p>
         </p:txBody>
@@ -11096,14 +11113,14 @@
         </p:nvSpPr>
         <p:spPr>
           <a:xfrm>
-            <a:off x="3675887" y="4434840"/>
-            <a:ext cx="1261872" cy="274320"/>
-          </a:xfrm>
-          <a:prstGeom prst="rect">
-            <a:avLst/>
-          </a:prstGeom>
-          <a:solidFill>
-            <a:srgbClr val="F1F3F2"/>
+            <a:off x="5047488" y="4526280"/>
+            <a:ext cx="1207008" cy="256032"/>
+          </a:xfrm>
+          <a:prstGeom prst="rect">
+            <a:avLst/>
+          </a:prstGeom>
+          <a:solidFill>
+            <a:srgbClr val="EDB8AC"/>
           </a:solidFill>
           <a:ln>
             <a:noFill/>
@@ -11124,27 +11141,66 @@
                 <a:latin typeface="Calibri"/>
                 <a:cs typeface="Calibri"/>
               </a:rPr>
-              <a:t xml:space="preserve">2.13</a:t>
-            </a:r>
-          </a:p>
-        </p:txBody>
-      </p:sp>
-      <p:sp>
-        <p:nvSpPr>
-          <p:cNvPr id="1275" name="Cell"/>
+              <a:t xml:space="preserve">0.13</a:t>
+            </a:r>
+          </a:p>
+        </p:txBody>
+      </p:sp>
+      <p:sp>
+        <p:nvSpPr>
+          <p:cNvPr id="1275" name="Method"/>
+          <p:cNvSpPr txBox="1"/>
+          <p:nvPr/>
+        </p:nvSpPr>
+        <p:spPr>
+          <a:xfrm>
+            <a:off x="1033271" y="4800600"/>
+            <a:ext cx="1508760" cy="292608"/>
+          </a:xfrm>
+          <a:prstGeom prst="rect">
+            <a:avLst/>
+          </a:prstGeom>
+          <a:noFill/>
+          <a:ln>
+            <a:noFill/>
+          </a:ln>
+        </p:spPr>
+        <p:txBody>
+          <a:bodyPr wrap="square" lIns="0" tIns="0" rIns="0" bIns="0" anchor="ctr">
+            <a:noAutofit/>
+          </a:bodyPr>
+          <a:lstStyle/>
+          <a:p>
+            <a:pPr algn="l"/>
+            <a:r>
+              <a:rPr lang="en-US" sz="1200" b="0" i="0" dirty="0">
+                <a:solidFill>
+                  <a:srgbClr val="1F2328"/>
+                </a:solidFill>
+                <a:latin typeface="Calibri"/>
+                <a:cs typeface="Calibri"/>
+              </a:rPr>
+              <a:t xml:space="preserve">LLM baseline</a:t>
+            </a:r>
+          </a:p>
+        </p:txBody>
+      </p:sp>
+      <p:sp>
+        <p:nvSpPr>
+          <p:cNvPr id="1276" name="Cell"/>
           <p:cNvSpPr/>
           <p:nvPr/>
         </p:nvSpPr>
         <p:spPr>
           <a:xfrm>
-            <a:off x="4974336" y="4434840"/>
-            <a:ext cx="1261872" cy="274320"/>
-          </a:xfrm>
-          <a:prstGeom prst="rect">
-            <a:avLst/>
-          </a:prstGeom>
-          <a:solidFill>
-            <a:srgbClr val="EDB8AC"/>
+            <a:off x="2560320" y="4818888"/>
+            <a:ext cx="1207008" cy="256032"/>
+          </a:xfrm>
+          <a:prstGeom prst="rect">
+            <a:avLst/>
+          </a:prstGeom>
+          <a:solidFill>
+            <a:srgbClr val="F6DAD3"/>
           </a:solidFill>
           <a:ln>
             <a:noFill/>
@@ -11165,46 +11221,7 @@
                 <a:latin typeface="Calibri"/>
                 <a:cs typeface="Calibri"/>
               </a:rPr>
-              <a:t xml:space="preserve">0.13</a:t>
-            </a:r>
-          </a:p>
-        </p:txBody>
-      </p:sp>
-      <p:sp>
-        <p:nvSpPr>
-          <p:cNvPr id="1276" name="Method"/>
-          <p:cNvSpPr txBox="1"/>
-          <p:nvPr/>
-        </p:nvSpPr>
-        <p:spPr>
-          <a:xfrm>
-            <a:off x="1033271" y="4727448"/>
-            <a:ext cx="1325880" cy="310896"/>
-          </a:xfrm>
-          <a:prstGeom prst="rect">
-            <a:avLst/>
-          </a:prstGeom>
-          <a:noFill/>
-          <a:ln>
-            <a:noFill/>
-          </a:ln>
-        </p:spPr>
-        <p:txBody>
-          <a:bodyPr wrap="square" lIns="0" tIns="0" rIns="0" bIns="0" anchor="ctr">
-            <a:noAutofit/>
-          </a:bodyPr>
-          <a:lstStyle/>
-          <a:p>
-            <a:pPr algn="l"/>
-            <a:r>
-              <a:rPr lang="en-US" sz="1200" b="0" i="0" dirty="0">
-                <a:solidFill>
-                  <a:srgbClr val="1F2328"/>
-                </a:solidFill>
-                <a:latin typeface="Calibri"/>
-                <a:cs typeface="Calibri"/>
-              </a:rPr>
-              <a:t xml:space="preserve">LLM baseline</a:t>
+              <a:t xml:space="preserve">1.38</a:t>
             </a:r>
           </a:p>
         </p:txBody>
@@ -11217,14 +11234,14 @@
         </p:nvSpPr>
         <p:spPr>
           <a:xfrm>
-            <a:off x="2377440" y="4745736"/>
-            <a:ext cx="1261872" cy="274320"/>
-          </a:xfrm>
-          <a:prstGeom prst="rect">
-            <a:avLst/>
-          </a:prstGeom>
-          <a:solidFill>
-            <a:srgbClr val="F6DAD3"/>
+            <a:off x="3803903" y="4818888"/>
+            <a:ext cx="1207008" cy="256032"/>
+          </a:xfrm>
+          <a:prstGeom prst="rect">
+            <a:avLst/>
+          </a:prstGeom>
+          <a:solidFill>
+            <a:srgbClr val="EDB8AC"/>
           </a:solidFill>
           <a:ln>
             <a:noFill/>
@@ -11245,7 +11262,7 @@
                 <a:latin typeface="Calibri"/>
                 <a:cs typeface="Calibri"/>
               </a:rPr>
-              <a:t xml:space="preserve">1.38</a:t>
+              <a:t xml:space="preserve">0.28</a:t>
             </a:r>
           </a:p>
         </p:txBody>
@@ -11258,14 +11275,14 @@
         </p:nvSpPr>
         <p:spPr>
           <a:xfrm>
-            <a:off x="3675887" y="4745736"/>
-            <a:ext cx="1261872" cy="274320"/>
-          </a:xfrm>
-          <a:prstGeom prst="rect">
-            <a:avLst/>
-          </a:prstGeom>
-          <a:solidFill>
-            <a:srgbClr val="EDB8AC"/>
+            <a:off x="5047488" y="4818888"/>
+            <a:ext cx="1207008" cy="256032"/>
+          </a:xfrm>
+          <a:prstGeom prst="rect">
+            <a:avLst/>
+          </a:prstGeom>
+          <a:solidFill>
+            <a:srgbClr val="F6DAD3"/>
           </a:solidFill>
           <a:ln>
             <a:noFill/>
@@ -11286,21 +11303,60 @@
                 <a:latin typeface="Calibri"/>
                 <a:cs typeface="Calibri"/>
               </a:rPr>
-              <a:t xml:space="preserve">0.28</a:t>
-            </a:r>
-          </a:p>
-        </p:txBody>
-      </p:sp>
-      <p:sp>
-        <p:nvSpPr>
-          <p:cNvPr id="1279" name="Cell"/>
+              <a:t xml:space="preserve">1.48</a:t>
+            </a:r>
+          </a:p>
+        </p:txBody>
+      </p:sp>
+      <p:sp>
+        <p:nvSpPr>
+          <p:cNvPr id="1279" name="Method"/>
+          <p:cNvSpPr txBox="1"/>
+          <p:nvPr/>
+        </p:nvSpPr>
+        <p:spPr>
+          <a:xfrm>
+            <a:off x="1033271" y="5093208"/>
+            <a:ext cx="1508760" cy="292608"/>
+          </a:xfrm>
+          <a:prstGeom prst="rect">
+            <a:avLst/>
+          </a:prstGeom>
+          <a:noFill/>
+          <a:ln>
+            <a:noFill/>
+          </a:ln>
+        </p:spPr>
+        <p:txBody>
+          <a:bodyPr wrap="square" lIns="0" tIns="0" rIns="0" bIns="0" anchor="ctr">
+            <a:noAutofit/>
+          </a:bodyPr>
+          <a:lstStyle/>
+          <a:p>
+            <a:pPr algn="l"/>
+            <a:r>
+              <a:rPr lang="en-US" sz="1200" b="0" i="0" dirty="0">
+                <a:solidFill>
+                  <a:srgbClr val="1F2328"/>
+                </a:solidFill>
+                <a:latin typeface="Calibri"/>
+                <a:cs typeface="Calibri"/>
+              </a:rPr>
+              <a:t xml:space="preserve">Non-Iterative RAG</a:t>
+            </a:r>
+          </a:p>
+        </p:txBody>
+      </p:sp>
+      <p:sp>
+        <p:nvSpPr>
+          <p:cNvPr id="1280" name="Cell"/>
           <p:cNvSpPr/>
           <p:nvPr/>
         </p:nvSpPr>
         <p:spPr>
           <a:xfrm>
-            <a:off x="4974336" y="4745736"/>
-            <a:ext cx="1261872" cy="274320"/>
+            <a:off x="2560320" y="5111496"/>
+            <a:ext cx="1207008" cy="256032"/>
           </a:xfrm>
           <a:prstGeom prst="rect">
             <a:avLst/>
@@ -11327,46 +11383,7 @@
                 <a:latin typeface="Calibri"/>
                 <a:cs typeface="Calibri"/>
               </a:rPr>
-              <a:t xml:space="preserve">1.48</a:t>
-            </a:r>
-          </a:p>
-        </p:txBody>
-      </p:sp>
-      <p:sp>
-        <p:nvSpPr>
-          <p:cNvPr id="1280" name="Method"/>
-          <p:cNvSpPr txBox="1"/>
-          <p:nvPr/>
-        </p:nvSpPr>
-        <p:spPr>
-          <a:xfrm>
-            <a:off x="1033271" y="5038344"/>
-            <a:ext cx="1325880" cy="310896"/>
-          </a:xfrm>
-          <a:prstGeom prst="rect">
-            <a:avLst/>
-          </a:prstGeom>
-          <a:noFill/>
-          <a:ln>
-            <a:noFill/>
-          </a:ln>
-        </p:spPr>
-        <p:txBody>
-          <a:bodyPr wrap="square" lIns="0" tIns="0" rIns="0" bIns="0" anchor="ctr">
-            <a:noAutofit/>
-          </a:bodyPr>
-          <a:lstStyle/>
-          <a:p>
-            <a:pPr algn="l"/>
-            <a:r>
-              <a:rPr lang="en-US" sz="1200" b="0" i="0" dirty="0">
-                <a:solidFill>
-                  <a:srgbClr val="1F2328"/>
-                </a:solidFill>
-                <a:latin typeface="Calibri"/>
-                <a:cs typeface="Calibri"/>
-              </a:rPr>
-              <a:t xml:space="preserve">Non-Iterative</a:t>
+              <a:t xml:space="preserve">1.89</a:t>
             </a:r>
           </a:p>
         </p:txBody>
@@ -11379,14 +11396,14 @@
         </p:nvSpPr>
         <p:spPr>
           <a:xfrm>
-            <a:off x="2377440" y="5056632"/>
-            <a:ext cx="1261872" cy="274320"/>
-          </a:xfrm>
-          <a:prstGeom prst="rect">
-            <a:avLst/>
-          </a:prstGeom>
-          <a:solidFill>
-            <a:srgbClr val="F6DAD3"/>
+            <a:off x="3803903" y="5111496"/>
+            <a:ext cx="1207008" cy="256032"/>
+          </a:xfrm>
+          <a:prstGeom prst="rect">
+            <a:avLst/>
+          </a:prstGeom>
+          <a:solidFill>
+            <a:srgbClr val="EDB8AC"/>
           </a:solidFill>
           <a:ln>
             <a:noFill/>
@@ -11407,7 +11424,7 @@
                 <a:latin typeface="Calibri"/>
                 <a:cs typeface="Calibri"/>
               </a:rPr>
-              <a:t xml:space="preserve">1.89</a:t>
+              <a:t xml:space="preserve">0.67</a:t>
             </a:r>
           </a:p>
         </p:txBody>
@@ -11420,14 +11437,14 @@
         </p:nvSpPr>
         <p:spPr>
           <a:xfrm>
-            <a:off x="3675887" y="5056632"/>
-            <a:ext cx="1261872" cy="274320"/>
-          </a:xfrm>
-          <a:prstGeom prst="rect">
-            <a:avLst/>
-          </a:prstGeom>
-          <a:solidFill>
-            <a:srgbClr val="EDB8AC"/>
+            <a:off x="5047488" y="5111496"/>
+            <a:ext cx="1207008" cy="256032"/>
+          </a:xfrm>
+          <a:prstGeom prst="rect">
+            <a:avLst/>
+          </a:prstGeom>
+          <a:solidFill>
+            <a:srgbClr val="F1F3F2"/>
           </a:solidFill>
           <a:ln>
             <a:noFill/>
@@ -11448,87 +11465,87 @@
                 <a:latin typeface="Calibri"/>
                 <a:cs typeface="Calibri"/>
               </a:rPr>
-              <a:t xml:space="preserve">0.67</a:t>
-            </a:r>
-          </a:p>
-        </p:txBody>
-      </p:sp>
-      <p:sp>
-        <p:nvSpPr>
-          <p:cNvPr id="1283" name="Cell"/>
+              <a:t xml:space="preserve">2.77</a:t>
+            </a:r>
+          </a:p>
+        </p:txBody>
+      </p:sp>
+      <p:sp>
+        <p:nvSpPr>
+          <p:cNvPr id="1283" name="Method"/>
+          <p:cNvSpPr txBox="1"/>
+          <p:nvPr/>
+        </p:nvSpPr>
+        <p:spPr>
+          <a:xfrm>
+            <a:off x="1033271" y="5385816"/>
+            <a:ext cx="1508760" cy="292608"/>
+          </a:xfrm>
+          <a:prstGeom prst="rect">
+            <a:avLst/>
+          </a:prstGeom>
+          <a:noFill/>
+          <a:ln>
+            <a:noFill/>
+          </a:ln>
+        </p:spPr>
+        <p:txBody>
+          <a:bodyPr wrap="square" lIns="0" tIns="0" rIns="0" bIns="0" anchor="ctr">
+            <a:noAutofit/>
+          </a:bodyPr>
+          <a:lstStyle/>
+          <a:p>
+            <a:pPr algn="l"/>
+            <a:r>
+              <a:rPr lang="en-US" sz="1200" b="1" i="0" dirty="0">
+                <a:solidFill>
+                  <a:srgbClr val="0B6E4F"/>
+                </a:solidFill>
+                <a:latin typeface="Calibri"/>
+                <a:cs typeface="Calibri"/>
+              </a:rPr>
+              <a:t xml:space="preserve">RIGOR</a:t>
+            </a:r>
+          </a:p>
+        </p:txBody>
+      </p:sp>
+      <p:sp>
+        <p:nvSpPr>
+          <p:cNvPr id="1284" name="Cell"/>
           <p:cNvSpPr/>
           <p:nvPr/>
         </p:nvSpPr>
         <p:spPr>
           <a:xfrm>
-            <a:off x="4974336" y="5056632"/>
-            <a:ext cx="1261872" cy="274320"/>
-          </a:xfrm>
-          <a:prstGeom prst="rect">
-            <a:avLst/>
-          </a:prstGeom>
-          <a:solidFill>
-            <a:srgbClr val="F1F3F2"/>
-          </a:solidFill>
-          <a:ln>
-            <a:noFill/>
-          </a:ln>
-        </p:spPr>
-        <p:txBody>
-          <a:bodyPr wrap="square" lIns="0" tIns="0" rIns="0" bIns="0" anchor="ctr">
-            <a:noAutofit/>
-          </a:bodyPr>
-          <a:lstStyle/>
-          <a:p>
-            <a:pPr algn="ctr"/>
-            <a:r>
-              <a:rPr lang="en-US" sz="1100" b="0" i="0" dirty="0">
+            <a:off x="2560320" y="5404104"/>
+            <a:ext cx="1207008" cy="256032"/>
+          </a:xfrm>
+          <a:prstGeom prst="rect">
+            <a:avLst/>
+          </a:prstGeom>
+          <a:solidFill>
+            <a:srgbClr val="BFE3CF"/>
+          </a:solidFill>
+          <a:ln>
+            <a:noFill/>
+          </a:ln>
+        </p:spPr>
+        <p:txBody>
+          <a:bodyPr wrap="square" lIns="0" tIns="0" rIns="0" bIns="0" anchor="ctr">
+            <a:noAutofit/>
+          </a:bodyPr>
+          <a:lstStyle/>
+          <a:p>
+            <a:pPr algn="ctr"/>
+            <a:r>
+              <a:rPr lang="en-US" sz="1100" b="1" i="0" dirty="0">
                 <a:solidFill>
                   <a:srgbClr val="1F2328"/>
                 </a:solidFill>
                 <a:latin typeface="Calibri"/>
                 <a:cs typeface="Calibri"/>
               </a:rPr>
-              <a:t xml:space="preserve">2.77</a:t>
-            </a:r>
-          </a:p>
-        </p:txBody>
-      </p:sp>
-      <p:sp>
-        <p:nvSpPr>
-          <p:cNvPr id="1284" name="Method"/>
-          <p:cNvSpPr txBox="1"/>
-          <p:nvPr/>
-        </p:nvSpPr>
-        <p:spPr>
-          <a:xfrm>
-            <a:off x="1033271" y="5349240"/>
-            <a:ext cx="1325880" cy="310896"/>
-          </a:xfrm>
-          <a:prstGeom prst="rect">
-            <a:avLst/>
-          </a:prstGeom>
-          <a:noFill/>
-          <a:ln>
-            <a:noFill/>
-          </a:ln>
-        </p:spPr>
-        <p:txBody>
-          <a:bodyPr wrap="square" lIns="0" tIns="0" rIns="0" bIns="0" anchor="ctr">
-            <a:noAutofit/>
-          </a:bodyPr>
-          <a:lstStyle/>
-          <a:p>
-            <a:pPr algn="l"/>
-            <a:r>
-              <a:rPr lang="en-US" sz="1200" b="1" i="0" dirty="0">
-                <a:solidFill>
-                  <a:srgbClr val="0B6E4F"/>
-                </a:solidFill>
-                <a:latin typeface="Calibri"/>
-                <a:cs typeface="Calibri"/>
-              </a:rPr>
-              <a:t xml:space="preserve">RIGOR</a:t>
+              <a:t xml:space="preserve">3.93</a:t>
             </a:r>
           </a:p>
         </p:txBody>
@@ -11541,8 +11558,8 @@
         </p:nvSpPr>
         <p:spPr>
           <a:xfrm>
-            <a:off x="2377440" y="5367528"/>
-            <a:ext cx="1261872" cy="274320"/>
+            <a:off x="3803903" y="5404104"/>
+            <a:ext cx="1207008" cy="256032"/>
           </a:xfrm>
           <a:prstGeom prst="rect">
             <a:avLst/>
@@ -11569,7 +11586,7 @@
                 <a:latin typeface="Calibri"/>
                 <a:cs typeface="Calibri"/>
               </a:rPr>
-              <a:t xml:space="preserve">3.93</a:t>
+              <a:t xml:space="preserve">3.64</a:t>
             </a:r>
           </a:p>
         </p:txBody>
@@ -11582,14 +11599,14 @@
         </p:nvSpPr>
         <p:spPr>
           <a:xfrm>
-            <a:off x="3675887" y="5367528"/>
-            <a:ext cx="1261872" cy="274320"/>
-          </a:xfrm>
-          <a:prstGeom prst="rect">
-            <a:avLst/>
-          </a:prstGeom>
-          <a:solidFill>
-            <a:srgbClr val="BFE3CF"/>
+            <a:off x="5047488" y="5404104"/>
+            <a:ext cx="1207008" cy="256032"/>
+          </a:xfrm>
+          <a:prstGeom prst="rect">
+            <a:avLst/>
+          </a:prstGeom>
+          <a:solidFill>
+            <a:srgbClr val="DDF0E5"/>
           </a:solidFill>
           <a:ln>
             <a:noFill/>
@@ -11610,62 +11627,21 @@
                 <a:latin typeface="Calibri"/>
                 <a:cs typeface="Calibri"/>
               </a:rPr>
-              <a:t xml:space="preserve">3.64</a:t>
-            </a:r>
-          </a:p>
-        </p:txBody>
-      </p:sp>
-      <p:sp>
-        <p:nvSpPr>
-          <p:cNvPr id="1287" name="Cell"/>
+              <a:t xml:space="preserve">3.32</a:t>
+            </a:r>
+          </a:p>
+        </p:txBody>
+      </p:sp>
+      <p:sp>
+        <p:nvSpPr>
+          <p:cNvPr id="1287" name="Card"/>
           <p:cNvSpPr/>
           <p:nvPr/>
         </p:nvSpPr>
         <p:spPr>
           <a:xfrm>
-            <a:off x="4974336" y="5367528"/>
-            <a:ext cx="1261872" cy="274320"/>
-          </a:xfrm>
-          <a:prstGeom prst="rect">
-            <a:avLst/>
-          </a:prstGeom>
-          <a:solidFill>
-            <a:srgbClr val="DDF0E5"/>
-          </a:solidFill>
-          <a:ln>
-            <a:noFill/>
-          </a:ln>
-        </p:spPr>
-        <p:txBody>
-          <a:bodyPr wrap="square" lIns="0" tIns="0" rIns="0" bIns="0" anchor="ctr">
-            <a:noAutofit/>
-          </a:bodyPr>
-          <a:lstStyle/>
-          <a:p>
-            <a:pPr algn="ctr"/>
-            <a:r>
-              <a:rPr lang="en-US" sz="1100" b="1" i="0" dirty="0">
-                <a:solidFill>
-                  <a:srgbClr val="1F2328"/>
-                </a:solidFill>
-                <a:latin typeface="Calibri"/>
-                <a:cs typeface="Calibri"/>
-              </a:rPr>
-              <a:t xml:space="preserve">3.32</a:t>
-            </a:r>
-          </a:p>
-        </p:txBody>
-      </p:sp>
-      <p:sp>
-        <p:nvSpPr>
-          <p:cNvPr id="1288" name="Card"/>
-          <p:cNvSpPr/>
-          <p:nvPr/>
-        </p:nvSpPr>
-        <p:spPr>
-          <a:xfrm>
-            <a:off x="6702552" y="3172968"/>
-            <a:ext cx="4681728" cy="2587752"/>
+            <a:off x="6702552" y="3355848"/>
+            <a:ext cx="4681728" cy="2404872"/>
           </a:xfrm>
           <a:prstGeom prst="roundRect">
             <a:avLst>
@@ -11693,13 +11669,13 @@
       </p:sp>
       <p:sp>
         <p:nvSpPr>
-          <p:cNvPr id="1289" name="Card label"/>
+          <p:cNvPr id="1288" name="Card label"/>
           <p:cNvSpPr txBox="1"/>
           <p:nvPr/>
         </p:nvSpPr>
         <p:spPr>
           <a:xfrm>
-            <a:off x="6976872" y="3355848"/>
+            <a:off x="6976872" y="3538728"/>
             <a:ext cx="4133088" cy="274320"/>
           </a:xfrm>
           <a:prstGeom prst="rect">
@@ -11732,14 +11708,14 @@
       </p:sp>
       <p:sp>
         <p:nvSpPr>
-          <p:cNvPr id="1290" name="Big"/>
+          <p:cNvPr id="1289" name="Claim"/>
           <p:cNvSpPr txBox="1"/>
           <p:nvPr/>
         </p:nvSpPr>
         <p:spPr>
           <a:xfrm>
-            <a:off x="6976872" y="3557016"/>
-            <a:ext cx="2194560" cy="566928"/>
+            <a:off x="6976872" y="3794760"/>
+            <a:ext cx="4133088" cy="365760"/>
           </a:xfrm>
           <a:prstGeom prst="rect">
             <a:avLst/>
@@ -11750,35 +11726,74 @@
           </a:ln>
         </p:spPr>
         <p:txBody>
-          <a:bodyPr wrap="square" lIns="0" tIns="0" rIns="0" bIns="0" anchor="t">
+          <a:bodyPr wrap="square" lIns="0" tIns="0" rIns="0" bIns="0" anchor="ctr">
             <a:noAutofit/>
           </a:bodyPr>
           <a:lstStyle/>
           <a:p>
             <a:pPr algn="l"/>
             <a:r>
-              <a:rPr lang="en-US" sz="3400" b="1" i="0" dirty="0">
+              <a:rPr lang="en-US" sz="1800" b="1" i="0" dirty="0">
+                <a:solidFill>
+                  <a:srgbClr val="0B6E4F"/>
+                </a:solidFill>
+                <a:latin typeface="Calibri"/>
+                <a:cs typeface="Calibri"/>
+              </a:rPr>
+              <a:t xml:space="preserve">First in 7 of 10 rankings</a:t>
+            </a:r>
+          </a:p>
+        </p:txBody>
+      </p:sp>
+      <p:sp>
+        <p:nvSpPr>
+          <p:cNvPr id="1290" name="Database"/>
+          <p:cNvSpPr txBox="1"/>
+          <p:nvPr/>
+        </p:nvSpPr>
+        <p:spPr>
+          <a:xfrm>
+            <a:off x="8439912" y="4251960"/>
+            <a:ext cx="1353312" cy="219456"/>
+          </a:xfrm>
+          <a:prstGeom prst="rect">
+            <a:avLst/>
+          </a:prstGeom>
+          <a:noFill/>
+          <a:ln>
+            <a:noFill/>
+          </a:ln>
+        </p:spPr>
+        <p:txBody>
+          <a:bodyPr wrap="square" lIns="0" tIns="0" rIns="0" bIns="0" anchor="ctr">
+            <a:noAutofit/>
+          </a:bodyPr>
+          <a:lstStyle/>
+          <a:p>
+            <a:pPr algn="ctr"/>
+            <a:r>
+              <a:rPr lang="en-US" sz="1100" b="1" i="0" dirty="0">
                 <a:solidFill>
                   <a:srgbClr val="1F2328"/>
                 </a:solidFill>
-                <a:latin typeface="Cambria"/>
-                <a:cs typeface="Cambria"/>
-              </a:rPr>
-              <a:t xml:space="preserve">28 / 40</a:t>
-            </a:r>
-          </a:p>
-        </p:txBody>
-      </p:sp>
-      <p:sp>
-        <p:nvSpPr>
-          <p:cNvPr id="1291" name="Claim"/>
+                <a:latin typeface="Calibri"/>
+                <a:cs typeface="Calibri"/>
+              </a:rPr>
+              <a:t xml:space="preserve">Liver Cancer</a:t>
+            </a:r>
+          </a:p>
+        </p:txBody>
+      </p:sp>
+      <p:sp>
+        <p:nvSpPr>
+          <p:cNvPr id="1291" name="Database"/>
           <p:cNvSpPr txBox="1"/>
           <p:nvPr/>
         </p:nvSpPr>
         <p:spPr>
           <a:xfrm>
-            <a:off x="8942832" y="3584448"/>
-            <a:ext cx="2304288" cy="502920"/>
+            <a:off x="9793224" y="4251960"/>
+            <a:ext cx="1353312" cy="219456"/>
           </a:xfrm>
           <a:prstGeom prst="rect">
             <a:avLst/>
@@ -11794,30 +11809,151 @@
           </a:bodyPr>
           <a:lstStyle/>
           <a:p>
+            <a:pPr algn="ctr"/>
+            <a:r>
+              <a:rPr lang="en-US" sz="1100" b="1" i="0" dirty="0">
+                <a:solidFill>
+                  <a:srgbClr val="1F2328"/>
+                </a:solidFill>
+                <a:latin typeface="Calibri"/>
+                <a:cs typeface="Calibri"/>
+              </a:rPr>
+              <a:t xml:space="preserve">eICU-CRD</a:t>
+            </a:r>
+          </a:p>
+        </p:txBody>
+      </p:sp>
+      <p:sp>
+        <p:nvSpPr>
+          <p:cNvPr id="1292" name="Method"/>
+          <p:cNvSpPr txBox="1"/>
+          <p:nvPr/>
+        </p:nvSpPr>
+        <p:spPr>
+          <a:xfrm>
+            <a:off x="6931152" y="4507992"/>
+            <a:ext cx="1508760" cy="292608"/>
+          </a:xfrm>
+          <a:prstGeom prst="rect">
+            <a:avLst/>
+          </a:prstGeom>
+          <a:noFill/>
+          <a:ln>
+            <a:noFill/>
+          </a:ln>
+        </p:spPr>
+        <p:txBody>
+          <a:bodyPr wrap="square" lIns="0" tIns="0" rIns="0" bIns="0" anchor="ctr">
+            <a:noAutofit/>
+          </a:bodyPr>
+          <a:lstStyle/>
+          <a:p>
             <a:pPr algn="l"/>
             <a:r>
-              <a:rPr lang="en-US" sz="1500" b="1" i="0" dirty="0">
-                <a:solidFill>
-                  <a:srgbClr val="0B6E4F"/>
-                </a:solidFill>
-                <a:latin typeface="Calibri"/>
-                <a:cs typeface="Calibri"/>
-              </a:rPr>
-              <a:t xml:space="preserve">rankings with RIGOR first (70%)</a:t>
-            </a:r>
-          </a:p>
-        </p:txBody>
-      </p:sp>
-      <p:sp>
-        <p:nvSpPr>
-          <p:cNvPr id="1292" name="Database"/>
+              <a:rPr lang="en-US" sz="1200" b="0" i="0" dirty="0">
+                <a:solidFill>
+                  <a:srgbClr val="1F2328"/>
+                </a:solidFill>
+                <a:latin typeface="Calibri"/>
+                <a:cs typeface="Calibri"/>
+              </a:rPr>
+              <a:t xml:space="preserve">Direct Mapping</a:t>
+            </a:r>
+          </a:p>
+        </p:txBody>
+      </p:sp>
+      <p:sp>
+        <p:nvSpPr>
+          <p:cNvPr id="1293" name="Cell"/>
+          <p:cNvSpPr/>
+          <p:nvPr/>
+        </p:nvSpPr>
+        <p:spPr>
+          <a:xfrm>
+            <a:off x="8458200" y="4526280"/>
+            <a:ext cx="1316736" cy="256032"/>
+          </a:xfrm>
+          <a:prstGeom prst="rect">
+            <a:avLst/>
+          </a:prstGeom>
+          <a:solidFill>
+            <a:srgbClr val="F1F3F2"/>
+          </a:solidFill>
+          <a:ln>
+            <a:noFill/>
+          </a:ln>
+        </p:spPr>
+        <p:txBody>
+          <a:bodyPr wrap="square" lIns="0" tIns="0" rIns="0" bIns="0" anchor="ctr">
+            <a:noAutofit/>
+          </a:bodyPr>
+          <a:lstStyle/>
+          <a:p>
+            <a:pPr algn="ctr"/>
+            <a:r>
+              <a:rPr lang="en-US" sz="1100" b="0" i="0" dirty="0">
+                <a:solidFill>
+                  <a:srgbClr val="1F2328"/>
+                </a:solidFill>
+                <a:latin typeface="Calibri"/>
+                <a:cs typeface="Calibri"/>
+              </a:rPr>
+              <a:t xml:space="preserve">2.95</a:t>
+            </a:r>
+          </a:p>
+        </p:txBody>
+      </p:sp>
+      <p:sp>
+        <p:nvSpPr>
+          <p:cNvPr id="1294" name="Cell"/>
+          <p:cNvSpPr/>
+          <p:nvPr/>
+        </p:nvSpPr>
+        <p:spPr>
+          <a:xfrm>
+            <a:off x="9811512" y="4526280"/>
+            <a:ext cx="1316736" cy="256032"/>
+          </a:xfrm>
+          <a:prstGeom prst="rect">
+            <a:avLst/>
+          </a:prstGeom>
+          <a:solidFill>
+            <a:srgbClr val="F1F3F2"/>
+          </a:solidFill>
+          <a:ln>
+            <a:noFill/>
+          </a:ln>
+        </p:spPr>
+        <p:txBody>
+          <a:bodyPr wrap="square" lIns="0" tIns="0" rIns="0" bIns="0" anchor="ctr">
+            <a:noAutofit/>
+          </a:bodyPr>
+          <a:lstStyle/>
+          <a:p>
+            <a:pPr algn="ctr"/>
+            <a:r>
+              <a:rPr lang="en-US" sz="1100" b="0" i="0" dirty="0">
+                <a:solidFill>
+                  <a:srgbClr val="1F2328"/>
+                </a:solidFill>
+                <a:latin typeface="Calibri"/>
+                <a:cs typeface="Calibri"/>
+              </a:rPr>
+              <a:t xml:space="preserve">2.59</a:t>
+            </a:r>
+          </a:p>
+        </p:txBody>
+      </p:sp>
+      <p:sp>
+        <p:nvSpPr>
+          <p:cNvPr id="1295" name="Method"/>
           <p:cNvSpPr txBox="1"/>
           <p:nvPr/>
         </p:nvSpPr>
         <p:spPr>
           <a:xfrm>
-            <a:off x="8257031" y="4160520"/>
-            <a:ext cx="1417320" cy="219456"/>
+            <a:off x="6931152" y="4800600"/>
+            <a:ext cx="1508760" cy="292608"/>
           </a:xfrm>
           <a:prstGeom prst="rect">
             <a:avLst/>
@@ -11833,135 +11969,16 @@
           </a:bodyPr>
           <a:lstStyle/>
           <a:p>
-            <a:pPr algn="ctr"/>
-            <a:r>
-              <a:rPr lang="en-US" sz="1100" b="1" i="0" dirty="0">
+            <a:pPr algn="l"/>
+            <a:r>
+              <a:rPr lang="en-US" sz="1200" b="0" i="0" dirty="0">
                 <a:solidFill>
                   <a:srgbClr val="1F2328"/>
                 </a:solidFill>
                 <a:latin typeface="Calibri"/>
                 <a:cs typeface="Calibri"/>
               </a:rPr>
-              <a:t xml:space="preserve">Liver Cancer</a:t>
-            </a:r>
-          </a:p>
-        </p:txBody>
-      </p:sp>
-      <p:sp>
-        <p:nvSpPr>
-          <p:cNvPr id="1293" name="Database"/>
-          <p:cNvSpPr txBox="1"/>
-          <p:nvPr/>
-        </p:nvSpPr>
-        <p:spPr>
-          <a:xfrm>
-            <a:off x="9674352" y="4160520"/>
-            <a:ext cx="1417320" cy="219456"/>
-          </a:xfrm>
-          <a:prstGeom prst="rect">
-            <a:avLst/>
-          </a:prstGeom>
-          <a:noFill/>
-          <a:ln>
-            <a:noFill/>
-          </a:ln>
-        </p:spPr>
-        <p:txBody>
-          <a:bodyPr wrap="square" lIns="0" tIns="0" rIns="0" bIns="0" anchor="ctr">
-            <a:noAutofit/>
-          </a:bodyPr>
-          <a:lstStyle/>
-          <a:p>
-            <a:pPr algn="ctr"/>
-            <a:r>
-              <a:rPr lang="en-US" sz="1100" b="1" i="0" dirty="0">
-                <a:solidFill>
-                  <a:srgbClr val="1F2328"/>
-                </a:solidFill>
-                <a:latin typeface="Calibri"/>
-                <a:cs typeface="Calibri"/>
-              </a:rPr>
-              <a:t xml:space="preserve">eICU-CRD</a:t>
-            </a:r>
-          </a:p>
-        </p:txBody>
-      </p:sp>
-      <p:sp>
-        <p:nvSpPr>
-          <p:cNvPr id="1294" name="Method"/>
-          <p:cNvSpPr txBox="1"/>
-          <p:nvPr/>
-        </p:nvSpPr>
-        <p:spPr>
-          <a:xfrm>
-            <a:off x="6931152" y="4416552"/>
-            <a:ext cx="1325880" cy="310896"/>
-          </a:xfrm>
-          <a:prstGeom prst="rect">
-            <a:avLst/>
-          </a:prstGeom>
-          <a:noFill/>
-          <a:ln>
-            <a:noFill/>
-          </a:ln>
-        </p:spPr>
-        <p:txBody>
-          <a:bodyPr wrap="square" lIns="0" tIns="0" rIns="0" bIns="0" anchor="ctr">
-            <a:noAutofit/>
-          </a:bodyPr>
-          <a:lstStyle/>
-          <a:p>
-            <a:pPr algn="l"/>
-            <a:r>
-              <a:rPr lang="en-US" sz="1200" b="0" i="0" dirty="0">
-                <a:solidFill>
-                  <a:srgbClr val="1F2328"/>
-                </a:solidFill>
-                <a:latin typeface="Calibri"/>
-                <a:cs typeface="Calibri"/>
-              </a:rPr>
-              <a:t xml:space="preserve">Direct Mapping</a:t>
-            </a:r>
-          </a:p>
-        </p:txBody>
-      </p:sp>
-      <p:sp>
-        <p:nvSpPr>
-          <p:cNvPr id="1295" name="Cell"/>
-          <p:cNvSpPr/>
-          <p:nvPr/>
-        </p:nvSpPr>
-        <p:spPr>
-          <a:xfrm>
-            <a:off x="8275319" y="4434840"/>
-            <a:ext cx="1380744" cy="274320"/>
-          </a:xfrm>
-          <a:prstGeom prst="rect">
-            <a:avLst/>
-          </a:prstGeom>
-          <a:solidFill>
-            <a:srgbClr val="F1F3F2"/>
-          </a:solidFill>
-          <a:ln>
-            <a:noFill/>
-          </a:ln>
-        </p:spPr>
-        <p:txBody>
-          <a:bodyPr wrap="square" lIns="0" tIns="0" rIns="0" bIns="0" anchor="ctr">
-            <a:noAutofit/>
-          </a:bodyPr>
-          <a:lstStyle/>
-          <a:p>
-            <a:pPr algn="ctr"/>
-            <a:r>
-              <a:rPr lang="en-US" sz="1100" b="0" i="0" dirty="0">
-                <a:solidFill>
-                  <a:srgbClr val="1F2328"/>
-                </a:solidFill>
-                <a:latin typeface="Calibri"/>
-                <a:cs typeface="Calibri"/>
-              </a:rPr>
-              <a:t xml:space="preserve">3</a:t>
+              <a:t xml:space="preserve">LLM baseline</a:t>
             </a:r>
           </a:p>
         </p:txBody>
@@ -11974,14 +11991,14 @@
         </p:nvSpPr>
         <p:spPr>
           <a:xfrm>
-            <a:off x="9692640" y="4434840"/>
-            <a:ext cx="1380744" cy="274320"/>
-          </a:xfrm>
-          <a:prstGeom prst="rect">
-            <a:avLst/>
-          </a:prstGeom>
-          <a:solidFill>
-            <a:srgbClr val="F6DAD3"/>
+            <a:off x="8458200" y="4818888"/>
+            <a:ext cx="1316736" cy="256032"/>
+          </a:xfrm>
+          <a:prstGeom prst="rect">
+            <a:avLst/>
+          </a:prstGeom>
+          <a:solidFill>
+            <a:srgbClr val="F1F3F2"/>
           </a:solidFill>
           <a:ln>
             <a:noFill/>
@@ -12002,21 +12019,62 @@
                 <a:latin typeface="Calibri"/>
                 <a:cs typeface="Calibri"/>
               </a:rPr>
-              <a:t xml:space="preserve">2</a:t>
-            </a:r>
-          </a:p>
-        </p:txBody>
-      </p:sp>
-      <p:sp>
-        <p:nvSpPr>
-          <p:cNvPr id="1297" name="Method"/>
+              <a:t xml:space="preserve">2.74</a:t>
+            </a:r>
+          </a:p>
+        </p:txBody>
+      </p:sp>
+      <p:sp>
+        <p:nvSpPr>
+          <p:cNvPr id="1297" name="Cell"/>
+          <p:cNvSpPr/>
+          <p:nvPr/>
+        </p:nvSpPr>
+        <p:spPr>
+          <a:xfrm>
+            <a:off x="9811512" y="4818888"/>
+            <a:ext cx="1316736" cy="256032"/>
+          </a:xfrm>
+          <a:prstGeom prst="rect">
+            <a:avLst/>
+          </a:prstGeom>
+          <a:solidFill>
+            <a:srgbClr val="DDF0E5"/>
+          </a:solidFill>
+          <a:ln>
+            <a:noFill/>
+          </a:ln>
+        </p:spPr>
+        <p:txBody>
+          <a:bodyPr wrap="square" lIns="0" tIns="0" rIns="0" bIns="0" anchor="ctr">
+            <a:noAutofit/>
+          </a:bodyPr>
+          <a:lstStyle/>
+          <a:p>
+            <a:pPr algn="ctr"/>
+            <a:r>
+              <a:rPr lang="en-US" sz="1100" b="0" i="0" dirty="0">
+                <a:solidFill>
+                  <a:srgbClr val="1F2328"/>
+                </a:solidFill>
+                <a:latin typeface="Calibri"/>
+                <a:cs typeface="Calibri"/>
+              </a:rPr>
+              <a:t xml:space="preserve">3.01</a:t>
+            </a:r>
+          </a:p>
+        </p:txBody>
+      </p:sp>
+      <p:sp>
+        <p:nvSpPr>
+          <p:cNvPr id="1298" name="Method"/>
           <p:cNvSpPr txBox="1"/>
           <p:nvPr/>
         </p:nvSpPr>
         <p:spPr>
           <a:xfrm>
-            <a:off x="6931152" y="4727448"/>
-            <a:ext cx="1325880" cy="310896"/>
+            <a:off x="6931152" y="5093208"/>
+            <a:ext cx="1508760" cy="292608"/>
           </a:xfrm>
           <a:prstGeom prst="rect">
             <a:avLst/>
@@ -12041,48 +12099,7 @@
                 <a:latin typeface="Calibri"/>
                 <a:cs typeface="Calibri"/>
               </a:rPr>
-              <a:t xml:space="preserve">LLM baseline</a:t>
-            </a:r>
-          </a:p>
-        </p:txBody>
-      </p:sp>
-      <p:sp>
-        <p:nvSpPr>
-          <p:cNvPr id="1298" name="Cell"/>
-          <p:cNvSpPr/>
-          <p:nvPr/>
-        </p:nvSpPr>
-        <p:spPr>
-          <a:xfrm>
-            <a:off x="8275319" y="4745736"/>
-            <a:ext cx="1380744" cy="274320"/>
-          </a:xfrm>
-          <a:prstGeom prst="rect">
-            <a:avLst/>
-          </a:prstGeom>
-          <a:solidFill>
-            <a:srgbClr val="F6DAD3"/>
-          </a:solidFill>
-          <a:ln>
-            <a:noFill/>
-          </a:ln>
-        </p:spPr>
-        <p:txBody>
-          <a:bodyPr wrap="square" lIns="0" tIns="0" rIns="0" bIns="0" anchor="ctr">
-            <a:noAutofit/>
-          </a:bodyPr>
-          <a:lstStyle/>
-          <a:p>
-            <a:pPr algn="ctr"/>
-            <a:r>
-              <a:rPr lang="en-US" sz="1100" b="0" i="0" dirty="0">
-                <a:solidFill>
-                  <a:srgbClr val="1F2328"/>
-                </a:solidFill>
-                <a:latin typeface="Calibri"/>
-                <a:cs typeface="Calibri"/>
-              </a:rPr>
-              <a:t xml:space="preserve">1</a:t>
+              <a:t xml:space="preserve">Non-Iterative RAG</a:t>
             </a:r>
           </a:p>
         </p:txBody>
@@ -12095,8 +12112,8 @@
         </p:nvSpPr>
         <p:spPr>
           <a:xfrm>
-            <a:off x="9692640" y="4745736"/>
-            <a:ext cx="1380744" cy="274320"/>
+            <a:off x="8458200" y="5111496"/>
+            <a:ext cx="1316736" cy="256032"/>
           </a:xfrm>
           <a:prstGeom prst="rect">
             <a:avLst/>
@@ -12123,21 +12140,62 @@
                 <a:latin typeface="Calibri"/>
                 <a:cs typeface="Calibri"/>
               </a:rPr>
-              <a:t xml:space="preserve">4</a:t>
-            </a:r>
-          </a:p>
-        </p:txBody>
-      </p:sp>
-      <p:sp>
-        <p:nvSpPr>
-          <p:cNvPr id="1300" name="Method"/>
+              <a:t xml:space="preserve">2.39</a:t>
+            </a:r>
+          </a:p>
+        </p:txBody>
+      </p:sp>
+      <p:sp>
+        <p:nvSpPr>
+          <p:cNvPr id="1300" name="Cell"/>
+          <p:cNvSpPr/>
+          <p:nvPr/>
+        </p:nvSpPr>
+        <p:spPr>
+          <a:xfrm>
+            <a:off x="9811512" y="5111496"/>
+            <a:ext cx="1316736" cy="256032"/>
+          </a:xfrm>
+          <a:prstGeom prst="rect">
+            <a:avLst/>
+          </a:prstGeom>
+          <a:solidFill>
+            <a:srgbClr val="F6DAD3"/>
+          </a:solidFill>
+          <a:ln>
+            <a:noFill/>
+          </a:ln>
+        </p:spPr>
+        <p:txBody>
+          <a:bodyPr wrap="square" lIns="0" tIns="0" rIns="0" bIns="0" anchor="ctr">
+            <a:noAutofit/>
+          </a:bodyPr>
+          <a:lstStyle/>
+          <a:p>
+            <a:pPr algn="ctr"/>
+            <a:r>
+              <a:rPr lang="en-US" sz="1100" b="0" i="0" dirty="0">
+                <a:solidFill>
+                  <a:srgbClr val="1F2328"/>
+                </a:solidFill>
+                <a:latin typeface="Calibri"/>
+                <a:cs typeface="Calibri"/>
+              </a:rPr>
+              <a:t xml:space="preserve">1.24</a:t>
+            </a:r>
+          </a:p>
+        </p:txBody>
+      </p:sp>
+      <p:sp>
+        <p:nvSpPr>
+          <p:cNvPr id="1301" name="Method"/>
           <p:cNvSpPr txBox="1"/>
           <p:nvPr/>
         </p:nvSpPr>
         <p:spPr>
           <a:xfrm>
-            <a:off x="6931152" y="5038344"/>
-            <a:ext cx="1325880" cy="310896"/>
+            <a:off x="6931152" y="5385816"/>
+            <a:ext cx="1508760" cy="292608"/>
           </a:xfrm>
           <a:prstGeom prst="rect">
             <a:avLst/>
@@ -12155,55 +12213,14 @@
           <a:p>
             <a:pPr algn="l"/>
             <a:r>
-              <a:rPr lang="en-US" sz="1200" b="0" i="0" dirty="0">
-                <a:solidFill>
-                  <a:srgbClr val="1F2328"/>
-                </a:solidFill>
-                <a:latin typeface="Calibri"/>
-                <a:cs typeface="Calibri"/>
-              </a:rPr>
-              <a:t xml:space="preserve">Non-Iterative</a:t>
-            </a:r>
-          </a:p>
-        </p:txBody>
-      </p:sp>
-      <p:sp>
-        <p:nvSpPr>
-          <p:cNvPr id="1301" name="Cell"/>
-          <p:cNvSpPr/>
-          <p:nvPr/>
-        </p:nvSpPr>
-        <p:spPr>
-          <a:xfrm>
-            <a:off x="8275319" y="5056632"/>
-            <a:ext cx="1380744" cy="274320"/>
-          </a:xfrm>
-          <a:prstGeom prst="rect">
-            <a:avLst/>
-          </a:prstGeom>
-          <a:solidFill>
-            <a:srgbClr val="F6DAD3"/>
-          </a:solidFill>
-          <a:ln>
-            <a:noFill/>
-          </a:ln>
-        </p:spPr>
-        <p:txBody>
-          <a:bodyPr wrap="square" lIns="0" tIns="0" rIns="0" bIns="0" anchor="ctr">
-            <a:noAutofit/>
-          </a:bodyPr>
-          <a:lstStyle/>
-          <a:p>
-            <a:pPr algn="ctr"/>
-            <a:r>
-              <a:rPr lang="en-US" sz="1100" b="0" i="0" dirty="0">
-                <a:solidFill>
-                  <a:srgbClr val="1F2328"/>
-                </a:solidFill>
-                <a:latin typeface="Calibri"/>
-                <a:cs typeface="Calibri"/>
-              </a:rPr>
-              <a:t xml:space="preserve">2</a:t>
+              <a:rPr lang="en-US" sz="1200" b="1" i="0" dirty="0">
+                <a:solidFill>
+                  <a:srgbClr val="0B6E4F"/>
+                </a:solidFill>
+                <a:latin typeface="Calibri"/>
+                <a:cs typeface="Calibri"/>
+              </a:rPr>
+              <a:t xml:space="preserve">RIGOR</a:t>
             </a:r>
           </a:p>
         </p:txBody>
@@ -12216,88 +12233,49 @@
         </p:nvSpPr>
         <p:spPr>
           <a:xfrm>
-            <a:off x="9692640" y="5056632"/>
-            <a:ext cx="1380744" cy="274320"/>
-          </a:xfrm>
-          <a:prstGeom prst="rect">
-            <a:avLst/>
-          </a:prstGeom>
-          <a:solidFill>
-            <a:srgbClr val="EDB8AC"/>
-          </a:solidFill>
-          <a:ln>
-            <a:noFill/>
-          </a:ln>
-        </p:spPr>
-        <p:txBody>
-          <a:bodyPr wrap="square" lIns="0" tIns="0" rIns="0" bIns="0" anchor="ctr">
-            <a:noAutofit/>
-          </a:bodyPr>
-          <a:lstStyle/>
-          <a:p>
-            <a:pPr algn="ctr"/>
-            <a:r>
-              <a:rPr lang="en-US" sz="1100" b="0" i="0" dirty="0">
+            <a:off x="8458200" y="5404104"/>
+            <a:ext cx="1316736" cy="256032"/>
+          </a:xfrm>
+          <a:prstGeom prst="rect">
+            <a:avLst/>
+          </a:prstGeom>
+          <a:solidFill>
+            <a:srgbClr val="DDF0E5"/>
+          </a:solidFill>
+          <a:ln>
+            <a:noFill/>
+          </a:ln>
+        </p:spPr>
+        <p:txBody>
+          <a:bodyPr wrap="square" lIns="0" tIns="0" rIns="0" bIns="0" anchor="ctr">
+            <a:noAutofit/>
+          </a:bodyPr>
+          <a:lstStyle/>
+          <a:p>
+            <a:pPr algn="ctr"/>
+            <a:r>
+              <a:rPr lang="en-US" sz="1100" b="1" i="0" dirty="0">
                 <a:solidFill>
                   <a:srgbClr val="1F2328"/>
                 </a:solidFill>
                 <a:latin typeface="Calibri"/>
                 <a:cs typeface="Calibri"/>
               </a:rPr>
-              <a:t xml:space="preserve">0</a:t>
-            </a:r>
-          </a:p>
-        </p:txBody>
-      </p:sp>
-      <p:sp>
-        <p:nvSpPr>
-          <p:cNvPr id="1303" name="Method"/>
-          <p:cNvSpPr txBox="1"/>
-          <p:nvPr/>
-        </p:nvSpPr>
-        <p:spPr>
-          <a:xfrm>
-            <a:off x="6931152" y="5349240"/>
-            <a:ext cx="1325880" cy="310896"/>
-          </a:xfrm>
-          <a:prstGeom prst="rect">
-            <a:avLst/>
-          </a:prstGeom>
-          <a:noFill/>
-          <a:ln>
-            <a:noFill/>
-          </a:ln>
-        </p:spPr>
-        <p:txBody>
-          <a:bodyPr wrap="square" lIns="0" tIns="0" rIns="0" bIns="0" anchor="ctr">
-            <a:noAutofit/>
-          </a:bodyPr>
-          <a:lstStyle/>
-          <a:p>
-            <a:pPr algn="l"/>
-            <a:r>
-              <a:rPr lang="en-US" sz="1200" b="1" i="0" dirty="0">
-                <a:solidFill>
-                  <a:srgbClr val="0B6E4F"/>
-                </a:solidFill>
-                <a:latin typeface="Calibri"/>
-                <a:cs typeface="Calibri"/>
-              </a:rPr>
-              <a:t xml:space="preserve">RIGOR</a:t>
-            </a:r>
-          </a:p>
-        </p:txBody>
-      </p:sp>
-      <p:sp>
-        <p:nvSpPr>
-          <p:cNvPr id="1304" name="Cell"/>
+              <a:t xml:space="preserve">3.44</a:t>
+            </a:r>
+          </a:p>
+        </p:txBody>
+      </p:sp>
+      <p:sp>
+        <p:nvSpPr>
+          <p:cNvPr id="1303" name="Cell"/>
           <p:cNvSpPr/>
           <p:nvPr/>
         </p:nvSpPr>
         <p:spPr>
           <a:xfrm>
-            <a:off x="8275319" y="5367528"/>
-            <a:ext cx="1380744" cy="274320"/>
+            <a:off x="9811512" y="5404104"/>
+            <a:ext cx="1316736" cy="256032"/>
           </a:xfrm>
           <a:prstGeom prst="rect">
             <a:avLst/>
@@ -12324,55 +12302,14 @@
                 <a:latin typeface="Calibri"/>
                 <a:cs typeface="Calibri"/>
               </a:rPr>
-              <a:t xml:space="preserve">14</a:t>
-            </a:r>
-          </a:p>
-        </p:txBody>
-      </p:sp>
-      <p:sp>
-        <p:nvSpPr>
-          <p:cNvPr id="1305" name="Cell"/>
-          <p:cNvSpPr/>
-          <p:nvPr/>
-        </p:nvSpPr>
-        <p:spPr>
-          <a:xfrm>
-            <a:off x="9692640" y="5367528"/>
-            <a:ext cx="1380744" cy="274320"/>
-          </a:xfrm>
-          <a:prstGeom prst="rect">
-            <a:avLst/>
-          </a:prstGeom>
-          <a:solidFill>
-            <a:srgbClr val="BFE3CF"/>
-          </a:solidFill>
-          <a:ln>
-            <a:noFill/>
-          </a:ln>
-        </p:spPr>
-        <p:txBody>
-          <a:bodyPr wrap="square" lIns="0" tIns="0" rIns="0" bIns="0" anchor="ctr">
-            <a:noAutofit/>
-          </a:bodyPr>
-          <a:lstStyle/>
-          <a:p>
-            <a:pPr algn="ctr"/>
-            <a:r>
-              <a:rPr lang="en-US" sz="1100" b="1" i="0" dirty="0">
-                <a:solidFill>
-                  <a:srgbClr val="1F2328"/>
-                </a:solidFill>
-                <a:latin typeface="Calibri"/>
-                <a:cs typeface="Calibri"/>
-              </a:rPr>
-              <a:t xml:space="preserve">14</a:t>
-            </a:r>
-          </a:p>
-        </p:txBody>
-      </p:sp>
-      <p:sp>
-        <p:nvSpPr>
-          <p:cNvPr id="1306" name="Strip"/>
+              <a:t xml:space="preserve">3.53</a:t>
+            </a:r>
+          </a:p>
+        </p:txBody>
+      </p:sp>
+      <p:sp>
+        <p:nvSpPr>
+          <p:cNvPr id="1304" name="Strip"/>
           <p:cNvSpPr/>
           <p:nvPr/>
         </p:nvSpPr>
@@ -12425,7 +12362,7 @@
       </p:sp>
       <p:sp>
         <p:nvSpPr>
-          <p:cNvPr id="1307" name="Source"/>
+          <p:cNvPr id="1305" name="Source"/>
           <p:cNvSpPr txBox="1"/>
           <p:nvPr/>
         </p:nvSpPr>
@@ -12457,7 +12394,7 @@
                 <a:latin typeface="Calibri"/>
                 <a:cs typeface="Calibri"/>
               </a:rPr>
-              <a:t xml:space="preserve">Judge: average score 0–5 per database, Claude ontologies, 58 tables. Experts: first places of 20 per database, 4 medical tables, Kendall's W 0.39–0.72. Paper Tables 1, 6, 12.</a:t>
+              <a:t xml:space="preserve">Average scores (0–5) per database. Judge: all 58 tables, ontologies generated with Claude. Experts: 4 medical tables, significant agreement (Kendall's W). Paper Sec. 4.6, Tables 1, 10–12.</a:t>
             </a:r>
           </a:p>
         </p:txBody>

</xml_diff>